<commit_message>
Polish slide deck: embed charts, add icon/accent graphics
- src/make_report_assets.py: charts restyled to the deck's own palette
  (navy/accent-blue/green), bold data labels, cleaner spines
- src/make_slides_pptx.py:
  - Phase 1/2/3 slides now show the actual chart image next to a compact
    table, instead of a table-only layout
  - accent-bar top strip on every card for visual rhythm
  - cover slide gets a circular 68.8% headline badge + thin accent bar
  - conclusions slide switched from plain bullets to checkmark badges
  - fixed card return value + shape-index bug the badge/accent additions
    exposed on the insights slide
</commit_message>
<xml_diff>
--- a/report/slides.pptx
+++ b/report/slides.pptx
@@ -3181,13 +3181,57 @@
       </p:sp>
       <p:sp>
         <p:nvSpPr>
-          <p:cNvPr id="4" name="TextBox 3"/>
+          <p:cNvPr id="4" name="Rectangle 3"/>
+          <p:cNvSpPr/>
+          <p:nvPr/>
+        </p:nvSpPr>
+        <p:spPr>
+          <a:xfrm>
+            <a:off x="850392" y="1371600"/>
+            <a:ext cx="1463040" cy="64008"/>
+          </a:xfrm>
+          <a:prstGeom prst="rect">
+            <a:avLst/>
+          </a:prstGeom>
+          <a:solidFill>
+            <a:srgbClr val="2A5CAA"/>
+          </a:solidFill>
+          <a:ln>
+            <a:noFill/>
+          </a:ln>
+          <a:effectLst/>
+        </p:spPr>
+        <p:style>
+          <a:lnRef idx="1">
+            <a:schemeClr val="accent1"/>
+          </a:lnRef>
+          <a:fillRef idx="3">
+            <a:schemeClr val="accent1"/>
+          </a:fillRef>
+          <a:effectRef idx="2">
+            <a:schemeClr val="accent1"/>
+          </a:effectRef>
+          <a:fontRef idx="minor">
+            <a:schemeClr val="lt1"/>
+          </a:fontRef>
+        </p:style>
+        <p:txBody>
+          <a:bodyPr rtlCol="0" anchor="ctr"/>
+          <a:lstStyle/>
+          <a:p>
+            <a:pPr algn="ctr"/>
+          </a:p>
+        </p:txBody>
+      </p:sp>
+      <p:sp>
+        <p:nvSpPr>
+          <p:cNvPr id="5" name="TextBox 4"/>
           <p:cNvSpPr txBox="1"/>
           <p:nvPr/>
         </p:nvSpPr>
         <p:spPr>
           <a:xfrm>
-            <a:off x="822960" y="1463040"/>
+            <a:off x="822960" y="1508760"/>
             <a:ext cx="10058400" cy="1645920"/>
           </a:xfrm>
           <a:prstGeom prst="rect">
@@ -3220,13 +3264,13 @@
       </p:sp>
       <p:sp>
         <p:nvSpPr>
-          <p:cNvPr id="5" name="TextBox 4"/>
+          <p:cNvPr id="6" name="TextBox 5"/>
           <p:cNvSpPr txBox="1"/>
           <p:nvPr/>
         </p:nvSpPr>
         <p:spPr>
           <a:xfrm>
-            <a:off x="822960" y="2743200"/>
+            <a:off x="822960" y="2788920"/>
             <a:ext cx="9601200" cy="1097280"/>
           </a:xfrm>
           <a:prstGeom prst="rect">
@@ -3259,7 +3303,99 @@
       </p:sp>
       <p:sp>
         <p:nvSpPr>
-          <p:cNvPr id="6" name="TextBox 5"/>
+          <p:cNvPr id="7" name="Oval 6"/>
+          <p:cNvSpPr/>
+          <p:nvPr/>
+        </p:nvSpPr>
+        <p:spPr>
+          <a:xfrm>
+            <a:off x="10012680" y="502920"/>
+            <a:ext cx="1371600" cy="1371600"/>
+          </a:xfrm>
+          <a:prstGeom prst="ellipse">
+            <a:avLst/>
+          </a:prstGeom>
+          <a:solidFill>
+            <a:srgbClr val="1C3055"/>
+          </a:solidFill>
+          <a:ln>
+            <a:noFill/>
+          </a:ln>
+          <a:effectLst/>
+        </p:spPr>
+        <p:style>
+          <a:lnRef idx="1">
+            <a:schemeClr val="accent1"/>
+          </a:lnRef>
+          <a:fillRef idx="3">
+            <a:schemeClr val="accent1"/>
+          </a:fillRef>
+          <a:effectRef idx="2">
+            <a:schemeClr val="accent1"/>
+          </a:effectRef>
+          <a:fontRef idx="minor">
+            <a:schemeClr val="lt1"/>
+          </a:fontRef>
+        </p:style>
+        <p:txBody>
+          <a:bodyPr rtlCol="0" anchor="ctr" wrap="none"/>
+          <a:lstStyle/>
+          <a:p>
+            <a:pPr algn="ctr"/>
+            <a:r>
+              <a:rPr sz="1500" b="1">
+                <a:solidFill>
+                  <a:srgbClr val="8FB4FF"/>
+                </a:solidFill>
+                <a:latin typeface="Arial"/>
+              </a:rPr>
+              <a:t>68.8%</a:t>
+            </a:r>
+          </a:p>
+        </p:txBody>
+      </p:sp>
+      <p:sp>
+        <p:nvSpPr>
+          <p:cNvPr id="8" name="TextBox 7"/>
+          <p:cNvSpPr txBox="1"/>
+          <p:nvPr/>
+        </p:nvSpPr>
+        <p:spPr>
+          <a:xfrm>
+            <a:off x="10012680" y="1965960"/>
+            <a:ext cx="1371600" cy="274320"/>
+          </a:xfrm>
+          <a:prstGeom prst="rect">
+            <a:avLst/>
+          </a:prstGeom>
+          <a:noFill/>
+        </p:spPr>
+        <p:txBody>
+          <a:bodyPr wrap="square">
+            <a:spAutoFit/>
+          </a:bodyPr>
+          <a:lstStyle/>
+          <a:p>
+            <a:pPr algn="ctr">
+              <a:lnSpc>
+                <a:spcPct val="110000"/>
+              </a:lnSpc>
+            </a:pPr>
+            <a:r>
+              <a:rPr sz="1000" b="0" i="0">
+                <a:solidFill>
+                  <a:srgbClr val="6E85AD"/>
+                </a:solidFill>
+                <a:latin typeface="Arial"/>
+              </a:rPr>
+              <a:t>best test acc</a:t>
+            </a:r>
+          </a:p>
+        </p:txBody>
+      </p:sp>
+      <p:sp>
+        <p:nvSpPr>
+          <p:cNvPr id="9" name="TextBox 8"/>
           <p:cNvSpPr txBox="1"/>
           <p:nvPr/>
         </p:nvSpPr>
@@ -3557,6 +3693,50 @@
         </p:nvSpPr>
         <p:spPr>
           <a:xfrm>
+            <a:off x="822960" y="3063240"/>
+            <a:ext cx="4937760" cy="54864"/>
+          </a:xfrm>
+          <a:prstGeom prst="rect">
+            <a:avLst/>
+          </a:prstGeom>
+          <a:solidFill>
+            <a:srgbClr val="2A5CAA"/>
+          </a:solidFill>
+          <a:ln>
+            <a:noFill/>
+          </a:ln>
+          <a:effectLst/>
+        </p:spPr>
+        <p:style>
+          <a:lnRef idx="1">
+            <a:schemeClr val="accent1"/>
+          </a:lnRef>
+          <a:fillRef idx="3">
+            <a:schemeClr val="accent1"/>
+          </a:fillRef>
+          <a:effectRef idx="2">
+            <a:schemeClr val="accent1"/>
+          </a:effectRef>
+          <a:fontRef idx="minor">
+            <a:schemeClr val="lt1"/>
+          </a:fontRef>
+        </p:style>
+        <p:txBody>
+          <a:bodyPr rtlCol="0" anchor="ctr"/>
+          <a:lstStyle/>
+          <a:p>
+            <a:pPr algn="ctr"/>
+          </a:p>
+        </p:txBody>
+      </p:sp>
+      <p:sp>
+        <p:nvSpPr>
+          <p:cNvPr id="8" name="Rectangle 7"/>
+          <p:cNvSpPr/>
+          <p:nvPr/>
+        </p:nvSpPr>
+        <p:spPr>
+          <a:xfrm>
             <a:off x="5943600" y="3063240"/>
             <a:ext cx="4937760" cy="1828800"/>
           </a:xfrm>
@@ -3625,7 +3805,51 @@
       </p:sp>
       <p:sp>
         <p:nvSpPr>
-          <p:cNvPr id="8" name="TextBox 7"/>
+          <p:cNvPr id="9" name="Rectangle 8"/>
+          <p:cNvSpPr/>
+          <p:nvPr/>
+        </p:nvSpPr>
+        <p:spPr>
+          <a:xfrm>
+            <a:off x="5943600" y="3063240"/>
+            <a:ext cx="4937760" cy="54864"/>
+          </a:xfrm>
+          <a:prstGeom prst="rect">
+            <a:avLst/>
+          </a:prstGeom>
+          <a:solidFill>
+            <a:srgbClr val="2A5CAA"/>
+          </a:solidFill>
+          <a:ln>
+            <a:noFill/>
+          </a:ln>
+          <a:effectLst/>
+        </p:spPr>
+        <p:style>
+          <a:lnRef idx="1">
+            <a:schemeClr val="accent1"/>
+          </a:lnRef>
+          <a:fillRef idx="3">
+            <a:schemeClr val="accent1"/>
+          </a:fillRef>
+          <a:effectRef idx="2">
+            <a:schemeClr val="accent1"/>
+          </a:effectRef>
+          <a:fontRef idx="minor">
+            <a:schemeClr val="lt1"/>
+          </a:fontRef>
+        </p:style>
+        <p:txBody>
+          <a:bodyPr rtlCol="0" anchor="ctr"/>
+          <a:lstStyle/>
+          <a:p>
+            <a:pPr algn="ctr"/>
+          </a:p>
+        </p:txBody>
+      </p:sp>
+      <p:sp>
+        <p:nvSpPr>
+          <p:cNvPr id="10" name="TextBox 9"/>
           <p:cNvSpPr txBox="1"/>
           <p:nvPr/>
         </p:nvSpPr>
@@ -3923,6 +4147,50 @@
         </p:nvSpPr>
         <p:spPr>
           <a:xfrm>
+            <a:off x="822960" y="2423160"/>
+            <a:ext cx="3291840" cy="54864"/>
+          </a:xfrm>
+          <a:prstGeom prst="rect">
+            <a:avLst/>
+          </a:prstGeom>
+          <a:solidFill>
+            <a:srgbClr val="2A5CAA"/>
+          </a:solidFill>
+          <a:ln>
+            <a:noFill/>
+          </a:ln>
+          <a:effectLst/>
+        </p:spPr>
+        <p:style>
+          <a:lnRef idx="1">
+            <a:schemeClr val="accent1"/>
+          </a:lnRef>
+          <a:fillRef idx="3">
+            <a:schemeClr val="accent1"/>
+          </a:fillRef>
+          <a:effectRef idx="2">
+            <a:schemeClr val="accent1"/>
+          </a:effectRef>
+          <a:fontRef idx="minor">
+            <a:schemeClr val="lt1"/>
+          </a:fontRef>
+        </p:style>
+        <p:txBody>
+          <a:bodyPr rtlCol="0" anchor="ctr"/>
+          <a:lstStyle/>
+          <a:p>
+            <a:pPr algn="ctr"/>
+          </a:p>
+        </p:txBody>
+      </p:sp>
+      <p:sp>
+        <p:nvSpPr>
+          <p:cNvPr id="8" name="Rectangle 7"/>
+          <p:cNvSpPr/>
+          <p:nvPr/>
+        </p:nvSpPr>
+        <p:spPr>
+          <a:xfrm>
             <a:off x="4343400" y="2423160"/>
             <a:ext cx="3291840" cy="1463040"/>
           </a:xfrm>
@@ -3991,7 +4259,51 @@
       </p:sp>
       <p:sp>
         <p:nvSpPr>
-          <p:cNvPr id="8" name="Rectangle 7"/>
+          <p:cNvPr id="9" name="Rectangle 8"/>
+          <p:cNvSpPr/>
+          <p:nvPr/>
+        </p:nvSpPr>
+        <p:spPr>
+          <a:xfrm>
+            <a:off x="4343400" y="2423160"/>
+            <a:ext cx="3291840" cy="54864"/>
+          </a:xfrm>
+          <a:prstGeom prst="rect">
+            <a:avLst/>
+          </a:prstGeom>
+          <a:solidFill>
+            <a:srgbClr val="2A5CAA"/>
+          </a:solidFill>
+          <a:ln>
+            <a:noFill/>
+          </a:ln>
+          <a:effectLst/>
+        </p:spPr>
+        <p:style>
+          <a:lnRef idx="1">
+            <a:schemeClr val="accent1"/>
+          </a:lnRef>
+          <a:fillRef idx="3">
+            <a:schemeClr val="accent1"/>
+          </a:fillRef>
+          <a:effectRef idx="2">
+            <a:schemeClr val="accent1"/>
+          </a:effectRef>
+          <a:fontRef idx="minor">
+            <a:schemeClr val="lt1"/>
+          </a:fontRef>
+        </p:style>
+        <p:txBody>
+          <a:bodyPr rtlCol="0" anchor="ctr"/>
+          <a:lstStyle/>
+          <a:p>
+            <a:pPr algn="ctr"/>
+          </a:p>
+        </p:txBody>
+      </p:sp>
+      <p:sp>
+        <p:nvSpPr>
+          <p:cNvPr id="10" name="Rectangle 9"/>
           <p:cNvSpPr/>
           <p:nvPr/>
         </p:nvSpPr>
@@ -4065,7 +4377,51 @@
       </p:sp>
       <p:sp>
         <p:nvSpPr>
-          <p:cNvPr id="9" name="TextBox 8"/>
+          <p:cNvPr id="11" name="Rectangle 10"/>
+          <p:cNvSpPr/>
+          <p:nvPr/>
+        </p:nvSpPr>
+        <p:spPr>
+          <a:xfrm>
+            <a:off x="7863840" y="2423160"/>
+            <a:ext cx="3474720" cy="54864"/>
+          </a:xfrm>
+          <a:prstGeom prst="rect">
+            <a:avLst/>
+          </a:prstGeom>
+          <a:solidFill>
+            <a:srgbClr val="2A5CAA"/>
+          </a:solidFill>
+          <a:ln>
+            <a:noFill/>
+          </a:ln>
+          <a:effectLst/>
+        </p:spPr>
+        <p:style>
+          <a:lnRef idx="1">
+            <a:schemeClr val="accent1"/>
+          </a:lnRef>
+          <a:fillRef idx="3">
+            <a:schemeClr val="accent1"/>
+          </a:fillRef>
+          <a:effectRef idx="2">
+            <a:schemeClr val="accent1"/>
+          </a:effectRef>
+          <a:fontRef idx="minor">
+            <a:schemeClr val="lt1"/>
+          </a:fontRef>
+        </p:style>
+        <p:txBody>
+          <a:bodyPr rtlCol="0" anchor="ctr"/>
+          <a:lstStyle/>
+          <a:p>
+            <a:pPr algn="ctr"/>
+          </a:p>
+        </p:txBody>
+      </p:sp>
+      <p:sp>
+        <p:nvSpPr>
+          <p:cNvPr id="12" name="TextBox 11"/>
           <p:cNvSpPr txBox="1"/>
           <p:nvPr/>
         </p:nvSpPr>
@@ -4104,7 +4460,7 @@
       </p:sp>
       <p:sp>
         <p:nvSpPr>
-          <p:cNvPr id="10" name="TextBox 9"/>
+          <p:cNvPr id="13" name="TextBox 12"/>
           <p:cNvSpPr txBox="1"/>
           <p:nvPr/>
         </p:nvSpPr>
@@ -4364,6 +4720,50 @@
         </p:nvSpPr>
         <p:spPr>
           <a:xfrm>
+            <a:off x="822960" y="1828800"/>
+            <a:ext cx="5029200" cy="54864"/>
+          </a:xfrm>
+          <a:prstGeom prst="rect">
+            <a:avLst/>
+          </a:prstGeom>
+          <a:solidFill>
+            <a:srgbClr val="2A5CAA"/>
+          </a:solidFill>
+          <a:ln>
+            <a:noFill/>
+          </a:ln>
+          <a:effectLst/>
+        </p:spPr>
+        <p:style>
+          <a:lnRef idx="1">
+            <a:schemeClr val="accent1"/>
+          </a:lnRef>
+          <a:fillRef idx="3">
+            <a:schemeClr val="accent1"/>
+          </a:fillRef>
+          <a:effectRef idx="2">
+            <a:schemeClr val="accent1"/>
+          </a:effectRef>
+          <a:fontRef idx="minor">
+            <a:schemeClr val="lt1"/>
+          </a:fontRef>
+        </p:style>
+        <p:txBody>
+          <a:bodyPr rtlCol="0" anchor="ctr"/>
+          <a:lstStyle/>
+          <a:p>
+            <a:pPr algn="ctr"/>
+          </a:p>
+        </p:txBody>
+      </p:sp>
+      <p:sp>
+        <p:nvSpPr>
+          <p:cNvPr id="7" name="Rectangle 6"/>
+          <p:cNvSpPr/>
+          <p:nvPr/>
+        </p:nvSpPr>
+        <p:spPr>
+          <a:xfrm>
             <a:off x="6035040" y="1828800"/>
             <a:ext cx="5120640" cy="3017520"/>
           </a:xfrm>
@@ -4433,7 +4833,51 @@
       </p:sp>
       <p:sp>
         <p:nvSpPr>
-          <p:cNvPr id="7" name="TextBox 6"/>
+          <p:cNvPr id="8" name="Rectangle 7"/>
+          <p:cNvSpPr/>
+          <p:nvPr/>
+        </p:nvSpPr>
+        <p:spPr>
+          <a:xfrm>
+            <a:off x="6035040" y="1828800"/>
+            <a:ext cx="5120640" cy="54864"/>
+          </a:xfrm>
+          <a:prstGeom prst="rect">
+            <a:avLst/>
+          </a:prstGeom>
+          <a:solidFill>
+            <a:srgbClr val="2A5CAA"/>
+          </a:solidFill>
+          <a:ln>
+            <a:noFill/>
+          </a:ln>
+          <a:effectLst/>
+        </p:spPr>
+        <p:style>
+          <a:lnRef idx="1">
+            <a:schemeClr val="accent1"/>
+          </a:lnRef>
+          <a:fillRef idx="3">
+            <a:schemeClr val="accent1"/>
+          </a:fillRef>
+          <a:effectRef idx="2">
+            <a:schemeClr val="accent1"/>
+          </a:effectRef>
+          <a:fontRef idx="minor">
+            <a:schemeClr val="lt1"/>
+          </a:fontRef>
+        </p:style>
+        <p:txBody>
+          <a:bodyPr rtlCol="0" anchor="ctr"/>
+          <a:lstStyle/>
+          <a:p>
+            <a:pPr algn="ctr"/>
+          </a:p>
+        </p:txBody>
+      </p:sp>
+      <p:sp>
+        <p:nvSpPr>
+          <p:cNvPr id="9" name="TextBox 8"/>
           <p:cNvSpPr txBox="1"/>
           <p:nvPr/>
         </p:nvSpPr>
@@ -4472,7 +4916,7 @@
       </p:sp>
       <p:sp>
         <p:nvSpPr>
-          <p:cNvPr id="8" name="TextBox 7"/>
+          <p:cNvPr id="10" name="TextBox 9"/>
           <p:cNvSpPr txBox="1"/>
           <p:nvPr/>
         </p:nvSpPr>
@@ -4619,7 +5063,7 @@
         <p:spPr>
           <a:xfrm>
             <a:off x="822960" y="868680"/>
-            <a:ext cx="10515600" cy="731520"/>
+            <a:ext cx="10515600" cy="548640"/>
           </a:xfrm>
           <a:prstGeom prst="rect">
             <a:avLst/>
@@ -4658,8 +5102,8 @@
           <p:nvPr/>
         </p:nvGraphicFramePr>
         <p:xfrm>
-          <a:off x="822960" y="1737360"/>
-          <a:ext cx="10424160" cy="2011680"/>
+          <a:off x="822960" y="1600200"/>
+          <a:ext cx="5029200" cy="2377440"/>
         </p:xfrm>
         <a:graphic>
           <a:graphicData uri="http://schemas.openxmlformats.org/drawingml/2006/table">
@@ -4668,12 +5112,12 @@
                 <a:tableStyleId>{5C22544A-7EE6-4342-B048-85BDC9FD1C3A}</a:tableStyleId>
               </a:tblPr>
               <a:tblGrid>
-                <a:gridCol w="2560320"/>
-                <a:gridCol w="3291840"/>
-                <a:gridCol w="2286000"/>
-                <a:gridCol w="2286000"/>
+                <a:gridCol w="1737360"/>
+                <a:gridCol w="1463040"/>
+                <a:gridCol w="960120"/>
+                <a:gridCol w="868680"/>
               </a:tblGrid>
-              <a:tr h="402336">
+              <a:tr h="475488">
                 <a:tc>
                   <a:txBody>
                     <a:bodyPr/>
@@ -4710,7 +5154,7 @@
                           </a:solidFill>
                           <a:latin typeface="Arial"/>
                         </a:rPr>
-                        <a:t>Label task</a:t>
+                        <a:t>Task</a:t>
                       </a:r>
                     </a:p>
                   </a:txBody>
@@ -4756,7 +5200,7 @@
                           </a:solidFill>
                           <a:latin typeface="Arial"/>
                         </a:rPr>
-                        <a:t>Test Macro-F1</a:t>
+                        <a:t>F1</a:t>
                       </a:r>
                     </a:p>
                   </a:txBody>
@@ -4767,7 +5211,7 @@
                   </a:tcPr>
                 </a:tc>
               </a:tr>
-              <a:tr h="402336">
+              <a:tr h="475488">
                 <a:tc>
                   <a:txBody>
                     <a:bodyPr/>
@@ -4804,7 +5248,7 @@
                           </a:solidFill>
                           <a:latin typeface="Arial"/>
                         </a:rPr>
-                        <a:t>issue_area (15-label)</a:t>
+                        <a:t>issue_area</a:t>
                       </a:r>
                     </a:p>
                   </a:txBody>
@@ -4861,7 +5305,7 @@
                   </a:tcPr>
                 </a:tc>
               </a:tr>
-              <a:tr h="402336">
+              <a:tr h="475488">
                 <a:tc>
                   <a:txBody>
                     <a:bodyPr/>
@@ -4898,7 +5342,7 @@
                           </a:solidFill>
                           <a:latin typeface="Arial"/>
                         </a:rPr>
-                        <a:t>issue (fine-grained)</a:t>
+                        <a:t>issue</a:t>
                       </a:r>
                     </a:p>
                   </a:txBody>
@@ -4955,7 +5399,7 @@
                   </a:tcPr>
                 </a:tc>
               </a:tr>
-              <a:tr h="402336">
+              <a:tr h="475488">
                 <a:tc>
                   <a:txBody>
                     <a:bodyPr/>
@@ -4992,7 +5436,7 @@
                           </a:solidFill>
                           <a:latin typeface="Arial"/>
                         </a:rPr>
-                        <a:t>issue_area (15-label)</a:t>
+                        <a:t>issue_area</a:t>
                       </a:r>
                     </a:p>
                   </a:txBody>
@@ -5049,7 +5493,7 @@
                   </a:tcPr>
                 </a:tc>
               </a:tr>
-              <a:tr h="402336">
+              <a:tr h="475488">
                 <a:tc>
                   <a:txBody>
                     <a:bodyPr/>
@@ -5086,7 +5530,7 @@
                           </a:solidFill>
                           <a:latin typeface="Arial"/>
                         </a:rPr>
-                        <a:t>issue (fine-grained)</a:t>
+                        <a:t>issue</a:t>
                       </a:r>
                     </a:p>
                   </a:txBody>
@@ -5155,8 +5599,8 @@
         </p:nvSpPr>
         <p:spPr>
           <a:xfrm>
-            <a:off x="822960" y="4023360"/>
-            <a:ext cx="10241280" cy="731520"/>
+            <a:off x="822960" y="4160520"/>
+            <a:ext cx="4846320" cy="1463040"/>
           </a:xfrm>
           <a:prstGeom prst="rect">
             <a:avLst/>
@@ -5186,9 +5630,33 @@
           </a:p>
         </p:txBody>
       </p:sp>
-      <p:sp>
-        <p:nvSpPr>
-          <p:cNvPr id="7" name="TextBox 6"/>
+      <p:pic>
+        <p:nvPicPr>
+          <p:cNvPr id="7" name="Picture 6" descr="phase1_test_accuracy.png"/>
+          <p:cNvPicPr>
+            <a:picLocks noChangeAspect="1"/>
+          </p:cNvPicPr>
+          <p:nvPr/>
+        </p:nvPicPr>
+        <p:blipFill>
+          <a:blip r:embed="rId2"/>
+          <a:stretch>
+            <a:fillRect/>
+          </a:stretch>
+        </p:blipFill>
+        <p:spPr>
+          <a:xfrm>
+            <a:off x="6126480" y="1600200"/>
+            <a:ext cx="5212080" cy="2895600"/>
+          </a:xfrm>
+          <a:prstGeom prst="rect">
+            <a:avLst/>
+          </a:prstGeom>
+        </p:spPr>
+      </p:pic>
+      <p:sp>
+        <p:nvSpPr>
+          <p:cNvPr id="8" name="TextBox 7"/>
           <p:cNvSpPr txBox="1"/>
           <p:nvPr/>
         </p:nvSpPr>
@@ -5335,7 +5803,7 @@
         <p:spPr>
           <a:xfrm>
             <a:off x="822960" y="868680"/>
-            <a:ext cx="10515600" cy="731520"/>
+            <a:ext cx="10515600" cy="548640"/>
           </a:xfrm>
           <a:prstGeom prst="rect">
             <a:avLst/>
@@ -5374,8 +5842,8 @@
           <p:nvPr/>
         </p:nvGraphicFramePr>
         <p:xfrm>
-          <a:off x="822960" y="1737360"/>
-          <a:ext cx="10424160" cy="2011680"/>
+          <a:off x="822960" y="1600200"/>
+          <a:ext cx="5577840" cy="2377440"/>
         </p:xfrm>
         <a:graphic>
           <a:graphicData uri="http://schemas.openxmlformats.org/drawingml/2006/table">
@@ -5384,12 +5852,12 @@
                 <a:tableStyleId>{5C22544A-7EE6-4342-B048-85BDC9FD1C3A}</a:tableStyleId>
               </a:tblPr>
               <a:tblGrid>
-                <a:gridCol w="4114800"/>
                 <a:gridCol w="2194560"/>
-                <a:gridCol w="2057400"/>
-                <a:gridCol w="2057400"/>
+                <a:gridCol w="1005840"/>
+                <a:gridCol w="1188720"/>
+                <a:gridCol w="1188720"/>
               </a:tblGrid>
-              <a:tr h="402336">
+              <a:tr h="475488">
                 <a:tc>
                   <a:txBody>
                     <a:bodyPr/>
@@ -5426,7 +5894,7 @@
                           </a:solidFill>
                           <a:latin typeface="Arial"/>
                         </a:rPr>
-                        <a:t>Tuned Param</a:t>
+                        <a:t>Param</a:t>
                       </a:r>
                     </a:p>
                   </a:txBody>
@@ -5483,7 +5951,7 @@
                   </a:tcPr>
                 </a:tc>
               </a:tr>
-              <a:tr h="402336">
+              <a:tr h="475488">
                 <a:tc>
                   <a:txBody>
                     <a:bodyPr/>
@@ -5577,7 +6045,7 @@
                   </a:tcPr>
                 </a:tc>
               </a:tr>
-              <a:tr h="402336">
+              <a:tr h="475488">
                 <a:tc>
                   <a:txBody>
                     <a:bodyPr/>
@@ -5671,7 +6139,7 @@
                   </a:tcPr>
                 </a:tc>
               </a:tr>
-              <a:tr h="402336">
+              <a:tr h="475488">
                 <a:tc>
                   <a:txBody>
                     <a:bodyPr/>
@@ -5765,7 +6233,7 @@
                   </a:tcPr>
                 </a:tc>
               </a:tr>
-              <a:tr h="402336">
+              <a:tr h="475488">
                 <a:tc>
                   <a:txBody>
                     <a:bodyPr/>
@@ -5871,8 +6339,8 @@
         </p:nvSpPr>
         <p:spPr>
           <a:xfrm>
-            <a:off x="822960" y="4023360"/>
-            <a:ext cx="10241280" cy="914400"/>
+            <a:off x="822960" y="4160520"/>
+            <a:ext cx="5394960" cy="1463040"/>
           </a:xfrm>
           <a:prstGeom prst="rect">
             <a:avLst/>
@@ -5902,9 +6370,33 @@
           </a:p>
         </p:txBody>
       </p:sp>
-      <p:sp>
-        <p:nvSpPr>
-          <p:cNvPr id="7" name="TextBox 6"/>
+      <p:pic>
+        <p:nvPicPr>
+          <p:cNvPr id="7" name="Picture 6" descr="before_after_tuning.png"/>
+          <p:cNvPicPr>
+            <a:picLocks noChangeAspect="1"/>
+          </p:cNvPicPr>
+          <p:nvPr/>
+        </p:nvPicPr>
+        <p:blipFill>
+          <a:blip r:embed="rId2"/>
+          <a:stretch>
+            <a:fillRect/>
+          </a:stretch>
+        </p:blipFill>
+        <p:spPr>
+          <a:xfrm>
+            <a:off x="6675120" y="1600200"/>
+            <a:ext cx="4663440" cy="2590800"/>
+          </a:xfrm>
+          <a:prstGeom prst="rect">
+            <a:avLst/>
+          </a:prstGeom>
+        </p:spPr>
+      </p:pic>
+      <p:sp>
+        <p:nvSpPr>
+          <p:cNvPr id="8" name="TextBox 7"/>
           <p:cNvSpPr txBox="1"/>
           <p:nvPr/>
         </p:nvSpPr>
@@ -6051,7 +6543,7 @@
         <p:spPr>
           <a:xfrm>
             <a:off x="822960" y="868680"/>
-            <a:ext cx="10515600" cy="731520"/>
+            <a:ext cx="10515600" cy="548640"/>
           </a:xfrm>
           <a:prstGeom prst="rect">
             <a:avLst/>
@@ -6089,8 +6581,8 @@
         </p:nvSpPr>
         <p:spPr>
           <a:xfrm>
-            <a:off x="822960" y="1554480"/>
-            <a:ext cx="10241280" cy="548640"/>
+            <a:off x="822960" y="1417320"/>
+            <a:ext cx="4937760" cy="822960"/>
           </a:xfrm>
           <a:prstGeom prst="rect">
             <a:avLst/>
@@ -6129,8 +6621,8 @@
           <p:nvPr/>
         </p:nvGraphicFramePr>
         <p:xfrm>
-          <a:off x="822960" y="2286000"/>
-          <a:ext cx="7772400" cy="2377440"/>
+          <a:off x="822960" y="2377440"/>
+          <a:ext cx="4937760" cy="2103120"/>
         </p:xfrm>
         <a:graphic>
           <a:graphicData uri="http://schemas.openxmlformats.org/drawingml/2006/table">
@@ -6139,11 +6631,11 @@
                 <a:tableStyleId>{5C22544A-7EE6-4342-B048-85BDC9FD1C3A}</a:tableStyleId>
               </a:tblPr>
               <a:tblGrid>
-                <a:gridCol w="3657600"/>
-                <a:gridCol w="2057400"/>
-                <a:gridCol w="2057400"/>
+                <a:gridCol w="2377440"/>
+                <a:gridCol w="1280160"/>
+                <a:gridCol w="1280160"/>
               </a:tblGrid>
-              <a:tr h="475488">
+              <a:tr h="420624">
                 <a:tc>
                   <a:txBody>
                     <a:bodyPr/>
@@ -6203,7 +6695,7 @@
                           </a:solidFill>
                           <a:latin typeface="Arial"/>
                         </a:rPr>
-                        <a:t>Test Macro-F1</a:t>
+                        <a:t>F1</a:t>
                       </a:r>
                     </a:p>
                   </a:txBody>
@@ -6214,7 +6706,7 @@
                   </a:tcPr>
                 </a:tc>
               </a:tr>
-              <a:tr h="475488">
+              <a:tr h="420624">
                 <a:tc>
                   <a:txBody>
                     <a:bodyPr/>
@@ -6228,7 +6720,7 @@
                           </a:solidFill>
                           <a:latin typeface="Arial"/>
                         </a:rPr>
-                        <a:t>SVM (RBF kernel)</a:t>
+                        <a:t>SVM (RBF)</a:t>
                       </a:r>
                     </a:p>
                   </a:txBody>
@@ -6285,7 +6777,7 @@
                   </a:tcPr>
                 </a:tc>
               </a:tr>
-              <a:tr h="475488">
+              <a:tr h="420624">
                 <a:tc>
                   <a:txBody>
                     <a:bodyPr/>
@@ -6356,7 +6848,7 @@
                   </a:tcPr>
                 </a:tc>
               </a:tr>
-              <a:tr h="475488">
+              <a:tr h="420624">
                 <a:tc>
                   <a:txBody>
                     <a:bodyPr/>
@@ -6427,7 +6919,7 @@
                   </a:tcPr>
                 </a:tc>
               </a:tr>
-              <a:tr h="475488">
+              <a:tr h="420624">
                 <a:tc>
                   <a:txBody>
                     <a:bodyPr/>
@@ -6510,8 +7002,8 @@
         </p:nvSpPr>
         <p:spPr>
           <a:xfrm>
-            <a:off x="822960" y="4937760"/>
-            <a:ext cx="10241280" cy="822960"/>
+            <a:off x="822960" y="4754880"/>
+            <a:ext cx="4937760" cy="1188720"/>
           </a:xfrm>
           <a:prstGeom prst="rect">
             <a:avLst/>
@@ -6541,9 +7033,33 @@
           </a:p>
         </p:txBody>
       </p:sp>
-      <p:sp>
-        <p:nvSpPr>
-          <p:cNvPr id="8" name="TextBox 7"/>
+      <p:pic>
+        <p:nvPicPr>
+          <p:cNvPr id="8" name="Picture 7" descr="classifier_comparison.png"/>
+          <p:cNvPicPr>
+            <a:picLocks noChangeAspect="1"/>
+          </p:cNvPicPr>
+          <p:nvPr/>
+        </p:nvPicPr>
+        <p:blipFill>
+          <a:blip r:embed="rId2"/>
+          <a:stretch>
+            <a:fillRect/>
+          </a:stretch>
+        </p:blipFill>
+        <p:spPr>
+          <a:xfrm>
+            <a:off x="6035040" y="1600200"/>
+            <a:ext cx="5394960" cy="2967228"/>
+          </a:xfrm>
+          <a:prstGeom prst="rect">
+            <a:avLst/>
+          </a:prstGeom>
+        </p:spPr>
+      </p:pic>
+      <p:sp>
+        <p:nvSpPr>
+          <p:cNvPr id="9" name="TextBox 8"/>
           <p:cNvSpPr txBox="1"/>
           <p:nvPr/>
         </p:nvSpPr>
@@ -6802,6 +7318,50 @@
         </p:nvSpPr>
         <p:spPr>
           <a:xfrm>
+            <a:off x="822960" y="1828800"/>
+            <a:ext cx="5029200" cy="54864"/>
+          </a:xfrm>
+          <a:prstGeom prst="rect">
+            <a:avLst/>
+          </a:prstGeom>
+          <a:solidFill>
+            <a:srgbClr val="B3261E"/>
+          </a:solidFill>
+          <a:ln>
+            <a:noFill/>
+          </a:ln>
+          <a:effectLst/>
+        </p:spPr>
+        <p:style>
+          <a:lnRef idx="1">
+            <a:schemeClr val="accent1"/>
+          </a:lnRef>
+          <a:fillRef idx="3">
+            <a:schemeClr val="accent1"/>
+          </a:fillRef>
+          <a:effectRef idx="2">
+            <a:schemeClr val="accent1"/>
+          </a:effectRef>
+          <a:fontRef idx="minor">
+            <a:schemeClr val="lt1"/>
+          </a:fontRef>
+        </p:style>
+        <p:txBody>
+          <a:bodyPr rtlCol="0" anchor="ctr"/>
+          <a:lstStyle/>
+          <a:p>
+            <a:pPr algn="ctr"/>
+          </a:p>
+        </p:txBody>
+      </p:sp>
+      <p:sp>
+        <p:nvSpPr>
+          <p:cNvPr id="7" name="Rectangle 6"/>
+          <p:cNvSpPr/>
+          <p:nvPr/>
+        </p:nvSpPr>
+        <p:spPr>
+          <a:xfrm>
             <a:off x="6035040" y="1828800"/>
             <a:ext cx="5120640" cy="3108960"/>
           </a:xfrm>
@@ -6870,7 +7430,51 @@
       </p:sp>
       <p:sp>
         <p:nvSpPr>
-          <p:cNvPr id="7" name="TextBox 6"/>
+          <p:cNvPr id="8" name="Rectangle 7"/>
+          <p:cNvSpPr/>
+          <p:nvPr/>
+        </p:nvSpPr>
+        <p:spPr>
+          <a:xfrm>
+            <a:off x="6035040" y="1828800"/>
+            <a:ext cx="5120640" cy="54864"/>
+          </a:xfrm>
+          <a:prstGeom prst="rect">
+            <a:avLst/>
+          </a:prstGeom>
+          <a:solidFill>
+            <a:srgbClr val="1E7A3D"/>
+          </a:solidFill>
+          <a:ln>
+            <a:noFill/>
+          </a:ln>
+          <a:effectLst/>
+        </p:spPr>
+        <p:style>
+          <a:lnRef idx="1">
+            <a:schemeClr val="accent1"/>
+          </a:lnRef>
+          <a:fillRef idx="3">
+            <a:schemeClr val="accent1"/>
+          </a:fillRef>
+          <a:effectRef idx="2">
+            <a:schemeClr val="accent1"/>
+          </a:effectRef>
+          <a:fontRef idx="minor">
+            <a:schemeClr val="lt1"/>
+          </a:fontRef>
+        </p:style>
+        <p:txBody>
+          <a:bodyPr rtlCol="0" anchor="ctr"/>
+          <a:lstStyle/>
+          <a:p>
+            <a:pPr algn="ctr"/>
+          </a:p>
+        </p:txBody>
+      </p:sp>
+      <p:sp>
+        <p:nvSpPr>
+          <p:cNvPr id="9" name="TextBox 8"/>
           <p:cNvSpPr txBox="1"/>
           <p:nvPr/>
         </p:nvSpPr>
@@ -6909,7 +7513,7 @@
       </p:sp>
       <p:sp>
         <p:nvSpPr>
-          <p:cNvPr id="8" name="TextBox 7"/>
+          <p:cNvPr id="10" name="TextBox 9"/>
           <p:cNvSpPr txBox="1"/>
           <p:nvPr/>
         </p:nvSpPr>
@@ -7049,14 +7653,67 @@
       </p:sp>
       <p:sp>
         <p:nvSpPr>
-          <p:cNvPr id="4" name="TextBox 3"/>
+          <p:cNvPr id="4" name="Oval 3"/>
+          <p:cNvSpPr/>
+          <p:nvPr/>
+        </p:nvSpPr>
+        <p:spPr>
+          <a:xfrm>
+            <a:off x="822960" y="1463040"/>
+            <a:ext cx="292608" cy="292608"/>
+          </a:xfrm>
+          <a:prstGeom prst="ellipse">
+            <a:avLst/>
+          </a:prstGeom>
+          <a:solidFill>
+            <a:srgbClr val="8FB4FF"/>
+          </a:solidFill>
+          <a:ln>
+            <a:noFill/>
+          </a:ln>
+          <a:effectLst/>
+        </p:spPr>
+        <p:style>
+          <a:lnRef idx="1">
+            <a:schemeClr val="accent1"/>
+          </a:lnRef>
+          <a:fillRef idx="3">
+            <a:schemeClr val="accent1"/>
+          </a:fillRef>
+          <a:effectRef idx="2">
+            <a:schemeClr val="accent1"/>
+          </a:effectRef>
+          <a:fontRef idx="minor">
+            <a:schemeClr val="lt1"/>
+          </a:fontRef>
+        </p:style>
+        <p:txBody>
+          <a:bodyPr rtlCol="0" anchor="ctr" wrap="none"/>
+          <a:lstStyle/>
+          <a:p>
+            <a:pPr algn="ctr"/>
+            <a:r>
+              <a:rPr sz="1300" b="1">
+                <a:solidFill>
+                  <a:srgbClr val="142340"/>
+                </a:solidFill>
+                <a:latin typeface="Arial"/>
+              </a:rPr>
+              <a:t>✓</a:t>
+            </a:r>
+          </a:p>
+        </p:txBody>
+      </p:sp>
+      <p:sp>
+        <p:nvSpPr>
+          <p:cNvPr id="5" name="TextBox 4"/>
           <p:cNvSpPr txBox="1"/>
           <p:nvPr/>
         </p:nvSpPr>
         <p:spPr>
           <a:xfrm>
-            <a:off x="822960" y="1463040"/>
-            <a:ext cx="10241280" cy="4114800"/>
+            <a:off x="1280160" y="1435608"/>
+            <a:ext cx="9784080" cy="548640"/>
           </a:xfrm>
           <a:prstGeom prst="rect">
             <a:avLst/>
@@ -7069,124 +7726,486 @@
           </a:bodyPr>
           <a:lstStyle/>
           <a:p>
-            <a:pPr>
+            <a:pPr algn="l">
               <a:lnSpc>
-                <a:spcPct val="120000"/>
+                <a:spcPct val="115000"/>
               </a:lnSpc>
-              <a:spcAft>
-                <a:spcPts val="1400"/>
-              </a:spcAft>
             </a:pPr>
             <a:r>
-              <a:rPr sz="1900">
+              <a:rPr sz="1900" b="0" i="0">
                 <a:solidFill>
                   <a:srgbClr val="E3E9F5"/>
                 </a:solidFill>
                 <a:latin typeface="Arial"/>
               </a:rPr>
-              <a:t>•  Doc2Vec embeddings consistently beat LDA topic features on this task</a:t>
-            </a:r>
-          </a:p>
-          <a:p>
-            <a:pPr>
-              <a:lnSpc>
-                <a:spcPct val="120000"/>
-              </a:lnSpc>
-              <a:spcAft>
-                <a:spcPts val="1400"/>
-              </a:spcAft>
-            </a:pPr>
-            <a:r>
-              <a:rPr sz="1900">
-                <a:solidFill>
-                  <a:srgbClr val="E3E9F5"/>
+              <a:t>Doc2Vec embeddings consistently beat LDA topic features on this task</a:t>
+            </a:r>
+          </a:p>
+        </p:txBody>
+      </p:sp>
+      <p:sp>
+        <p:nvSpPr>
+          <p:cNvPr id="6" name="Oval 5"/>
+          <p:cNvSpPr/>
+          <p:nvPr/>
+        </p:nvSpPr>
+        <p:spPr>
+          <a:xfrm>
+            <a:off x="822960" y="2029968"/>
+            <a:ext cx="292608" cy="292608"/>
+          </a:xfrm>
+          <a:prstGeom prst="ellipse">
+            <a:avLst/>
+          </a:prstGeom>
+          <a:solidFill>
+            <a:srgbClr val="8FB4FF"/>
+          </a:solidFill>
+          <a:ln>
+            <a:noFill/>
+          </a:ln>
+          <a:effectLst/>
+        </p:spPr>
+        <p:style>
+          <a:lnRef idx="1">
+            <a:schemeClr val="accent1"/>
+          </a:lnRef>
+          <a:fillRef idx="3">
+            <a:schemeClr val="accent1"/>
+          </a:fillRef>
+          <a:effectRef idx="2">
+            <a:schemeClr val="accent1"/>
+          </a:effectRef>
+          <a:fontRef idx="minor">
+            <a:schemeClr val="lt1"/>
+          </a:fontRef>
+        </p:style>
+        <p:txBody>
+          <a:bodyPr rtlCol="0" anchor="ctr" wrap="none"/>
+          <a:lstStyle/>
+          <a:p>
+            <a:pPr algn="ctr"/>
+            <a:r>
+              <a:rPr sz="1300" b="1">
+                <a:solidFill>
+                  <a:srgbClr val="142340"/>
                 </a:solidFill>
                 <a:latin typeface="Arial"/>
               </a:rPr>
-              <a:t>•  Coarse 15-category task is much easier than the 260+-category one</a:t>
-            </a:r>
-          </a:p>
-          <a:p>
-            <a:pPr>
+              <a:t>✓</a:t>
+            </a:r>
+          </a:p>
+        </p:txBody>
+      </p:sp>
+      <p:sp>
+        <p:nvSpPr>
+          <p:cNvPr id="7" name="TextBox 6"/>
+          <p:cNvSpPr txBox="1"/>
+          <p:nvPr/>
+        </p:nvSpPr>
+        <p:spPr>
+          <a:xfrm>
+            <a:off x="1280160" y="2002536"/>
+            <a:ext cx="9784080" cy="548640"/>
+          </a:xfrm>
+          <a:prstGeom prst="rect">
+            <a:avLst/>
+          </a:prstGeom>
+          <a:noFill/>
+        </p:spPr>
+        <p:txBody>
+          <a:bodyPr wrap="square">
+            <a:spAutoFit/>
+          </a:bodyPr>
+          <a:lstStyle/>
+          <a:p>
+            <a:pPr algn="l">
               <a:lnSpc>
-                <a:spcPct val="120000"/>
+                <a:spcPct val="115000"/>
               </a:lnSpc>
-              <a:spcAft>
-                <a:spcPts val="1400"/>
-              </a:spcAft>
             </a:pPr>
             <a:r>
-              <a:rPr sz="1900">
+              <a:rPr sz="1900" b="0" i="0">
                 <a:solidFill>
                   <a:srgbClr val="E3E9F5"/>
                 </a:solidFill>
                 <a:latin typeface="Arial"/>
               </a:rPr>
-              <a:t>•  Tuning hyperparameters gave real gains everywhere (not just marginal)</a:t>
-            </a:r>
-          </a:p>
-          <a:p>
-            <a:pPr>
-              <a:lnSpc>
-                <a:spcPct val="120000"/>
-              </a:lnSpc>
-              <a:spcAft>
-                <a:spcPts val="1400"/>
-              </a:spcAft>
-            </a:pPr>
-            <a:r>
-              <a:rPr sz="1900">
-                <a:solidFill>
-                  <a:srgbClr val="E3E9F5"/>
+              <a:t>Coarse 15-category task is much easier than the 260+-category one</a:t>
+            </a:r>
+          </a:p>
+        </p:txBody>
+      </p:sp>
+      <p:sp>
+        <p:nvSpPr>
+          <p:cNvPr id="8" name="Oval 7"/>
+          <p:cNvSpPr/>
+          <p:nvPr/>
+        </p:nvSpPr>
+        <p:spPr>
+          <a:xfrm>
+            <a:off x="822960" y="2596896"/>
+            <a:ext cx="292608" cy="292608"/>
+          </a:xfrm>
+          <a:prstGeom prst="ellipse">
+            <a:avLst/>
+          </a:prstGeom>
+          <a:solidFill>
+            <a:srgbClr val="8FB4FF"/>
+          </a:solidFill>
+          <a:ln>
+            <a:noFill/>
+          </a:ln>
+          <a:effectLst/>
+        </p:spPr>
+        <p:style>
+          <a:lnRef idx="1">
+            <a:schemeClr val="accent1"/>
+          </a:lnRef>
+          <a:fillRef idx="3">
+            <a:schemeClr val="accent1"/>
+          </a:fillRef>
+          <a:effectRef idx="2">
+            <a:schemeClr val="accent1"/>
+          </a:effectRef>
+          <a:fontRef idx="minor">
+            <a:schemeClr val="lt1"/>
+          </a:fontRef>
+        </p:style>
+        <p:txBody>
+          <a:bodyPr rtlCol="0" anchor="ctr" wrap="none"/>
+          <a:lstStyle/>
+          <a:p>
+            <a:pPr algn="ctr"/>
+            <a:r>
+              <a:rPr sz="1300" b="1">
+                <a:solidFill>
+                  <a:srgbClr val="142340"/>
                 </a:solidFill>
                 <a:latin typeface="Arial"/>
               </a:rPr>
-              <a:t>•  SVM beat every classifier tried — classifier choice mattered almost as much as features</a:t>
-            </a:r>
-          </a:p>
-          <a:p>
-            <a:pPr>
+              <a:t>✓</a:t>
+            </a:r>
+          </a:p>
+        </p:txBody>
+      </p:sp>
+      <p:sp>
+        <p:nvSpPr>
+          <p:cNvPr id="9" name="TextBox 8"/>
+          <p:cNvSpPr txBox="1"/>
+          <p:nvPr/>
+        </p:nvSpPr>
+        <p:spPr>
+          <a:xfrm>
+            <a:off x="1280160" y="2569464"/>
+            <a:ext cx="9784080" cy="548640"/>
+          </a:xfrm>
+          <a:prstGeom prst="rect">
+            <a:avLst/>
+          </a:prstGeom>
+          <a:noFill/>
+        </p:spPr>
+        <p:txBody>
+          <a:bodyPr wrap="square">
+            <a:spAutoFit/>
+          </a:bodyPr>
+          <a:lstStyle/>
+          <a:p>
+            <a:pPr algn="l">
               <a:lnSpc>
-                <a:spcPct val="120000"/>
+                <a:spcPct val="115000"/>
               </a:lnSpc>
-              <a:spcAft>
-                <a:spcPts val="1400"/>
-              </a:spcAft>
             </a:pPr>
             <a:r>
-              <a:rPr sz="1900">
+              <a:rPr sz="1900" b="0" i="0">
                 <a:solidFill>
                   <a:srgbClr val="E3E9F5"/>
                 </a:solidFill>
                 <a:latin typeface="Arial"/>
               </a:rPr>
-              <a:t>•  Our numbers land in the same range and order as the original paper's</a:t>
-            </a:r>
-          </a:p>
-          <a:p>
-            <a:pPr>
-              <a:lnSpc>
-                <a:spcPct val="120000"/>
-              </a:lnSpc>
-              <a:spcAft>
-                <a:spcPts val="1400"/>
-              </a:spcAft>
-            </a:pPr>
-            <a:r>
-              <a:rPr sz="1900">
-                <a:solidFill>
-                  <a:srgbClr val="E3E9F5"/>
+              <a:t>Tuning hyperparameters gave real gains everywhere (not just marginal)</a:t>
+            </a:r>
+          </a:p>
+        </p:txBody>
+      </p:sp>
+      <p:sp>
+        <p:nvSpPr>
+          <p:cNvPr id="10" name="Oval 9"/>
+          <p:cNvSpPr/>
+          <p:nvPr/>
+        </p:nvSpPr>
+        <p:spPr>
+          <a:xfrm>
+            <a:off x="822960" y="3163824"/>
+            <a:ext cx="292608" cy="292608"/>
+          </a:xfrm>
+          <a:prstGeom prst="ellipse">
+            <a:avLst/>
+          </a:prstGeom>
+          <a:solidFill>
+            <a:srgbClr val="8FB4FF"/>
+          </a:solidFill>
+          <a:ln>
+            <a:noFill/>
+          </a:ln>
+          <a:effectLst/>
+        </p:spPr>
+        <p:style>
+          <a:lnRef idx="1">
+            <a:schemeClr val="accent1"/>
+          </a:lnRef>
+          <a:fillRef idx="3">
+            <a:schemeClr val="accent1"/>
+          </a:fillRef>
+          <a:effectRef idx="2">
+            <a:schemeClr val="accent1"/>
+          </a:effectRef>
+          <a:fontRef idx="minor">
+            <a:schemeClr val="lt1"/>
+          </a:fontRef>
+        </p:style>
+        <p:txBody>
+          <a:bodyPr rtlCol="0" anchor="ctr" wrap="none"/>
+          <a:lstStyle/>
+          <a:p>
+            <a:pPr algn="ctr"/>
+            <a:r>
+              <a:rPr sz="1300" b="1">
+                <a:solidFill>
+                  <a:srgbClr val="142340"/>
                 </a:solidFill>
                 <a:latin typeface="Arial"/>
               </a:rPr>
-              <a:t>•  BERT not replicated — paper's own attempt ran out of memory, no baseline to match</a:t>
-            </a:r>
-          </a:p>
-        </p:txBody>
-      </p:sp>
-      <p:sp>
-        <p:nvSpPr>
-          <p:cNvPr id="5" name="TextBox 4"/>
+              <a:t>✓</a:t>
+            </a:r>
+          </a:p>
+        </p:txBody>
+      </p:sp>
+      <p:sp>
+        <p:nvSpPr>
+          <p:cNvPr id="11" name="TextBox 10"/>
+          <p:cNvSpPr txBox="1"/>
+          <p:nvPr/>
+        </p:nvSpPr>
+        <p:spPr>
+          <a:xfrm>
+            <a:off x="1280160" y="3136392"/>
+            <a:ext cx="9784080" cy="548640"/>
+          </a:xfrm>
+          <a:prstGeom prst="rect">
+            <a:avLst/>
+          </a:prstGeom>
+          <a:noFill/>
+        </p:spPr>
+        <p:txBody>
+          <a:bodyPr wrap="square">
+            <a:spAutoFit/>
+          </a:bodyPr>
+          <a:lstStyle/>
+          <a:p>
+            <a:pPr algn="l">
+              <a:lnSpc>
+                <a:spcPct val="115000"/>
+              </a:lnSpc>
+            </a:pPr>
+            <a:r>
+              <a:rPr sz="1900" b="0" i="0">
+                <a:solidFill>
+                  <a:srgbClr val="E3E9F5"/>
+                </a:solidFill>
+                <a:latin typeface="Arial"/>
+              </a:rPr>
+              <a:t>SVM beat every classifier tried — classifier choice mattered almost as much as features</a:t>
+            </a:r>
+          </a:p>
+        </p:txBody>
+      </p:sp>
+      <p:sp>
+        <p:nvSpPr>
+          <p:cNvPr id="12" name="Oval 11"/>
+          <p:cNvSpPr/>
+          <p:nvPr/>
+        </p:nvSpPr>
+        <p:spPr>
+          <a:xfrm>
+            <a:off x="822960" y="3730752"/>
+            <a:ext cx="292608" cy="292608"/>
+          </a:xfrm>
+          <a:prstGeom prst="ellipse">
+            <a:avLst/>
+          </a:prstGeom>
+          <a:solidFill>
+            <a:srgbClr val="8FB4FF"/>
+          </a:solidFill>
+          <a:ln>
+            <a:noFill/>
+          </a:ln>
+          <a:effectLst/>
+        </p:spPr>
+        <p:style>
+          <a:lnRef idx="1">
+            <a:schemeClr val="accent1"/>
+          </a:lnRef>
+          <a:fillRef idx="3">
+            <a:schemeClr val="accent1"/>
+          </a:fillRef>
+          <a:effectRef idx="2">
+            <a:schemeClr val="accent1"/>
+          </a:effectRef>
+          <a:fontRef idx="minor">
+            <a:schemeClr val="lt1"/>
+          </a:fontRef>
+        </p:style>
+        <p:txBody>
+          <a:bodyPr rtlCol="0" anchor="ctr" wrap="none"/>
+          <a:lstStyle/>
+          <a:p>
+            <a:pPr algn="ctr"/>
+            <a:r>
+              <a:rPr sz="1300" b="1">
+                <a:solidFill>
+                  <a:srgbClr val="142340"/>
+                </a:solidFill>
+                <a:latin typeface="Arial"/>
+              </a:rPr>
+              <a:t>✓</a:t>
+            </a:r>
+          </a:p>
+        </p:txBody>
+      </p:sp>
+      <p:sp>
+        <p:nvSpPr>
+          <p:cNvPr id="13" name="TextBox 12"/>
+          <p:cNvSpPr txBox="1"/>
+          <p:nvPr/>
+        </p:nvSpPr>
+        <p:spPr>
+          <a:xfrm>
+            <a:off x="1280160" y="3703320"/>
+            <a:ext cx="9784080" cy="548640"/>
+          </a:xfrm>
+          <a:prstGeom prst="rect">
+            <a:avLst/>
+          </a:prstGeom>
+          <a:noFill/>
+        </p:spPr>
+        <p:txBody>
+          <a:bodyPr wrap="square">
+            <a:spAutoFit/>
+          </a:bodyPr>
+          <a:lstStyle/>
+          <a:p>
+            <a:pPr algn="l">
+              <a:lnSpc>
+                <a:spcPct val="115000"/>
+              </a:lnSpc>
+            </a:pPr>
+            <a:r>
+              <a:rPr sz="1900" b="0" i="0">
+                <a:solidFill>
+                  <a:srgbClr val="E3E9F5"/>
+                </a:solidFill>
+                <a:latin typeface="Arial"/>
+              </a:rPr>
+              <a:t>Our numbers land in the same range and order as the original paper's</a:t>
+            </a:r>
+          </a:p>
+        </p:txBody>
+      </p:sp>
+      <p:sp>
+        <p:nvSpPr>
+          <p:cNvPr id="14" name="Oval 13"/>
+          <p:cNvSpPr/>
+          <p:nvPr/>
+        </p:nvSpPr>
+        <p:spPr>
+          <a:xfrm>
+            <a:off x="822960" y="4297680"/>
+            <a:ext cx="292608" cy="292608"/>
+          </a:xfrm>
+          <a:prstGeom prst="ellipse">
+            <a:avLst/>
+          </a:prstGeom>
+          <a:solidFill>
+            <a:srgbClr val="8FB4FF"/>
+          </a:solidFill>
+          <a:ln>
+            <a:noFill/>
+          </a:ln>
+          <a:effectLst/>
+        </p:spPr>
+        <p:style>
+          <a:lnRef idx="1">
+            <a:schemeClr val="accent1"/>
+          </a:lnRef>
+          <a:fillRef idx="3">
+            <a:schemeClr val="accent1"/>
+          </a:fillRef>
+          <a:effectRef idx="2">
+            <a:schemeClr val="accent1"/>
+          </a:effectRef>
+          <a:fontRef idx="minor">
+            <a:schemeClr val="lt1"/>
+          </a:fontRef>
+        </p:style>
+        <p:txBody>
+          <a:bodyPr rtlCol="0" anchor="ctr" wrap="none"/>
+          <a:lstStyle/>
+          <a:p>
+            <a:pPr algn="ctr"/>
+            <a:r>
+              <a:rPr sz="1300" b="1">
+                <a:solidFill>
+                  <a:srgbClr val="142340"/>
+                </a:solidFill>
+                <a:latin typeface="Arial"/>
+              </a:rPr>
+              <a:t>✓</a:t>
+            </a:r>
+          </a:p>
+        </p:txBody>
+      </p:sp>
+      <p:sp>
+        <p:nvSpPr>
+          <p:cNvPr id="15" name="TextBox 14"/>
+          <p:cNvSpPr txBox="1"/>
+          <p:nvPr/>
+        </p:nvSpPr>
+        <p:spPr>
+          <a:xfrm>
+            <a:off x="1280160" y="4270248"/>
+            <a:ext cx="9784080" cy="548640"/>
+          </a:xfrm>
+          <a:prstGeom prst="rect">
+            <a:avLst/>
+          </a:prstGeom>
+          <a:noFill/>
+        </p:spPr>
+        <p:txBody>
+          <a:bodyPr wrap="square">
+            <a:spAutoFit/>
+          </a:bodyPr>
+          <a:lstStyle/>
+          <a:p>
+            <a:pPr algn="l">
+              <a:lnSpc>
+                <a:spcPct val="115000"/>
+              </a:lnSpc>
+            </a:pPr>
+            <a:r>
+              <a:rPr sz="1900" b="0" i="0">
+                <a:solidFill>
+                  <a:srgbClr val="E3E9F5"/>
+                </a:solidFill>
+                <a:latin typeface="Arial"/>
+              </a:rPr>
+              <a:t>BERT not replicated — paper's own attempt ran out of memory, no baseline to match</a:t>
+            </a:r>
+          </a:p>
+        </p:txBody>
+      </p:sp>
+      <p:sp>
+        <p:nvSpPr>
+          <p:cNvPr id="16" name="TextBox 15"/>
           <p:cNvSpPr txBox="1"/>
           <p:nvPr/>
         </p:nvSpPr>
@@ -7225,7 +8244,7 @@
       </p:sp>
       <p:sp>
         <p:nvSpPr>
-          <p:cNvPr id="6" name="TextBox 5"/>
+          <p:cNvPr id="17" name="TextBox 16"/>
           <p:cNvSpPr txBox="1"/>
           <p:nvPr/>
         </p:nvSpPr>

</xml_diff>

<commit_message>
Clarify Phase 3 wording in slides, README and write-up
- Name the classifier Gaussian Naive Bayes
- State that SVM, Random Forest and Naive Bayes use default hyperparameters
  while Logistic Regression's C was tuned on dev
- Qualify the SVM conclusion: best on Doc2Vec issue_area, about level with LR on LDA
- Note results are single-seed, single-split
</commit_message>
<xml_diff>
--- a/report/slides.pptx
+++ b/report/slides.pptx
@@ -6607,7 +6607,7 @@
                 </a:solidFill>
                 <a:latin typeface="Arial"/>
               </a:rPr>
-              <a:t>The paper only tries Logistic Regression. We also tried SVM, Random Forest, and Naive Bayes — same Doc2Vec fingerprints, issue_area task.</a:t>
+              <a:t>The paper only tries Logistic Regression. We also tried SVM, Random Forest, and Gaussian Naive Bayes — same Doc2Vec fingerprints, issue_area task.</a:t>
             </a:r>
           </a:p>
         </p:txBody>
@@ -6933,7 +6933,7 @@
                           </a:solidFill>
                           <a:latin typeface="Arial"/>
                         </a:rPr>
-                        <a:t>Naive Bayes</a:t>
+                        <a:t>Gaussian Naive Bayes</a:t>
                       </a:r>
                     </a:p>
                   </a:txBody>
@@ -7002,8 +7002,47 @@
         </p:nvSpPr>
         <p:spPr>
           <a:xfrm>
-            <a:off x="822960" y="4754880"/>
-            <a:ext cx="4937760" cy="1188720"/>
+            <a:off x="822960" y="4526280"/>
+            <a:ext cx="4937760" cy="548640"/>
+          </a:xfrm>
+          <a:prstGeom prst="rect">
+            <a:avLst/>
+          </a:prstGeom>
+          <a:noFill/>
+        </p:spPr>
+        <p:txBody>
+          <a:bodyPr wrap="square">
+            <a:spAutoFit/>
+          </a:bodyPr>
+          <a:lstStyle/>
+          <a:p>
+            <a:pPr algn="l">
+              <a:lnSpc>
+                <a:spcPct val="120000"/>
+              </a:lnSpc>
+            </a:pPr>
+            <a:r>
+              <a:rPr sz="1100" b="0" i="0">
+                <a:solidFill>
+                  <a:srgbClr val="6A7179"/>
+                </a:solidFill>
+                <a:latin typeface="Arial"/>
+              </a:rPr>
+              <a:t>SVM (RBF, C=1.0), Random Forest (200 trees) and Naive Bayes use defaults, untuned; LR (C=1.0) is the tuned one.</a:t>
+            </a:r>
+          </a:p>
+        </p:txBody>
+      </p:sp>
+      <p:sp>
+        <p:nvSpPr>
+          <p:cNvPr id="8" name="TextBox 7"/>
+          <p:cNvSpPr txBox="1"/>
+          <p:nvPr/>
+        </p:nvSpPr>
+        <p:spPr>
+          <a:xfrm>
+            <a:off x="822960" y="5120640"/>
+            <a:ext cx="4937760" cy="1005840"/>
           </a:xfrm>
           <a:prstGeom prst="rect">
             <a:avLst/>
@@ -7035,7 +7074,7 @@
       </p:sp>
       <p:pic>
         <p:nvPicPr>
-          <p:cNvPr id="8" name="Picture 7" descr="classifier_comparison.png"/>
+          <p:cNvPr id="9" name="Picture 8" descr="classifier_comparison.png"/>
           <p:cNvPicPr>
             <a:picLocks noChangeAspect="1"/>
           </p:cNvPicPr>
@@ -7059,7 +7098,7 @@
       </p:pic>
       <p:sp>
         <p:nvSpPr>
-          <p:cNvPr id="9" name="TextBox 8"/>
+          <p:cNvPr id="10" name="TextBox 9"/>
           <p:cNvSpPr txBox="1"/>
           <p:nvPr/>
         </p:nvSpPr>
@@ -8014,7 +8053,7 @@
                 </a:solidFill>
                 <a:latin typeface="Arial"/>
               </a:rPr>
-              <a:t>SVM beat every classifier tried — classifier choice mattered almost as much as features</a:t>
+              <a:t>SVM beat every classifier on Doc2Vec issue_area (on LDA ~level with LR: 49.1 vs 48.7%)</a:t>
             </a:r>
           </a:p>
         </p:txBody>

</xml_diff>

<commit_message>
Slides: add 2 new comparison charts, icon accents, now 10 slides
- results/figures/per_category_f1.png: grouped bar, LDA vs Doc2Vec F1 across
  all 13 issue_area categories -- replaces the old text-only Insights slide
  cards, shows LDA collapsing on rare categories far more clearly than prose
- results/figures/progress_by_phase.png: Doc2Vec+issue_area test accuracy
  across all 3 phases (59.1% -> 62.2% -> 68.8%), line+bar combo
- new slide 'Putting It Together' (9 slides -> 10) walks through that
  progress chart with per-phase bullets, drives home the ~10pp total gain
- Approach slide: small icon badges (Sigma for LDA/stats, command-glyph for
  Doc2Vec/embeddings) on each method card
- fixed footer numbering (content-slide-count denominator, was previously
  inconsistent between early and late slides)
</commit_message>
<xml_diff>
--- a/report/slides.pptx
+++ b/report/slides.pptx
@@ -14,6 +14,7 @@
     <p:sldId id="262" r:id="rId13"/>
     <p:sldId id="263" r:id="rId14"/>
     <p:sldId id="264" r:id="rId15"/>
+    <p:sldId id="265" r:id="rId16"/>
   </p:sldIdLst>
   <p:sldSz cx="12191695" cy="6858000" type="screen4x3"/>
   <p:notesSz cx="6858000" cy="9144000"/>
@@ -3440,6 +3441,737 @@
 </p:sld>
 </file>
 
+<file path=ppt/slides/slide10.xml><?xml version="1.0" encoding="utf-8"?>
+<p:sld xmlns:a="http://schemas.openxmlformats.org/drawingml/2006/main" xmlns:p="http://schemas.openxmlformats.org/presentationml/2006/main" xmlns:r="http://schemas.openxmlformats.org/officeDocument/2006/relationships">
+  <p:cSld>
+    <p:spTree>
+      <p:nvGrpSpPr>
+        <p:cNvPr id="1" name=""/>
+        <p:cNvGrpSpPr/>
+        <p:nvPr/>
+      </p:nvGrpSpPr>
+      <p:grpSpPr/>
+      <p:sp>
+        <p:nvSpPr>
+          <p:cNvPr id="2" name="Rectangle 1"/>
+          <p:cNvSpPr/>
+          <p:nvPr/>
+        </p:nvSpPr>
+        <p:spPr>
+          <a:xfrm>
+            <a:off x="0" y="0"/>
+            <a:ext cx="12191695" cy="6858000"/>
+          </a:xfrm>
+          <a:prstGeom prst="rect">
+            <a:avLst/>
+          </a:prstGeom>
+          <a:solidFill>
+            <a:srgbClr val="142340"/>
+          </a:solidFill>
+          <a:ln>
+            <a:noFill/>
+          </a:ln>
+          <a:effectLst/>
+        </p:spPr>
+        <p:style>
+          <a:lnRef idx="1">
+            <a:schemeClr val="accent1"/>
+          </a:lnRef>
+          <a:fillRef idx="3">
+            <a:schemeClr val="accent1"/>
+          </a:fillRef>
+          <a:effectRef idx="2">
+            <a:schemeClr val="accent1"/>
+          </a:effectRef>
+          <a:fontRef idx="minor">
+            <a:schemeClr val="lt1"/>
+          </a:fontRef>
+        </p:style>
+        <p:txBody>
+          <a:bodyPr rtlCol="0" anchor="ctr"/>
+          <a:lstStyle/>
+          <a:p>
+            <a:pPr algn="ctr"/>
+          </a:p>
+        </p:txBody>
+      </p:sp>
+      <p:sp>
+        <p:nvSpPr>
+          <p:cNvPr id="3" name="TextBox 2"/>
+          <p:cNvSpPr txBox="1"/>
+          <p:nvPr/>
+        </p:nvSpPr>
+        <p:spPr>
+          <a:xfrm>
+            <a:off x="822960" y="502920"/>
+            <a:ext cx="10058400" cy="365760"/>
+          </a:xfrm>
+          <a:prstGeom prst="rect">
+            <a:avLst/>
+          </a:prstGeom>
+          <a:noFill/>
+        </p:spPr>
+        <p:txBody>
+          <a:bodyPr wrap="square">
+            <a:spAutoFit/>
+          </a:bodyPr>
+          <a:lstStyle/>
+          <a:p>
+            <a:pPr algn="l">
+              <a:lnSpc>
+                <a:spcPct val="110000"/>
+              </a:lnSpc>
+            </a:pPr>
+            <a:r>
+              <a:rPr sz="1400" b="1" i="0">
+                <a:solidFill>
+                  <a:srgbClr val="8FB4FF"/>
+                </a:solidFill>
+                <a:latin typeface="Arial"/>
+              </a:rPr>
+              <a:t>CONCLUSIONS</a:t>
+            </a:r>
+          </a:p>
+        </p:txBody>
+      </p:sp>
+      <p:sp>
+        <p:nvSpPr>
+          <p:cNvPr id="4" name="Oval 3"/>
+          <p:cNvSpPr/>
+          <p:nvPr/>
+        </p:nvSpPr>
+        <p:spPr>
+          <a:xfrm>
+            <a:off x="822960" y="1463040"/>
+            <a:ext cx="292608" cy="292608"/>
+          </a:xfrm>
+          <a:prstGeom prst="ellipse">
+            <a:avLst/>
+          </a:prstGeom>
+          <a:solidFill>
+            <a:srgbClr val="8FB4FF"/>
+          </a:solidFill>
+          <a:ln>
+            <a:noFill/>
+          </a:ln>
+          <a:effectLst/>
+        </p:spPr>
+        <p:style>
+          <a:lnRef idx="1">
+            <a:schemeClr val="accent1"/>
+          </a:lnRef>
+          <a:fillRef idx="3">
+            <a:schemeClr val="accent1"/>
+          </a:fillRef>
+          <a:effectRef idx="2">
+            <a:schemeClr val="accent1"/>
+          </a:effectRef>
+          <a:fontRef idx="minor">
+            <a:schemeClr val="lt1"/>
+          </a:fontRef>
+        </p:style>
+        <p:txBody>
+          <a:bodyPr rtlCol="0" anchor="ctr" wrap="none"/>
+          <a:lstStyle/>
+          <a:p>
+            <a:pPr algn="ctr"/>
+            <a:r>
+              <a:rPr sz="1300" b="1">
+                <a:solidFill>
+                  <a:srgbClr val="142340"/>
+                </a:solidFill>
+                <a:latin typeface="Arial"/>
+              </a:rPr>
+              <a:t>✓</a:t>
+            </a:r>
+          </a:p>
+        </p:txBody>
+      </p:sp>
+      <p:sp>
+        <p:nvSpPr>
+          <p:cNvPr id="5" name="TextBox 4"/>
+          <p:cNvSpPr txBox="1"/>
+          <p:nvPr/>
+        </p:nvSpPr>
+        <p:spPr>
+          <a:xfrm>
+            <a:off x="1280160" y="1435608"/>
+            <a:ext cx="9784080" cy="548640"/>
+          </a:xfrm>
+          <a:prstGeom prst="rect">
+            <a:avLst/>
+          </a:prstGeom>
+          <a:noFill/>
+        </p:spPr>
+        <p:txBody>
+          <a:bodyPr wrap="square">
+            <a:spAutoFit/>
+          </a:bodyPr>
+          <a:lstStyle/>
+          <a:p>
+            <a:pPr algn="l">
+              <a:lnSpc>
+                <a:spcPct val="115000"/>
+              </a:lnSpc>
+            </a:pPr>
+            <a:r>
+              <a:rPr sz="1900" b="0" i="0">
+                <a:solidFill>
+                  <a:srgbClr val="E3E9F5"/>
+                </a:solidFill>
+                <a:latin typeface="Arial"/>
+              </a:rPr>
+              <a:t>Doc2Vec embeddings consistently beat LDA topic features on this task</a:t>
+            </a:r>
+          </a:p>
+        </p:txBody>
+      </p:sp>
+      <p:sp>
+        <p:nvSpPr>
+          <p:cNvPr id="6" name="Oval 5"/>
+          <p:cNvSpPr/>
+          <p:nvPr/>
+        </p:nvSpPr>
+        <p:spPr>
+          <a:xfrm>
+            <a:off x="822960" y="2029968"/>
+            <a:ext cx="292608" cy="292608"/>
+          </a:xfrm>
+          <a:prstGeom prst="ellipse">
+            <a:avLst/>
+          </a:prstGeom>
+          <a:solidFill>
+            <a:srgbClr val="8FB4FF"/>
+          </a:solidFill>
+          <a:ln>
+            <a:noFill/>
+          </a:ln>
+          <a:effectLst/>
+        </p:spPr>
+        <p:style>
+          <a:lnRef idx="1">
+            <a:schemeClr val="accent1"/>
+          </a:lnRef>
+          <a:fillRef idx="3">
+            <a:schemeClr val="accent1"/>
+          </a:fillRef>
+          <a:effectRef idx="2">
+            <a:schemeClr val="accent1"/>
+          </a:effectRef>
+          <a:fontRef idx="minor">
+            <a:schemeClr val="lt1"/>
+          </a:fontRef>
+        </p:style>
+        <p:txBody>
+          <a:bodyPr rtlCol="0" anchor="ctr" wrap="none"/>
+          <a:lstStyle/>
+          <a:p>
+            <a:pPr algn="ctr"/>
+            <a:r>
+              <a:rPr sz="1300" b="1">
+                <a:solidFill>
+                  <a:srgbClr val="142340"/>
+                </a:solidFill>
+                <a:latin typeface="Arial"/>
+              </a:rPr>
+              <a:t>✓</a:t>
+            </a:r>
+          </a:p>
+        </p:txBody>
+      </p:sp>
+      <p:sp>
+        <p:nvSpPr>
+          <p:cNvPr id="7" name="TextBox 6"/>
+          <p:cNvSpPr txBox="1"/>
+          <p:nvPr/>
+        </p:nvSpPr>
+        <p:spPr>
+          <a:xfrm>
+            <a:off x="1280160" y="2002536"/>
+            <a:ext cx="9784080" cy="548640"/>
+          </a:xfrm>
+          <a:prstGeom prst="rect">
+            <a:avLst/>
+          </a:prstGeom>
+          <a:noFill/>
+        </p:spPr>
+        <p:txBody>
+          <a:bodyPr wrap="square">
+            <a:spAutoFit/>
+          </a:bodyPr>
+          <a:lstStyle/>
+          <a:p>
+            <a:pPr algn="l">
+              <a:lnSpc>
+                <a:spcPct val="115000"/>
+              </a:lnSpc>
+            </a:pPr>
+            <a:r>
+              <a:rPr sz="1900" b="0" i="0">
+                <a:solidFill>
+                  <a:srgbClr val="E3E9F5"/>
+                </a:solidFill>
+                <a:latin typeface="Arial"/>
+              </a:rPr>
+              <a:t>Coarse 15-category task is much easier than the 260+-category one</a:t>
+            </a:r>
+          </a:p>
+        </p:txBody>
+      </p:sp>
+      <p:sp>
+        <p:nvSpPr>
+          <p:cNvPr id="8" name="Oval 7"/>
+          <p:cNvSpPr/>
+          <p:nvPr/>
+        </p:nvSpPr>
+        <p:spPr>
+          <a:xfrm>
+            <a:off x="822960" y="2596896"/>
+            <a:ext cx="292608" cy="292608"/>
+          </a:xfrm>
+          <a:prstGeom prst="ellipse">
+            <a:avLst/>
+          </a:prstGeom>
+          <a:solidFill>
+            <a:srgbClr val="8FB4FF"/>
+          </a:solidFill>
+          <a:ln>
+            <a:noFill/>
+          </a:ln>
+          <a:effectLst/>
+        </p:spPr>
+        <p:style>
+          <a:lnRef idx="1">
+            <a:schemeClr val="accent1"/>
+          </a:lnRef>
+          <a:fillRef idx="3">
+            <a:schemeClr val="accent1"/>
+          </a:fillRef>
+          <a:effectRef idx="2">
+            <a:schemeClr val="accent1"/>
+          </a:effectRef>
+          <a:fontRef idx="minor">
+            <a:schemeClr val="lt1"/>
+          </a:fontRef>
+        </p:style>
+        <p:txBody>
+          <a:bodyPr rtlCol="0" anchor="ctr" wrap="none"/>
+          <a:lstStyle/>
+          <a:p>
+            <a:pPr algn="ctr"/>
+            <a:r>
+              <a:rPr sz="1300" b="1">
+                <a:solidFill>
+                  <a:srgbClr val="142340"/>
+                </a:solidFill>
+                <a:latin typeface="Arial"/>
+              </a:rPr>
+              <a:t>✓</a:t>
+            </a:r>
+          </a:p>
+        </p:txBody>
+      </p:sp>
+      <p:sp>
+        <p:nvSpPr>
+          <p:cNvPr id="9" name="TextBox 8"/>
+          <p:cNvSpPr txBox="1"/>
+          <p:nvPr/>
+        </p:nvSpPr>
+        <p:spPr>
+          <a:xfrm>
+            <a:off x="1280160" y="2569464"/>
+            <a:ext cx="9784080" cy="548640"/>
+          </a:xfrm>
+          <a:prstGeom prst="rect">
+            <a:avLst/>
+          </a:prstGeom>
+          <a:noFill/>
+        </p:spPr>
+        <p:txBody>
+          <a:bodyPr wrap="square">
+            <a:spAutoFit/>
+          </a:bodyPr>
+          <a:lstStyle/>
+          <a:p>
+            <a:pPr algn="l">
+              <a:lnSpc>
+                <a:spcPct val="115000"/>
+              </a:lnSpc>
+            </a:pPr>
+            <a:r>
+              <a:rPr sz="1900" b="0" i="0">
+                <a:solidFill>
+                  <a:srgbClr val="E3E9F5"/>
+                </a:solidFill>
+                <a:latin typeface="Arial"/>
+              </a:rPr>
+              <a:t>Tuning hyperparameters gave real gains everywhere (not just marginal)</a:t>
+            </a:r>
+          </a:p>
+        </p:txBody>
+      </p:sp>
+      <p:sp>
+        <p:nvSpPr>
+          <p:cNvPr id="10" name="Oval 9"/>
+          <p:cNvSpPr/>
+          <p:nvPr/>
+        </p:nvSpPr>
+        <p:spPr>
+          <a:xfrm>
+            <a:off x="822960" y="3163824"/>
+            <a:ext cx="292608" cy="292608"/>
+          </a:xfrm>
+          <a:prstGeom prst="ellipse">
+            <a:avLst/>
+          </a:prstGeom>
+          <a:solidFill>
+            <a:srgbClr val="8FB4FF"/>
+          </a:solidFill>
+          <a:ln>
+            <a:noFill/>
+          </a:ln>
+          <a:effectLst/>
+        </p:spPr>
+        <p:style>
+          <a:lnRef idx="1">
+            <a:schemeClr val="accent1"/>
+          </a:lnRef>
+          <a:fillRef idx="3">
+            <a:schemeClr val="accent1"/>
+          </a:fillRef>
+          <a:effectRef idx="2">
+            <a:schemeClr val="accent1"/>
+          </a:effectRef>
+          <a:fontRef idx="minor">
+            <a:schemeClr val="lt1"/>
+          </a:fontRef>
+        </p:style>
+        <p:txBody>
+          <a:bodyPr rtlCol="0" anchor="ctr" wrap="none"/>
+          <a:lstStyle/>
+          <a:p>
+            <a:pPr algn="ctr"/>
+            <a:r>
+              <a:rPr sz="1300" b="1">
+                <a:solidFill>
+                  <a:srgbClr val="142340"/>
+                </a:solidFill>
+                <a:latin typeface="Arial"/>
+              </a:rPr>
+              <a:t>✓</a:t>
+            </a:r>
+          </a:p>
+        </p:txBody>
+      </p:sp>
+      <p:sp>
+        <p:nvSpPr>
+          <p:cNvPr id="11" name="TextBox 10"/>
+          <p:cNvSpPr txBox="1"/>
+          <p:nvPr/>
+        </p:nvSpPr>
+        <p:spPr>
+          <a:xfrm>
+            <a:off x="1280160" y="3136392"/>
+            <a:ext cx="9784080" cy="548640"/>
+          </a:xfrm>
+          <a:prstGeom prst="rect">
+            <a:avLst/>
+          </a:prstGeom>
+          <a:noFill/>
+        </p:spPr>
+        <p:txBody>
+          <a:bodyPr wrap="square">
+            <a:spAutoFit/>
+          </a:bodyPr>
+          <a:lstStyle/>
+          <a:p>
+            <a:pPr algn="l">
+              <a:lnSpc>
+                <a:spcPct val="115000"/>
+              </a:lnSpc>
+            </a:pPr>
+            <a:r>
+              <a:rPr sz="1900" b="0" i="0">
+                <a:solidFill>
+                  <a:srgbClr val="E3E9F5"/>
+                </a:solidFill>
+                <a:latin typeface="Arial"/>
+              </a:rPr>
+              <a:t>SVM beat every classifier on Doc2Vec issue_area (on LDA ~level with LR: 49.1 vs 48.7%)</a:t>
+            </a:r>
+          </a:p>
+        </p:txBody>
+      </p:sp>
+      <p:sp>
+        <p:nvSpPr>
+          <p:cNvPr id="12" name="Oval 11"/>
+          <p:cNvSpPr/>
+          <p:nvPr/>
+        </p:nvSpPr>
+        <p:spPr>
+          <a:xfrm>
+            <a:off x="822960" y="3730752"/>
+            <a:ext cx="292608" cy="292608"/>
+          </a:xfrm>
+          <a:prstGeom prst="ellipse">
+            <a:avLst/>
+          </a:prstGeom>
+          <a:solidFill>
+            <a:srgbClr val="8FB4FF"/>
+          </a:solidFill>
+          <a:ln>
+            <a:noFill/>
+          </a:ln>
+          <a:effectLst/>
+        </p:spPr>
+        <p:style>
+          <a:lnRef idx="1">
+            <a:schemeClr val="accent1"/>
+          </a:lnRef>
+          <a:fillRef idx="3">
+            <a:schemeClr val="accent1"/>
+          </a:fillRef>
+          <a:effectRef idx="2">
+            <a:schemeClr val="accent1"/>
+          </a:effectRef>
+          <a:fontRef idx="minor">
+            <a:schemeClr val="lt1"/>
+          </a:fontRef>
+        </p:style>
+        <p:txBody>
+          <a:bodyPr rtlCol="0" anchor="ctr" wrap="none"/>
+          <a:lstStyle/>
+          <a:p>
+            <a:pPr algn="ctr"/>
+            <a:r>
+              <a:rPr sz="1300" b="1">
+                <a:solidFill>
+                  <a:srgbClr val="142340"/>
+                </a:solidFill>
+                <a:latin typeface="Arial"/>
+              </a:rPr>
+              <a:t>✓</a:t>
+            </a:r>
+          </a:p>
+        </p:txBody>
+      </p:sp>
+      <p:sp>
+        <p:nvSpPr>
+          <p:cNvPr id="13" name="TextBox 12"/>
+          <p:cNvSpPr txBox="1"/>
+          <p:nvPr/>
+        </p:nvSpPr>
+        <p:spPr>
+          <a:xfrm>
+            <a:off x="1280160" y="3703320"/>
+            <a:ext cx="9784080" cy="548640"/>
+          </a:xfrm>
+          <a:prstGeom prst="rect">
+            <a:avLst/>
+          </a:prstGeom>
+          <a:noFill/>
+        </p:spPr>
+        <p:txBody>
+          <a:bodyPr wrap="square">
+            <a:spAutoFit/>
+          </a:bodyPr>
+          <a:lstStyle/>
+          <a:p>
+            <a:pPr algn="l">
+              <a:lnSpc>
+                <a:spcPct val="115000"/>
+              </a:lnSpc>
+            </a:pPr>
+            <a:r>
+              <a:rPr sz="1900" b="0" i="0">
+                <a:solidFill>
+                  <a:srgbClr val="E3E9F5"/>
+                </a:solidFill>
+                <a:latin typeface="Arial"/>
+              </a:rPr>
+              <a:t>Our numbers land in the same range and order as the original paper's</a:t>
+            </a:r>
+          </a:p>
+        </p:txBody>
+      </p:sp>
+      <p:sp>
+        <p:nvSpPr>
+          <p:cNvPr id="14" name="Oval 13"/>
+          <p:cNvSpPr/>
+          <p:nvPr/>
+        </p:nvSpPr>
+        <p:spPr>
+          <a:xfrm>
+            <a:off x="822960" y="4297680"/>
+            <a:ext cx="292608" cy="292608"/>
+          </a:xfrm>
+          <a:prstGeom prst="ellipse">
+            <a:avLst/>
+          </a:prstGeom>
+          <a:solidFill>
+            <a:srgbClr val="8FB4FF"/>
+          </a:solidFill>
+          <a:ln>
+            <a:noFill/>
+          </a:ln>
+          <a:effectLst/>
+        </p:spPr>
+        <p:style>
+          <a:lnRef idx="1">
+            <a:schemeClr val="accent1"/>
+          </a:lnRef>
+          <a:fillRef idx="3">
+            <a:schemeClr val="accent1"/>
+          </a:fillRef>
+          <a:effectRef idx="2">
+            <a:schemeClr val="accent1"/>
+          </a:effectRef>
+          <a:fontRef idx="minor">
+            <a:schemeClr val="lt1"/>
+          </a:fontRef>
+        </p:style>
+        <p:txBody>
+          <a:bodyPr rtlCol="0" anchor="ctr" wrap="none"/>
+          <a:lstStyle/>
+          <a:p>
+            <a:pPr algn="ctr"/>
+            <a:r>
+              <a:rPr sz="1300" b="1">
+                <a:solidFill>
+                  <a:srgbClr val="142340"/>
+                </a:solidFill>
+                <a:latin typeface="Arial"/>
+              </a:rPr>
+              <a:t>✓</a:t>
+            </a:r>
+          </a:p>
+        </p:txBody>
+      </p:sp>
+      <p:sp>
+        <p:nvSpPr>
+          <p:cNvPr id="15" name="TextBox 14"/>
+          <p:cNvSpPr txBox="1"/>
+          <p:nvPr/>
+        </p:nvSpPr>
+        <p:spPr>
+          <a:xfrm>
+            <a:off x="1280160" y="4270248"/>
+            <a:ext cx="9784080" cy="548640"/>
+          </a:xfrm>
+          <a:prstGeom prst="rect">
+            <a:avLst/>
+          </a:prstGeom>
+          <a:noFill/>
+        </p:spPr>
+        <p:txBody>
+          <a:bodyPr wrap="square">
+            <a:spAutoFit/>
+          </a:bodyPr>
+          <a:lstStyle/>
+          <a:p>
+            <a:pPr algn="l">
+              <a:lnSpc>
+                <a:spcPct val="115000"/>
+              </a:lnSpc>
+            </a:pPr>
+            <a:r>
+              <a:rPr sz="1900" b="0" i="0">
+                <a:solidFill>
+                  <a:srgbClr val="E3E9F5"/>
+                </a:solidFill>
+                <a:latin typeface="Arial"/>
+              </a:rPr>
+              <a:t>BERT not replicated — paper's own attempt ran out of memory, no baseline to match</a:t>
+            </a:r>
+          </a:p>
+        </p:txBody>
+      </p:sp>
+      <p:sp>
+        <p:nvSpPr>
+          <p:cNvPr id="16" name="TextBox 15"/>
+          <p:cNvSpPr txBox="1"/>
+          <p:nvPr/>
+        </p:nvSpPr>
+        <p:spPr>
+          <a:xfrm>
+            <a:off x="822960" y="6309360"/>
+            <a:ext cx="6400800" cy="365760"/>
+          </a:xfrm>
+          <a:prstGeom prst="rect">
+            <a:avLst/>
+          </a:prstGeom>
+          <a:noFill/>
+        </p:spPr>
+        <p:txBody>
+          <a:bodyPr wrap="square">
+            <a:spAutoFit/>
+          </a:bodyPr>
+          <a:lstStyle/>
+          <a:p>
+            <a:pPr algn="l">
+              <a:lnSpc>
+                <a:spcPct val="110000"/>
+              </a:lnSpc>
+            </a:pPr>
+            <a:r>
+              <a:rPr sz="1300" b="0" i="0">
+                <a:solidFill>
+                  <a:srgbClr val="8FB4FF"/>
+                </a:solidFill>
+                <a:latin typeface="Arial"/>
+              </a:rPr>
+              <a:t>github.com/amogh-herle/ML-MINI-PROJECT</a:t>
+            </a:r>
+          </a:p>
+        </p:txBody>
+      </p:sp>
+      <p:sp>
+        <p:nvSpPr>
+          <p:cNvPr id="17" name="TextBox 16"/>
+          <p:cNvSpPr txBox="1"/>
+          <p:nvPr/>
+        </p:nvSpPr>
+        <p:spPr>
+          <a:xfrm>
+            <a:off x="9601200" y="6309360"/>
+            <a:ext cx="1828800" cy="365760"/>
+          </a:xfrm>
+          <a:prstGeom prst="rect">
+            <a:avLst/>
+          </a:prstGeom>
+          <a:noFill/>
+        </p:spPr>
+        <p:txBody>
+          <a:bodyPr wrap="square">
+            <a:spAutoFit/>
+          </a:bodyPr>
+          <a:lstStyle/>
+          <a:p>
+            <a:pPr algn="l">
+              <a:lnSpc>
+                <a:spcPct val="110000"/>
+              </a:lnSpc>
+            </a:pPr>
+            <a:r>
+              <a:rPr sz="1300" b="0" i="0">
+                <a:solidFill>
+                  <a:srgbClr val="6E85AD"/>
+                </a:solidFill>
+                <a:latin typeface="Arial"/>
+              </a:rPr>
+              <a:t>9 / 9</a:t>
+            </a:r>
+          </a:p>
+        </p:txBody>
+      </p:sp>
+    </p:spTree>
+  </p:cSld>
+  <p:clrMapOvr>
+    <a:masterClrMapping/>
+  </p:clrMapOvr>
+</p:sld>
+</file>
+
 <file path=ppt/slides/slide2.xml><?xml version="1.0" encoding="utf-8"?>
 <p:sld xmlns:a="http://schemas.openxmlformats.org/drawingml/2006/main" xmlns:p="http://schemas.openxmlformats.org/presentationml/2006/main" xmlns:r="http://schemas.openxmlformats.org/officeDocument/2006/relationships">
   <p:cSld>
@@ -4758,7 +5490,60 @@
       </p:sp>
       <p:sp>
         <p:nvSpPr>
-          <p:cNvPr id="7" name="Rectangle 6"/>
+          <p:cNvPr id="7" name="Oval 6"/>
+          <p:cNvSpPr/>
+          <p:nvPr/>
+        </p:nvSpPr>
+        <p:spPr>
+          <a:xfrm>
+            <a:off x="822959" y="1828800"/>
+            <a:ext cx="457200" cy="457200"/>
+          </a:xfrm>
+          <a:prstGeom prst="ellipse">
+            <a:avLst/>
+          </a:prstGeom>
+          <a:solidFill>
+            <a:srgbClr val="B3261E"/>
+          </a:solidFill>
+          <a:ln>
+            <a:noFill/>
+          </a:ln>
+          <a:effectLst/>
+        </p:spPr>
+        <p:style>
+          <a:lnRef idx="1">
+            <a:schemeClr val="accent1"/>
+          </a:lnRef>
+          <a:fillRef idx="3">
+            <a:schemeClr val="accent1"/>
+          </a:fillRef>
+          <a:effectRef idx="2">
+            <a:schemeClr val="accent1"/>
+          </a:effectRef>
+          <a:fontRef idx="minor">
+            <a:schemeClr val="lt1"/>
+          </a:fontRef>
+        </p:style>
+        <p:txBody>
+          <a:bodyPr rtlCol="0" anchor="ctr" wrap="none"/>
+          <a:lstStyle/>
+          <a:p>
+            <a:pPr algn="ctr"/>
+            <a:r>
+              <a:rPr sz="2200" b="1">
+                <a:solidFill>
+                  <a:srgbClr val="FBFBF8"/>
+                </a:solidFill>
+                <a:latin typeface="Arial"/>
+              </a:rPr>
+              <a:t>Σ</a:t>
+            </a:r>
+          </a:p>
+        </p:txBody>
+      </p:sp>
+      <p:sp>
+        <p:nvSpPr>
+          <p:cNvPr id="8" name="Rectangle 7"/>
           <p:cNvSpPr/>
           <p:nvPr/>
         </p:nvSpPr>
@@ -4833,7 +5618,7 @@
       </p:sp>
       <p:sp>
         <p:nvSpPr>
-          <p:cNvPr id="8" name="Rectangle 7"/>
+          <p:cNvPr id="9" name="Rectangle 8"/>
           <p:cNvSpPr/>
           <p:nvPr/>
         </p:nvSpPr>
@@ -4877,7 +5662,60 @@
       </p:sp>
       <p:sp>
         <p:nvSpPr>
-          <p:cNvPr id="9" name="TextBox 8"/>
+          <p:cNvPr id="10" name="Oval 9"/>
+          <p:cNvSpPr/>
+          <p:nvPr/>
+        </p:nvSpPr>
+        <p:spPr>
+          <a:xfrm>
+            <a:off x="6035040" y="1828800"/>
+            <a:ext cx="457200" cy="457200"/>
+          </a:xfrm>
+          <a:prstGeom prst="ellipse">
+            <a:avLst/>
+          </a:prstGeom>
+          <a:solidFill>
+            <a:srgbClr val="1E7A3D"/>
+          </a:solidFill>
+          <a:ln>
+            <a:noFill/>
+          </a:ln>
+          <a:effectLst/>
+        </p:spPr>
+        <p:style>
+          <a:lnRef idx="1">
+            <a:schemeClr val="accent1"/>
+          </a:lnRef>
+          <a:fillRef idx="3">
+            <a:schemeClr val="accent1"/>
+          </a:fillRef>
+          <a:effectRef idx="2">
+            <a:schemeClr val="accent1"/>
+          </a:effectRef>
+          <a:fontRef idx="minor">
+            <a:schemeClr val="lt1"/>
+          </a:fontRef>
+        </p:style>
+        <p:txBody>
+          <a:bodyPr rtlCol="0" anchor="ctr" wrap="none"/>
+          <a:lstStyle/>
+          <a:p>
+            <a:pPr algn="ctr"/>
+            <a:r>
+              <a:rPr sz="2000" b="1">
+                <a:solidFill>
+                  <a:srgbClr val="FBFBF8"/>
+                </a:solidFill>
+                <a:latin typeface="Arial"/>
+              </a:rPr>
+              <a:t>⌘</a:t>
+            </a:r>
+          </a:p>
+        </p:txBody>
+      </p:sp>
+      <p:sp>
+        <p:nvSpPr>
+          <p:cNvPr id="11" name="TextBox 10"/>
           <p:cNvSpPr txBox="1"/>
           <p:nvPr/>
         </p:nvSpPr>
@@ -4916,7 +5754,7 @@
       </p:sp>
       <p:sp>
         <p:nvSpPr>
-          <p:cNvPr id="10" name="TextBox 9"/>
+          <p:cNvPr id="12" name="TextBox 11"/>
           <p:cNvSpPr txBox="1"/>
           <p:nvPr/>
         </p:nvSpPr>
@@ -7245,7 +8083,7 @@
         <p:spPr>
           <a:xfrm>
             <a:off x="822960" y="868680"/>
-            <a:ext cx="10515600" cy="822960"/>
+            <a:ext cx="10515600" cy="640080"/>
           </a:xfrm>
           <a:prstGeom prst="rect">
             <a:avLst/>
@@ -7275,80 +8113,30 @@
           </a:p>
         </p:txBody>
       </p:sp>
-      <p:sp>
-        <p:nvSpPr>
-          <p:cNvPr id="5" name="Rectangle 4"/>
-          <p:cNvSpPr/>
-          <p:nvPr/>
-        </p:nvSpPr>
-        <p:spPr>
-          <a:xfrm>
-            <a:off x="822960" y="1828800"/>
-            <a:ext cx="5029200" cy="3108960"/>
+      <p:pic>
+        <p:nvPicPr>
+          <p:cNvPr id="5" name="Picture 4" descr="per_category_f1.png"/>
+          <p:cNvPicPr>
+            <a:picLocks noChangeAspect="1"/>
+          </p:cNvPicPr>
+          <p:nvPr/>
+        </p:nvPicPr>
+        <p:blipFill>
+          <a:blip r:embed="rId2"/>
+          <a:stretch>
+            <a:fillRect/>
+          </a:stretch>
+        </p:blipFill>
+        <p:spPr>
+          <a:xfrm>
+            <a:off x="1984248" y="1600200"/>
+            <a:ext cx="8229600" cy="4114800"/>
           </a:xfrm>
           <a:prstGeom prst="rect">
             <a:avLst/>
           </a:prstGeom>
-          <a:solidFill>
-            <a:srgbClr val="FFFFFF"/>
-          </a:solidFill>
-          <a:ln w="12700">
-            <a:solidFill>
-              <a:srgbClr val="E3E6E4"/>
-            </a:solidFill>
-          </a:ln>
-          <a:effectLst/>
-        </p:spPr>
-        <p:style>
-          <a:lnRef idx="1">
-            <a:schemeClr val="accent1"/>
-          </a:lnRef>
-          <a:fillRef idx="3">
-            <a:schemeClr val="accent1"/>
-          </a:fillRef>
-          <a:effectRef idx="2">
-            <a:schemeClr val="accent1"/>
-          </a:effectRef>
-          <a:fontRef idx="minor">
-            <a:schemeClr val="lt1"/>
-          </a:fontRef>
-        </p:style>
-        <p:txBody>
-          <a:bodyPr rtlCol="0" anchor="ctr" wrap="square" lIns="274320" rIns="274320" tIns="228600" bIns="228600"/>
-          <a:lstStyle/>
-          <a:p>
-            <a:pPr algn="ctr"/>
-            <a:r>
-              <a:rPr sz="2000" b="1">
-                <a:solidFill>
-                  <a:srgbClr val="B3261E"/>
-                </a:solidFill>
-                <a:latin typeface="Arial"/>
-              </a:rPr>
-              <a:t>LDA</a:t>
-            </a:r>
-          </a:p>
-          <a:p>
-            <a:pPr>
-              <a:lnSpc>
-                <a:spcPct val="115000"/>
-              </a:lnSpc>
-              <a:spcBef>
-                <a:spcPts val="800"/>
-              </a:spcBef>
-            </a:pPr>
-            <a:r>
-              <a:rPr sz="1400">
-                <a:solidFill>
-                  <a:srgbClr val="4A5568"/>
-                </a:solidFill>
-                <a:latin typeface="Arial"/>
-              </a:rPr>
-              <a:t>Macro-F1 (0.267) trails accuracy (48.7%) badly — it defaults to the two biggest categories (Criminal Procedure, Economic Activity) and misses rare ones almost entirely (Privacy, Attorneys, Interstate Relations: near 0 recall).</a:t>
-            </a:r>
-          </a:p>
-        </p:txBody>
-      </p:sp>
+        </p:spPr>
+      </p:pic>
       <p:sp>
         <p:nvSpPr>
           <p:cNvPr id="6" name="Rectangle 5"/>
@@ -7357,8 +8145,8 @@
         </p:nvSpPr>
         <p:spPr>
           <a:xfrm>
-            <a:off x="822960" y="1828800"/>
-            <a:ext cx="5029200" cy="54864"/>
+            <a:off x="1188720" y="5870448"/>
+            <a:ext cx="201168" cy="201168"/>
           </a:xfrm>
           <a:prstGeom prst="rect">
             <a:avLst/>
@@ -7395,74 +8183,39 @@
       </p:sp>
       <p:sp>
         <p:nvSpPr>
-          <p:cNvPr id="7" name="Rectangle 6"/>
-          <p:cNvSpPr/>
-          <p:nvPr/>
-        </p:nvSpPr>
-        <p:spPr>
-          <a:xfrm>
-            <a:off x="6035040" y="1828800"/>
-            <a:ext cx="5120640" cy="3108960"/>
+          <p:cNvPr id="7" name="TextBox 6"/>
+          <p:cNvSpPr txBox="1"/>
+          <p:nvPr/>
+        </p:nvSpPr>
+        <p:spPr>
+          <a:xfrm>
+            <a:off x="1508760" y="5797296"/>
+            <a:ext cx="4572000" cy="365760"/>
           </a:xfrm>
           <a:prstGeom prst="rect">
             <a:avLst/>
           </a:prstGeom>
-          <a:solidFill>
-            <a:srgbClr val="FFFFFF"/>
-          </a:solidFill>
-          <a:ln w="12700">
-            <a:solidFill>
-              <a:srgbClr val="E3E6E4"/>
-            </a:solidFill>
-          </a:ln>
-          <a:effectLst/>
-        </p:spPr>
-        <p:style>
-          <a:lnRef idx="1">
-            <a:schemeClr val="accent1"/>
-          </a:lnRef>
-          <a:fillRef idx="3">
-            <a:schemeClr val="accent1"/>
-          </a:fillRef>
-          <a:effectRef idx="2">
-            <a:schemeClr val="accent1"/>
-          </a:effectRef>
-          <a:fontRef idx="minor">
-            <a:schemeClr val="lt1"/>
-          </a:fontRef>
-        </p:style>
-        <p:txBody>
-          <a:bodyPr rtlCol="0" anchor="ctr" wrap="square" lIns="274320" rIns="274320" tIns="228600" bIns="228600"/>
-          <a:lstStyle/>
-          <a:p>
-            <a:pPr algn="ctr"/>
-            <a:r>
-              <a:rPr sz="2000" b="1">
-                <a:solidFill>
-                  <a:srgbClr val="1E7A3D"/>
+          <a:noFill/>
+        </p:spPr>
+        <p:txBody>
+          <a:bodyPr wrap="square">
+            <a:spAutoFit/>
+          </a:bodyPr>
+          <a:lstStyle/>
+          <a:p>
+            <a:pPr algn="l">
+              <a:lnSpc>
+                <a:spcPct val="110000"/>
+              </a:lnSpc>
+            </a:pPr>
+            <a:r>
+              <a:rPr sz="1200" b="0" i="0">
+                <a:solidFill>
+                  <a:srgbClr val="4A5568"/>
                 </a:solidFill>
                 <a:latin typeface="Arial"/>
               </a:rPr>
-              <a:t>Doc2Vec</a:t>
-            </a:r>
-          </a:p>
-          <a:p>
-            <a:pPr>
-              <a:lnSpc>
-                <a:spcPct val="115000"/>
-              </a:lnSpc>
-              <a:spcBef>
-                <a:spcPts val="800"/>
-              </a:spcBef>
-            </a:pPr>
-            <a:r>
-              <a:rPr sz="1400">
-                <a:solidFill>
-                  <a:srgbClr val="4A5568"/>
-                </a:solidFill>
-                <a:latin typeface="Arial"/>
-              </a:rPr>
-              <a:t>Far more balanced — still finds minority categories like Privacy (F1 0.26) and Attorneys (F1 0.31) that LDA completely misses, because it reads context, not just word counts.</a:t>
+              <a:t>LDA — collapses on rare categories (near-0 F1 on Privacy, Attorneys)</a:t>
             </a:r>
           </a:p>
         </p:txBody>
@@ -7475,8 +8228,8 @@
         </p:nvSpPr>
         <p:spPr>
           <a:xfrm>
-            <a:off x="6035040" y="1828800"/>
-            <a:ext cx="5120640" cy="54864"/>
+            <a:off x="6400800" y="5870448"/>
+            <a:ext cx="201168" cy="201168"/>
           </a:xfrm>
           <a:prstGeom prst="rect">
             <a:avLst/>
@@ -7519,8 +8272,8 @@
         </p:nvSpPr>
         <p:spPr>
           <a:xfrm>
-            <a:off x="822960" y="5166360"/>
-            <a:ext cx="10241280" cy="457200"/>
+            <a:off x="6720840" y="5797296"/>
+            <a:ext cx="4572000" cy="365760"/>
           </a:xfrm>
           <a:prstGeom prst="rect">
             <a:avLst/>
@@ -7539,13 +8292,13 @@
               </a:lnSpc>
             </a:pPr>
             <a:r>
-              <a:rPr sz="1300" b="0" i="0">
-                <a:solidFill>
-                  <a:srgbClr val="6A7179"/>
+              <a:rPr sz="1200" b="0" i="0">
+                <a:solidFill>
+                  <a:srgbClr val="4A5568"/>
                 </a:solidFill>
                 <a:latin typeface="Arial"/>
               </a:rPr>
-              <a:t>Same pattern the original paper reports on its own category breakdown.</a:t>
+              <a:t>Doc2Vec — far more balanced across all 13 categories</a:t>
             </a:r>
           </a:p>
         </p:txBody>
@@ -7622,7 +8375,7 @@
             <a:avLst/>
           </a:prstGeom>
           <a:solidFill>
-            <a:srgbClr val="142340"/>
+            <a:srgbClr val="FBFBF8"/>
           </a:solidFill>
           <a:ln>
             <a:noFill/>
@@ -7681,31 +8434,94 @@
             <a:r>
               <a:rPr sz="1400" b="1" i="0">
                 <a:solidFill>
-                  <a:srgbClr val="8FB4FF"/>
+                  <a:srgbClr val="2A5CAA"/>
                 </a:solidFill>
                 <a:latin typeface="Arial"/>
               </a:rPr>
-              <a:t>CONCLUSIONS</a:t>
-            </a:r>
-          </a:p>
-        </p:txBody>
-      </p:sp>
-      <p:sp>
-        <p:nvSpPr>
-          <p:cNvPr id="4" name="Oval 3"/>
+              <a:t>PUTTING IT TOGETHER</a:t>
+            </a:r>
+          </a:p>
+        </p:txBody>
+      </p:sp>
+      <p:sp>
+        <p:nvSpPr>
+          <p:cNvPr id="4" name="TextBox 3"/>
+          <p:cNvSpPr txBox="1"/>
+          <p:nvPr/>
+        </p:nvSpPr>
+        <p:spPr>
+          <a:xfrm>
+            <a:off x="822960" y="868680"/>
+            <a:ext cx="10515600" cy="822960"/>
+          </a:xfrm>
+          <a:prstGeom prst="rect">
+            <a:avLst/>
+          </a:prstGeom>
+          <a:noFill/>
+        </p:spPr>
+        <p:txBody>
+          <a:bodyPr wrap="square">
+            <a:spAutoFit/>
+          </a:bodyPr>
+          <a:lstStyle/>
+          <a:p>
+            <a:pPr algn="l">
+              <a:lnSpc>
+                <a:spcPct val="110000"/>
+              </a:lnSpc>
+            </a:pPr>
+            <a:r>
+              <a:rPr sz="2800" b="1" i="0">
+                <a:solidFill>
+                  <a:srgbClr val="1A1A1A"/>
+                </a:solidFill>
+                <a:latin typeface="Arial"/>
+              </a:rPr>
+              <a:t>Each phase pushed the best model further</a:t>
+            </a:r>
+          </a:p>
+        </p:txBody>
+      </p:sp>
+      <p:pic>
+        <p:nvPicPr>
+          <p:cNvPr id="5" name="Picture 4" descr="progress_by_phase.png"/>
+          <p:cNvPicPr>
+            <a:picLocks noChangeAspect="1"/>
+          </p:cNvPicPr>
+          <p:nvPr/>
+        </p:nvPicPr>
+        <p:blipFill>
+          <a:blip r:embed="rId2"/>
+          <a:stretch>
+            <a:fillRect/>
+          </a:stretch>
+        </p:blipFill>
+        <p:spPr>
+          <a:xfrm>
+            <a:off x="822960" y="1828800"/>
+            <a:ext cx="5486400" cy="3771900"/>
+          </a:xfrm>
+          <a:prstGeom prst="rect">
+            <a:avLst/>
+          </a:prstGeom>
+        </p:spPr>
+      </p:pic>
+      <p:sp>
+        <p:nvSpPr>
+          <p:cNvPr id="6" name="Oval 5"/>
           <p:cNvSpPr/>
           <p:nvPr/>
         </p:nvSpPr>
         <p:spPr>
           <a:xfrm>
-            <a:off x="822960" y="1463040"/>
+            <a:off x="6675120" y="2377440"/>
             <a:ext cx="292608" cy="292608"/>
           </a:xfrm>
           <a:prstGeom prst="ellipse">
             <a:avLst/>
           </a:prstGeom>
           <a:solidFill>
-            <a:srgbClr val="8FB4FF"/>
+            <a:srgbClr val="2A5CAA"/>
           </a:solidFill>
           <a:ln>
             <a:noFill/>
@@ -7745,14 +8561,14 @@
       </p:sp>
       <p:sp>
         <p:nvSpPr>
-          <p:cNvPr id="5" name="TextBox 4"/>
+          <p:cNvPr id="7" name="TextBox 6"/>
           <p:cNvSpPr txBox="1"/>
           <p:nvPr/>
         </p:nvSpPr>
         <p:spPr>
           <a:xfrm>
-            <a:off x="1280160" y="1435608"/>
-            <a:ext cx="9784080" cy="548640"/>
+            <a:off x="7132320" y="2350008"/>
+            <a:ext cx="4206240" cy="548640"/>
           </a:xfrm>
           <a:prstGeom prst="rect">
             <a:avLst/>
@@ -7771,33 +8587,33 @@
               </a:lnSpc>
             </a:pPr>
             <a:r>
-              <a:rPr sz="1900" b="0" i="0">
-                <a:solidFill>
-                  <a:srgbClr val="E3E9F5"/>
+              <a:rPr sz="1500" b="0" i="0">
+                <a:solidFill>
+                  <a:srgbClr val="1A1A1A"/>
                 </a:solidFill>
                 <a:latin typeface="Arial"/>
               </a:rPr>
-              <a:t>Doc2Vec embeddings consistently beat LDA topic features on this task</a:t>
-            </a:r>
-          </a:p>
-        </p:txBody>
-      </p:sp>
-      <p:sp>
-        <p:nvSpPr>
-          <p:cNvPr id="6" name="Oval 5"/>
+              <a:t>Phase 1: Doc2Vec + Logistic Regression, paper's default settings — 59.1%</a:t>
+            </a:r>
+          </a:p>
+        </p:txBody>
+      </p:sp>
+      <p:sp>
+        <p:nvSpPr>
+          <p:cNvPr id="8" name="Oval 7"/>
           <p:cNvSpPr/>
           <p:nvPr/>
         </p:nvSpPr>
         <p:spPr>
           <a:xfrm>
-            <a:off x="822960" y="2029968"/>
+            <a:off x="6675120" y="2944368"/>
             <a:ext cx="292608" cy="292608"/>
           </a:xfrm>
           <a:prstGeom prst="ellipse">
             <a:avLst/>
           </a:prstGeom>
           <a:solidFill>
-            <a:srgbClr val="8FB4FF"/>
+            <a:srgbClr val="2A5CAA"/>
           </a:solidFill>
           <a:ln>
             <a:noFill/>
@@ -7837,14 +8653,14 @@
       </p:sp>
       <p:sp>
         <p:nvSpPr>
-          <p:cNvPr id="7" name="TextBox 6"/>
+          <p:cNvPr id="9" name="TextBox 8"/>
           <p:cNvSpPr txBox="1"/>
           <p:nvPr/>
         </p:nvSpPr>
         <p:spPr>
           <a:xfrm>
-            <a:off x="1280160" y="2002536"/>
-            <a:ext cx="9784080" cy="548640"/>
+            <a:off x="7132320" y="2916936"/>
+            <a:ext cx="4206240" cy="548640"/>
           </a:xfrm>
           <a:prstGeom prst="rect">
             <a:avLst/>
@@ -7863,33 +8679,33 @@
               </a:lnSpc>
             </a:pPr>
             <a:r>
-              <a:rPr sz="1900" b="0" i="0">
-                <a:solidFill>
-                  <a:srgbClr val="E3E9F5"/>
+              <a:rPr sz="1500" b="0" i="0">
+                <a:solidFill>
+                  <a:srgbClr val="1A1A1A"/>
                 </a:solidFill>
                 <a:latin typeface="Arial"/>
               </a:rPr>
-              <a:t>Coarse 15-category task is much easier than the 260+-category one</a:t>
-            </a:r>
-          </a:p>
-        </p:txBody>
-      </p:sp>
-      <p:sp>
-        <p:nvSpPr>
-          <p:cNvPr id="8" name="Oval 7"/>
+              <a:t>Phase 2: tuned vector_size (100→50) and C on dev only — 62.2%</a:t>
+            </a:r>
+          </a:p>
+        </p:txBody>
+      </p:sp>
+      <p:sp>
+        <p:nvSpPr>
+          <p:cNvPr id="10" name="Oval 9"/>
           <p:cNvSpPr/>
           <p:nvPr/>
         </p:nvSpPr>
         <p:spPr>
           <a:xfrm>
-            <a:off x="822960" y="2596896"/>
+            <a:off x="6675120" y="3511296"/>
             <a:ext cx="292608" cy="292608"/>
           </a:xfrm>
           <a:prstGeom prst="ellipse">
             <a:avLst/>
           </a:prstGeom>
           <a:solidFill>
-            <a:srgbClr val="8FB4FF"/>
+            <a:srgbClr val="2A5CAA"/>
           </a:solidFill>
           <a:ln>
             <a:noFill/>
@@ -7929,14 +8745,14 @@
       </p:sp>
       <p:sp>
         <p:nvSpPr>
-          <p:cNvPr id="9" name="TextBox 8"/>
+          <p:cNvPr id="11" name="TextBox 10"/>
           <p:cNvSpPr txBox="1"/>
           <p:nvPr/>
         </p:nvSpPr>
         <p:spPr>
           <a:xfrm>
-            <a:off x="1280160" y="2569464"/>
-            <a:ext cx="9784080" cy="548640"/>
+            <a:off x="7132320" y="3483864"/>
+            <a:ext cx="4206240" cy="548640"/>
           </a:xfrm>
           <a:prstGeom prst="rect">
             <a:avLst/>
@@ -7955,80 +8771,27 @@
               </a:lnSpc>
             </a:pPr>
             <a:r>
-              <a:rPr sz="1900" b="0" i="0">
-                <a:solidFill>
-                  <a:srgbClr val="E3E9F5"/>
+              <a:rPr sz="1500" b="0" i="0">
+                <a:solidFill>
+                  <a:srgbClr val="1A1A1A"/>
                 </a:solidFill>
                 <a:latin typeface="Arial"/>
               </a:rPr>
-              <a:t>Tuning hyperparameters gave real gains everywhere (not just marginal)</a:t>
-            </a:r>
-          </a:p>
-        </p:txBody>
-      </p:sp>
-      <p:sp>
-        <p:nvSpPr>
-          <p:cNvPr id="10" name="Oval 9"/>
-          <p:cNvSpPr/>
-          <p:nvPr/>
-        </p:nvSpPr>
-        <p:spPr>
-          <a:xfrm>
-            <a:off x="822960" y="3163824"/>
-            <a:ext cx="292608" cy="292608"/>
-          </a:xfrm>
-          <a:prstGeom prst="ellipse">
-            <a:avLst/>
-          </a:prstGeom>
-          <a:solidFill>
-            <a:srgbClr val="8FB4FF"/>
-          </a:solidFill>
-          <a:ln>
-            <a:noFill/>
-          </a:ln>
-          <a:effectLst/>
-        </p:spPr>
-        <p:style>
-          <a:lnRef idx="1">
-            <a:schemeClr val="accent1"/>
-          </a:lnRef>
-          <a:fillRef idx="3">
-            <a:schemeClr val="accent1"/>
-          </a:fillRef>
-          <a:effectRef idx="2">
-            <a:schemeClr val="accent1"/>
-          </a:effectRef>
-          <a:fontRef idx="minor">
-            <a:schemeClr val="lt1"/>
-          </a:fontRef>
-        </p:style>
-        <p:txBody>
-          <a:bodyPr rtlCol="0" anchor="ctr" wrap="none"/>
-          <a:lstStyle/>
-          <a:p>
-            <a:pPr algn="ctr"/>
-            <a:r>
-              <a:rPr sz="1300" b="1">
-                <a:solidFill>
-                  <a:srgbClr val="142340"/>
-                </a:solidFill>
-                <a:latin typeface="Arial"/>
-              </a:rPr>
-              <a:t>✓</a:t>
-            </a:r>
-          </a:p>
-        </p:txBody>
-      </p:sp>
-      <p:sp>
-        <p:nvSpPr>
-          <p:cNvPr id="11" name="TextBox 10"/>
+              <a:t>Phase 3: swapped in SVM (RBF kernel) on the same features — 68.8%</a:t>
+            </a:r>
+          </a:p>
+        </p:txBody>
+      </p:sp>
+      <p:sp>
+        <p:nvSpPr>
+          <p:cNvPr id="12" name="TextBox 11"/>
           <p:cNvSpPr txBox="1"/>
           <p:nvPr/>
         </p:nvSpPr>
         <p:spPr>
           <a:xfrm>
-            <a:off x="1280160" y="3136392"/>
-            <a:ext cx="9784080" cy="548640"/>
+            <a:off x="6675120" y="4846320"/>
+            <a:ext cx="4663440" cy="1097280"/>
           </a:xfrm>
           <a:prstGeom prst="rect">
             <a:avLst/>
@@ -8043,70 +8806,17 @@
           <a:p>
             <a:pPr algn="l">
               <a:lnSpc>
-                <a:spcPct val="115000"/>
+                <a:spcPct val="130000"/>
               </a:lnSpc>
             </a:pPr>
             <a:r>
-              <a:rPr sz="1900" b="0" i="0">
-                <a:solidFill>
-                  <a:srgbClr val="E3E9F5"/>
+              <a:rPr sz="1400" b="0" i="1">
+                <a:solidFill>
+                  <a:srgbClr val="4A5568"/>
                 </a:solidFill>
                 <a:latin typeface="Arial"/>
               </a:rPr>
-              <a:t>SVM beat every classifier on Doc2Vec issue_area (on LDA ~level with LR: 49.1 vs 48.7%)</a:t>
-            </a:r>
-          </a:p>
-        </p:txBody>
-      </p:sp>
-      <p:sp>
-        <p:nvSpPr>
-          <p:cNvPr id="12" name="Oval 11"/>
-          <p:cNvSpPr/>
-          <p:nvPr/>
-        </p:nvSpPr>
-        <p:spPr>
-          <a:xfrm>
-            <a:off x="822960" y="3730752"/>
-            <a:ext cx="292608" cy="292608"/>
-          </a:xfrm>
-          <a:prstGeom prst="ellipse">
-            <a:avLst/>
-          </a:prstGeom>
-          <a:solidFill>
-            <a:srgbClr val="8FB4FF"/>
-          </a:solidFill>
-          <a:ln>
-            <a:noFill/>
-          </a:ln>
-          <a:effectLst/>
-        </p:spPr>
-        <p:style>
-          <a:lnRef idx="1">
-            <a:schemeClr val="accent1"/>
-          </a:lnRef>
-          <a:fillRef idx="3">
-            <a:schemeClr val="accent1"/>
-          </a:fillRef>
-          <a:effectRef idx="2">
-            <a:schemeClr val="accent1"/>
-          </a:effectRef>
-          <a:fontRef idx="minor">
-            <a:schemeClr val="lt1"/>
-          </a:fontRef>
-        </p:style>
-        <p:txBody>
-          <a:bodyPr rtlCol="0" anchor="ctr" wrap="none"/>
-          <a:lstStyle/>
-          <a:p>
-            <a:pPr algn="ctr"/>
-            <a:r>
-              <a:rPr sz="1300" b="1">
-                <a:solidFill>
-                  <a:srgbClr val="142340"/>
-                </a:solidFill>
-                <a:latin typeface="Arial"/>
-              </a:rPr>
-              <a:t>✓</a:t>
+              <a:t>Nearly 10 points of accuracy gained beyond the paper's own result, without touching the dataset.</a:t>
             </a:r>
           </a:p>
         </p:txBody>
@@ -8119,139 +8829,8 @@
         </p:nvSpPr>
         <p:spPr>
           <a:xfrm>
-            <a:off x="1280160" y="3703320"/>
-            <a:ext cx="9784080" cy="548640"/>
-          </a:xfrm>
-          <a:prstGeom prst="rect">
-            <a:avLst/>
-          </a:prstGeom>
-          <a:noFill/>
-        </p:spPr>
-        <p:txBody>
-          <a:bodyPr wrap="square">
-            <a:spAutoFit/>
-          </a:bodyPr>
-          <a:lstStyle/>
-          <a:p>
-            <a:pPr algn="l">
-              <a:lnSpc>
-                <a:spcPct val="115000"/>
-              </a:lnSpc>
-            </a:pPr>
-            <a:r>
-              <a:rPr sz="1900" b="0" i="0">
-                <a:solidFill>
-                  <a:srgbClr val="E3E9F5"/>
-                </a:solidFill>
-                <a:latin typeface="Arial"/>
-              </a:rPr>
-              <a:t>Our numbers land in the same range and order as the original paper's</a:t>
-            </a:r>
-          </a:p>
-        </p:txBody>
-      </p:sp>
-      <p:sp>
-        <p:nvSpPr>
-          <p:cNvPr id="14" name="Oval 13"/>
-          <p:cNvSpPr/>
-          <p:nvPr/>
-        </p:nvSpPr>
-        <p:spPr>
-          <a:xfrm>
-            <a:off x="822960" y="4297680"/>
-            <a:ext cx="292608" cy="292608"/>
-          </a:xfrm>
-          <a:prstGeom prst="ellipse">
-            <a:avLst/>
-          </a:prstGeom>
-          <a:solidFill>
-            <a:srgbClr val="8FB4FF"/>
-          </a:solidFill>
-          <a:ln>
-            <a:noFill/>
-          </a:ln>
-          <a:effectLst/>
-        </p:spPr>
-        <p:style>
-          <a:lnRef idx="1">
-            <a:schemeClr val="accent1"/>
-          </a:lnRef>
-          <a:fillRef idx="3">
-            <a:schemeClr val="accent1"/>
-          </a:fillRef>
-          <a:effectRef idx="2">
-            <a:schemeClr val="accent1"/>
-          </a:effectRef>
-          <a:fontRef idx="minor">
-            <a:schemeClr val="lt1"/>
-          </a:fontRef>
-        </p:style>
-        <p:txBody>
-          <a:bodyPr rtlCol="0" anchor="ctr" wrap="none"/>
-          <a:lstStyle/>
-          <a:p>
-            <a:pPr algn="ctr"/>
-            <a:r>
-              <a:rPr sz="1300" b="1">
-                <a:solidFill>
-                  <a:srgbClr val="142340"/>
-                </a:solidFill>
-                <a:latin typeface="Arial"/>
-              </a:rPr>
-              <a:t>✓</a:t>
-            </a:r>
-          </a:p>
-        </p:txBody>
-      </p:sp>
-      <p:sp>
-        <p:nvSpPr>
-          <p:cNvPr id="15" name="TextBox 14"/>
-          <p:cNvSpPr txBox="1"/>
-          <p:nvPr/>
-        </p:nvSpPr>
-        <p:spPr>
-          <a:xfrm>
-            <a:off x="1280160" y="4270248"/>
-            <a:ext cx="9784080" cy="548640"/>
-          </a:xfrm>
-          <a:prstGeom prst="rect">
-            <a:avLst/>
-          </a:prstGeom>
-          <a:noFill/>
-        </p:spPr>
-        <p:txBody>
-          <a:bodyPr wrap="square">
-            <a:spAutoFit/>
-          </a:bodyPr>
-          <a:lstStyle/>
-          <a:p>
-            <a:pPr algn="l">
-              <a:lnSpc>
-                <a:spcPct val="115000"/>
-              </a:lnSpc>
-            </a:pPr>
-            <a:r>
-              <a:rPr sz="1900" b="0" i="0">
-                <a:solidFill>
-                  <a:srgbClr val="E3E9F5"/>
-                </a:solidFill>
-                <a:latin typeface="Arial"/>
-              </a:rPr>
-              <a:t>BERT not replicated — paper's own attempt ran out of memory, no baseline to match</a:t>
-            </a:r>
-          </a:p>
-        </p:txBody>
-      </p:sp>
-      <p:sp>
-        <p:nvSpPr>
-          <p:cNvPr id="16" name="TextBox 15"/>
-          <p:cNvSpPr txBox="1"/>
-          <p:nvPr/>
-        </p:nvSpPr>
-        <p:spPr>
-          <a:xfrm>
-            <a:off x="822960" y="6309360"/>
-            <a:ext cx="6400800" cy="365760"/>
+            <a:off x="822960" y="6355080"/>
+            <a:ext cx="1828800" cy="365760"/>
           </a:xfrm>
           <a:prstGeom prst="rect">
             <a:avLst/>
@@ -8270,52 +8849,13 @@
               </a:lnSpc>
             </a:pPr>
             <a:r>
-              <a:rPr sz="1300" b="0" i="0">
-                <a:solidFill>
-                  <a:srgbClr val="8FB4FF"/>
+              <a:rPr sz="1200" b="0" i="0">
+                <a:solidFill>
+                  <a:srgbClr val="6A7179"/>
                 </a:solidFill>
                 <a:latin typeface="Arial"/>
               </a:rPr>
-              <a:t>github.com/amogh-herle/ML-MINI-PROJECT</a:t>
-            </a:r>
-          </a:p>
-        </p:txBody>
-      </p:sp>
-      <p:sp>
-        <p:nvSpPr>
-          <p:cNvPr id="17" name="TextBox 16"/>
-          <p:cNvSpPr txBox="1"/>
-          <p:nvPr/>
-        </p:nvSpPr>
-        <p:spPr>
-          <a:xfrm>
-            <a:off x="9601200" y="6309360"/>
-            <a:ext cx="1828800" cy="365760"/>
-          </a:xfrm>
-          <a:prstGeom prst="rect">
-            <a:avLst/>
-          </a:prstGeom>
-          <a:noFill/>
-        </p:spPr>
-        <p:txBody>
-          <a:bodyPr wrap="square">
-            <a:spAutoFit/>
-          </a:bodyPr>
-          <a:lstStyle/>
-          <a:p>
-            <a:pPr algn="l">
-              <a:lnSpc>
-                <a:spcPct val="110000"/>
-              </a:lnSpc>
-            </a:pPr>
-            <a:r>
-              <a:rPr sz="1300" b="0" i="0">
-                <a:solidFill>
-                  <a:srgbClr val="6E85AD"/>
-                </a:solidFill>
-                <a:latin typeface="Arial"/>
-              </a:rPr>
-              <a:t>9 / 9</a:t>
+              <a:t>8 / 9</a:t>
             </a:r>
           </a:p>
         </p:txBody>

</xml_diff>

<commit_message>
Phase 4 slide: show the full 14-row results table, not a cherry-picked top 5
- Replaces the 'biggest gains only' table + chart with the complete
  feature x task x classifier grid (all 14 combinations), now including
  test accuracy alongside macro-F1 for every row -- the previous version
  only showed F1, which hid that SVM's accuracy actually dropped after
  tuning (68.8% -> 63.3%) even though its F1 rose
- Two headline rows highlighted: SVM/doc2vec/issue_area (the
  accuracy-vs-F1 tradeoff) and GaussianNB/lda/issue_area (the one case
  where both rose sharply, 13.1% -> 40.4% accuracy)
- Callout text pulls both numbers live from tuned_classifiers.json instead
  of being hand-typed, so it can't drift from the table again
- add_table() gained font_size and multi-row highlight_row support, needed
  for the denser 14-row table
- Dropped the now-unused phase4_tuning_gains.png chart (was only ever
  used on this slide) and its generator in make_report_assets.py
</commit_message>
<xml_diff>
--- a/report/slides.pptx
+++ b/report/slides.pptx
@@ -12244,7 +12244,7 @@
         <p:spPr>
           <a:xfrm>
             <a:off x="822960" y="868680"/>
-            <a:ext cx="10515600" cy="548640"/>
+            <a:ext cx="10515600" cy="502920"/>
           </a:xfrm>
           <a:prstGeom prst="rect">
             <a:avLst/>
@@ -12263,13 +12263,13 @@
               </a:lnSpc>
             </a:pPr>
             <a:r>
-              <a:rPr sz="2600" b="1" i="0">
+              <a:rPr sz="2400" b="1" i="0">
                 <a:solidFill>
                   <a:srgbClr val="1A1A1A"/>
                 </a:solidFill>
                 <a:latin typeface="Arial"/>
               </a:rPr>
-              <a:t>A wider search finds a different kind of win</a:t>
+              <a:t>What tuning really did to accuracy — the full picture</a:t>
             </a:r>
           </a:p>
         </p:txBody>
@@ -12282,8 +12282,8 @@
         </p:nvSpPr>
         <p:spPr>
           <a:xfrm>
-            <a:off x="822960" y="1371600"/>
-            <a:ext cx="4937760" cy="914400"/>
+            <a:off x="822960" y="1298448"/>
+            <a:ext cx="10241280" cy="457200"/>
           </a:xfrm>
           <a:prstGeom prst="rect">
             <a:avLst/>
@@ -12298,17 +12298,17 @@
           <a:p>
             <a:pPr algn="l">
               <a:lnSpc>
-                <a:spcPct val="125000"/>
+                <a:spcPct val="120000"/>
               </a:lnSpc>
             </a:pPr>
             <a:r>
-              <a:rPr sz="1300" b="0" i="0">
+              <a:rPr sz="1250" b="0" i="0">
                 <a:solidFill>
                   <a:srgbClr val="4A5568"/>
                 </a:solidFill>
                 <a:latin typeface="Arial"/>
               </a:rPr>
-              <a:t>SVM, Random Forest and Naive Bayes from Phase 3 were still untuned. We grid-searched kernels, tree depth and smoothing — selected on dev macro-F1, not accuracy.</a:t>
+              <a:t>SVM, Random Forest and Naive Bayes from Phase 3 were still untuned. We grid-searched kernels, tree depth and smoothing — selected on dev macro-F1, not accuracy. All 14 feature × task × classifier combinations, in full:</a:t>
             </a:r>
           </a:p>
         </p:txBody>
@@ -12322,8 +12322,8 @@
           <p:nvPr/>
         </p:nvGraphicFramePr>
         <p:xfrm>
-          <a:off x="822960" y="2423160"/>
-          <a:ext cx="5212080" cy="2194560"/>
+          <a:off x="822960" y="1874519"/>
+          <a:ext cx="9966960" cy="3749039"/>
         </p:xfrm>
         <a:graphic>
           <a:graphicData uri="http://schemas.openxmlformats.org/drawingml/2006/table">
@@ -12332,11 +12332,15 @@
                 <a:tableStyleId>{5C22544A-7EE6-4342-B048-85BDC9FD1C3A}</a:tableStyleId>
               </a:tblPr>
               <a:tblGrid>
-                <a:gridCol w="2834640"/>
-                <a:gridCol w="1188720"/>
-                <a:gridCol w="1188720"/>
+                <a:gridCol w="1920240"/>
+                <a:gridCol w="1143000"/>
+                <a:gridCol w="1417320"/>
+                <a:gridCol w="1371600"/>
+                <a:gridCol w="1371600"/>
+                <a:gridCol w="1371600"/>
+                <a:gridCol w="1371600"/>
               </a:tblGrid>
-              <a:tr h="365760">
+              <a:tr h="249935">
                 <a:tc>
                   <a:txBody>
                     <a:bodyPr/>
@@ -12344,13 +12348,13 @@
                     <a:p>
                       <a:pPr algn="l"/>
                       <a:r>
-                        <a:rPr sz="1300" b="1">
+                        <a:rPr sz="1050" b="1">
                           <a:solidFill>
                             <a:srgbClr val="FBFBF8"/>
                           </a:solidFill>
                           <a:latin typeface="Arial"/>
                         </a:rPr>
-                        <a:t>Model · feature/task</a:t>
+                        <a:t>Classifier</a:t>
                       </a:r>
                     </a:p>
                   </a:txBody>
@@ -12367,7 +12371,99 @@
                     <a:p>
                       <a:pPr algn="l"/>
                       <a:r>
-                        <a:rPr sz="1300" b="1">
+                        <a:rPr sz="1050" b="1">
+                          <a:solidFill>
+                            <a:srgbClr val="FBFBF8"/>
+                          </a:solidFill>
+                          <a:latin typeface="Arial"/>
+                        </a:rPr>
+                        <a:t>Feature</a:t>
+                      </a:r>
+                    </a:p>
+                  </a:txBody>
+                  <a:tcPr anchor="ctr">
+                    <a:solidFill>
+                      <a:srgbClr val="142340"/>
+                    </a:solidFill>
+                  </a:tcPr>
+                </a:tc>
+                <a:tc>
+                  <a:txBody>
+                    <a:bodyPr/>
+                    <a:lstStyle/>
+                    <a:p>
+                      <a:pPr algn="ctr"/>
+                      <a:r>
+                        <a:rPr sz="1050" b="1">
+                          <a:solidFill>
+                            <a:srgbClr val="FBFBF8"/>
+                          </a:solidFill>
+                          <a:latin typeface="Arial"/>
+                        </a:rPr>
+                        <a:t>Task</a:t>
+                      </a:r>
+                    </a:p>
+                  </a:txBody>
+                  <a:tcPr anchor="ctr">
+                    <a:solidFill>
+                      <a:srgbClr val="142340"/>
+                    </a:solidFill>
+                  </a:tcPr>
+                </a:tc>
+                <a:tc>
+                  <a:txBody>
+                    <a:bodyPr/>
+                    <a:lstStyle/>
+                    <a:p>
+                      <a:pPr algn="ctr"/>
+                      <a:r>
+                        <a:rPr sz="1050" b="1">
+                          <a:solidFill>
+                            <a:srgbClr val="FBFBF8"/>
+                          </a:solidFill>
+                          <a:latin typeface="Arial"/>
+                        </a:rPr>
+                        <a:t>Acc Before</a:t>
+                      </a:r>
+                    </a:p>
+                  </a:txBody>
+                  <a:tcPr anchor="ctr">
+                    <a:solidFill>
+                      <a:srgbClr val="142340"/>
+                    </a:solidFill>
+                  </a:tcPr>
+                </a:tc>
+                <a:tc>
+                  <a:txBody>
+                    <a:bodyPr/>
+                    <a:lstStyle/>
+                    <a:p>
+                      <a:pPr algn="ctr"/>
+                      <a:r>
+                        <a:rPr sz="1050" b="1">
+                          <a:solidFill>
+                            <a:srgbClr val="FBFBF8"/>
+                          </a:solidFill>
+                          <a:latin typeface="Arial"/>
+                        </a:rPr>
+                        <a:t>Acc After</a:t>
+                      </a:r>
+                    </a:p>
+                  </a:txBody>
+                  <a:tcPr anchor="ctr">
+                    <a:solidFill>
+                      <a:srgbClr val="142340"/>
+                    </a:solidFill>
+                  </a:tcPr>
+                </a:tc>
+                <a:tc>
+                  <a:txBody>
+                    <a:bodyPr/>
+                    <a:lstStyle/>
+                    <a:p>
+                      <a:pPr algn="ctr"/>
+                      <a:r>
+                        <a:rPr sz="1050" b="1">
                           <a:solidFill>
                             <a:srgbClr val="FBFBF8"/>
                           </a:solidFill>
@@ -12390,7 +12486,7 @@
                     <a:p>
                       <a:pPr algn="ctr"/>
                       <a:r>
-                        <a:rPr sz="1300" b="1">
+                        <a:rPr sz="1050" b="1">
                           <a:solidFill>
                             <a:srgbClr val="FBFBF8"/>
                           </a:solidFill>
@@ -12407,7 +12503,7 @@
                   </a:tcPr>
                 </a:tc>
               </a:tr>
-              <a:tr h="365760">
+              <a:tr h="249935">
                 <a:tc>
                   <a:txBody>
                     <a:bodyPr/>
@@ -12415,13 +12511,1154 @@
                     <a:p>
                       <a:pPr algn="l"/>
                       <a:r>
-                        <a:rPr sz="1300" b="1">
+                        <a:rPr sz="1050" b="0">
+                          <a:solidFill>
+                            <a:srgbClr val="1A1A1A"/>
+                          </a:solidFill>
+                          <a:latin typeface="Arial"/>
+                        </a:rPr>
+                        <a:t>SVM</a:t>
+                      </a:r>
+                    </a:p>
+                  </a:txBody>
+                  <a:tcPr anchor="ctr">
+                    <a:solidFill>
+                      <a:srgbClr val="FFFFFF"/>
+                    </a:solidFill>
+                  </a:tcPr>
+                </a:tc>
+                <a:tc>
+                  <a:txBody>
+                    <a:bodyPr/>
+                    <a:lstStyle/>
+                    <a:p>
+                      <a:pPr algn="l"/>
+                      <a:r>
+                        <a:rPr sz="1050" b="0">
+                          <a:solidFill>
+                            <a:srgbClr val="1A1A1A"/>
+                          </a:solidFill>
+                          <a:latin typeface="Arial"/>
+                        </a:rPr>
+                        <a:t>doc2vec</a:t>
+                      </a:r>
+                    </a:p>
+                  </a:txBody>
+                  <a:tcPr anchor="ctr">
+                    <a:solidFill>
+                      <a:srgbClr val="FFFFFF"/>
+                    </a:solidFill>
+                  </a:tcPr>
+                </a:tc>
+                <a:tc>
+                  <a:txBody>
+                    <a:bodyPr/>
+                    <a:lstStyle/>
+                    <a:p>
+                      <a:pPr algn="ctr"/>
+                      <a:r>
+                        <a:rPr sz="1050" b="0">
+                          <a:solidFill>
+                            <a:srgbClr val="1A1A1A"/>
+                          </a:solidFill>
+                          <a:latin typeface="Arial"/>
+                        </a:rPr>
+                        <a:t>issue</a:t>
+                      </a:r>
+                    </a:p>
+                  </a:txBody>
+                  <a:tcPr anchor="ctr">
+                    <a:solidFill>
+                      <a:srgbClr val="FFFFFF"/>
+                    </a:solidFill>
+                  </a:tcPr>
+                </a:tc>
+                <a:tc>
+                  <a:txBody>
+                    <a:bodyPr/>
+                    <a:lstStyle/>
+                    <a:p>
+                      <a:pPr algn="ctr"/>
+                      <a:r>
+                        <a:rPr sz="1050" b="0">
+                          <a:solidFill>
+                            <a:srgbClr val="1A1A1A"/>
+                          </a:solidFill>
+                          <a:latin typeface="Arial"/>
+                        </a:rPr>
+                        <a:t>43.1%</a:t>
+                      </a:r>
+                    </a:p>
+                  </a:txBody>
+                  <a:tcPr anchor="ctr">
+                    <a:solidFill>
+                      <a:srgbClr val="FFFFFF"/>
+                    </a:solidFill>
+                  </a:tcPr>
+                </a:tc>
+                <a:tc>
+                  <a:txBody>
+                    <a:bodyPr/>
+                    <a:lstStyle/>
+                    <a:p>
+                      <a:pPr algn="ctr"/>
+                      <a:r>
+                        <a:rPr sz="1050" b="0">
+                          <a:solidFill>
+                            <a:srgbClr val="1A1A1A"/>
+                          </a:solidFill>
+                          <a:latin typeface="Arial"/>
+                        </a:rPr>
+                        <a:t>40.1%</a:t>
+                      </a:r>
+                    </a:p>
+                  </a:txBody>
+                  <a:tcPr anchor="ctr">
+                    <a:solidFill>
+                      <a:srgbClr val="FFFFFF"/>
+                    </a:solidFill>
+                  </a:tcPr>
+                </a:tc>
+                <a:tc>
+                  <a:txBody>
+                    <a:bodyPr/>
+                    <a:lstStyle/>
+                    <a:p>
+                      <a:pPr algn="ctr"/>
+                      <a:r>
+                        <a:rPr sz="1050" b="0">
+                          <a:solidFill>
+                            <a:srgbClr val="1A1A1A"/>
+                          </a:solidFill>
+                          <a:latin typeface="Arial"/>
+                        </a:rPr>
+                        <a:t>0.265</a:t>
+                      </a:r>
+                    </a:p>
+                  </a:txBody>
+                  <a:tcPr anchor="ctr">
+                    <a:solidFill>
+                      <a:srgbClr val="FFFFFF"/>
+                    </a:solidFill>
+                  </a:tcPr>
+                </a:tc>
+                <a:tc>
+                  <a:txBody>
+                    <a:bodyPr/>
+                    <a:lstStyle/>
+                    <a:p>
+                      <a:pPr algn="ctr"/>
+                      <a:r>
+                        <a:rPr sz="1050" b="0">
+                          <a:solidFill>
+                            <a:srgbClr val="1A1A1A"/>
+                          </a:solidFill>
+                          <a:latin typeface="Arial"/>
+                        </a:rPr>
+                        <a:t>0.294</a:t>
+                      </a:r>
+                    </a:p>
+                  </a:txBody>
+                  <a:tcPr anchor="ctr">
+                    <a:solidFill>
+                      <a:srgbClr val="FFFFFF"/>
+                    </a:solidFill>
+                  </a:tcPr>
+                </a:tc>
+              </a:tr>
+              <a:tr h="249935">
+                <a:tc>
+                  <a:txBody>
+                    <a:bodyPr/>
+                    <a:lstStyle/>
+                    <a:p>
+                      <a:pPr algn="l"/>
+                      <a:r>
+                        <a:rPr sz="1050" b="0">
+                          <a:solidFill>
+                            <a:srgbClr val="1A1A1A"/>
+                          </a:solidFill>
+                          <a:latin typeface="Arial"/>
+                        </a:rPr>
+                        <a:t>Random Forest</a:t>
+                      </a:r>
+                    </a:p>
+                  </a:txBody>
+                  <a:tcPr anchor="ctr">
+                    <a:solidFill>
+                      <a:srgbClr val="F2F2F2"/>
+                    </a:solidFill>
+                  </a:tcPr>
+                </a:tc>
+                <a:tc>
+                  <a:txBody>
+                    <a:bodyPr/>
+                    <a:lstStyle/>
+                    <a:p>
+                      <a:pPr algn="l"/>
+                      <a:r>
+                        <a:rPr sz="1050" b="0">
+                          <a:solidFill>
+                            <a:srgbClr val="1A1A1A"/>
+                          </a:solidFill>
+                          <a:latin typeface="Arial"/>
+                        </a:rPr>
+                        <a:t>doc2vec</a:t>
+                      </a:r>
+                    </a:p>
+                  </a:txBody>
+                  <a:tcPr anchor="ctr">
+                    <a:solidFill>
+                      <a:srgbClr val="F2F2F2"/>
+                    </a:solidFill>
+                  </a:tcPr>
+                </a:tc>
+                <a:tc>
+                  <a:txBody>
+                    <a:bodyPr/>
+                    <a:lstStyle/>
+                    <a:p>
+                      <a:pPr algn="ctr"/>
+                      <a:r>
+                        <a:rPr sz="1050" b="0">
+                          <a:solidFill>
+                            <a:srgbClr val="1A1A1A"/>
+                          </a:solidFill>
+                          <a:latin typeface="Arial"/>
+                        </a:rPr>
+                        <a:t>issue</a:t>
+                      </a:r>
+                    </a:p>
+                  </a:txBody>
+                  <a:tcPr anchor="ctr">
+                    <a:solidFill>
+                      <a:srgbClr val="F2F2F2"/>
+                    </a:solidFill>
+                  </a:tcPr>
+                </a:tc>
+                <a:tc>
+                  <a:txBody>
+                    <a:bodyPr/>
+                    <a:lstStyle/>
+                    <a:p>
+                      <a:pPr algn="ctr"/>
+                      <a:r>
+                        <a:rPr sz="1050" b="0">
+                          <a:solidFill>
+                            <a:srgbClr val="1A1A1A"/>
+                          </a:solidFill>
+                          <a:latin typeface="Arial"/>
+                        </a:rPr>
+                        <a:t>34.0%</a:t>
+                      </a:r>
+                    </a:p>
+                  </a:txBody>
+                  <a:tcPr anchor="ctr">
+                    <a:solidFill>
+                      <a:srgbClr val="F2F2F2"/>
+                    </a:solidFill>
+                  </a:tcPr>
+                </a:tc>
+                <a:tc>
+                  <a:txBody>
+                    <a:bodyPr/>
+                    <a:lstStyle/>
+                    <a:p>
+                      <a:pPr algn="ctr"/>
+                      <a:r>
+                        <a:rPr sz="1050" b="0">
+                          <a:solidFill>
+                            <a:srgbClr val="1A1A1A"/>
+                          </a:solidFill>
+                          <a:latin typeface="Arial"/>
+                        </a:rPr>
+                        <a:t>33.9%</a:t>
+                      </a:r>
+                    </a:p>
+                  </a:txBody>
+                  <a:tcPr anchor="ctr">
+                    <a:solidFill>
+                      <a:srgbClr val="F2F2F2"/>
+                    </a:solidFill>
+                  </a:tcPr>
+                </a:tc>
+                <a:tc>
+                  <a:txBody>
+                    <a:bodyPr/>
+                    <a:lstStyle/>
+                    <a:p>
+                      <a:pPr algn="ctr"/>
+                      <a:r>
+                        <a:rPr sz="1050" b="0">
+                          <a:solidFill>
+                            <a:srgbClr val="1A1A1A"/>
+                          </a:solidFill>
+                          <a:latin typeface="Arial"/>
+                        </a:rPr>
+                        <a:t>0.173</a:t>
+                      </a:r>
+                    </a:p>
+                  </a:txBody>
+                  <a:tcPr anchor="ctr">
+                    <a:solidFill>
+                      <a:srgbClr val="F2F2F2"/>
+                    </a:solidFill>
+                  </a:tcPr>
+                </a:tc>
+                <a:tc>
+                  <a:txBody>
+                    <a:bodyPr/>
+                    <a:lstStyle/>
+                    <a:p>
+                      <a:pPr algn="ctr"/>
+                      <a:r>
+                        <a:rPr sz="1050" b="0">
+                          <a:solidFill>
+                            <a:srgbClr val="1A1A1A"/>
+                          </a:solidFill>
+                          <a:latin typeface="Arial"/>
+                        </a:rPr>
+                        <a:t>0.170</a:t>
+                      </a:r>
+                    </a:p>
+                  </a:txBody>
+                  <a:tcPr anchor="ctr">
+                    <a:solidFill>
+                      <a:srgbClr val="F2F2F2"/>
+                    </a:solidFill>
+                  </a:tcPr>
+                </a:tc>
+              </a:tr>
+              <a:tr h="249935">
+                <a:tc>
+                  <a:txBody>
+                    <a:bodyPr/>
+                    <a:lstStyle/>
+                    <a:p>
+                      <a:pPr algn="l"/>
+                      <a:r>
+                        <a:rPr sz="1050" b="0">
+                          <a:solidFill>
+                            <a:srgbClr val="1A1A1A"/>
+                          </a:solidFill>
+                          <a:latin typeface="Arial"/>
+                        </a:rPr>
+                        <a:t>Naive Bayes (Gaussian)</a:t>
+                      </a:r>
+                    </a:p>
+                  </a:txBody>
+                  <a:tcPr anchor="ctr">
+                    <a:solidFill>
+                      <a:srgbClr val="FFFFFF"/>
+                    </a:solidFill>
+                  </a:tcPr>
+                </a:tc>
+                <a:tc>
+                  <a:txBody>
+                    <a:bodyPr/>
+                    <a:lstStyle/>
+                    <a:p>
+                      <a:pPr algn="l"/>
+                      <a:r>
+                        <a:rPr sz="1050" b="0">
+                          <a:solidFill>
+                            <a:srgbClr val="1A1A1A"/>
+                          </a:solidFill>
+                          <a:latin typeface="Arial"/>
+                        </a:rPr>
+                        <a:t>doc2vec</a:t>
+                      </a:r>
+                    </a:p>
+                  </a:txBody>
+                  <a:tcPr anchor="ctr">
+                    <a:solidFill>
+                      <a:srgbClr val="FFFFFF"/>
+                    </a:solidFill>
+                  </a:tcPr>
+                </a:tc>
+                <a:tc>
+                  <a:txBody>
+                    <a:bodyPr/>
+                    <a:lstStyle/>
+                    <a:p>
+                      <a:pPr algn="ctr"/>
+                      <a:r>
+                        <a:rPr sz="1050" b="0">
+                          <a:solidFill>
+                            <a:srgbClr val="1A1A1A"/>
+                          </a:solidFill>
+                          <a:latin typeface="Arial"/>
+                        </a:rPr>
+                        <a:t>issue</a:t>
+                      </a:r>
+                    </a:p>
+                  </a:txBody>
+                  <a:tcPr anchor="ctr">
+                    <a:solidFill>
+                      <a:srgbClr val="FFFFFF"/>
+                    </a:solidFill>
+                  </a:tcPr>
+                </a:tc>
+                <a:tc>
+                  <a:txBody>
+                    <a:bodyPr/>
+                    <a:lstStyle/>
+                    <a:p>
+                      <a:pPr algn="ctr"/>
+                      <a:r>
+                        <a:rPr sz="1050" b="0">
+                          <a:solidFill>
+                            <a:srgbClr val="1A1A1A"/>
+                          </a:solidFill>
+                          <a:latin typeface="Arial"/>
+                        </a:rPr>
+                        <a:t>37.1%</a:t>
+                      </a:r>
+                    </a:p>
+                  </a:txBody>
+                  <a:tcPr anchor="ctr">
+                    <a:solidFill>
+                      <a:srgbClr val="FFFFFF"/>
+                    </a:solidFill>
+                  </a:tcPr>
+                </a:tc>
+                <a:tc>
+                  <a:txBody>
+                    <a:bodyPr/>
+                    <a:lstStyle/>
+                    <a:p>
+                      <a:pPr algn="ctr"/>
+                      <a:r>
+                        <a:rPr sz="1050" b="0">
+                          <a:solidFill>
+                            <a:srgbClr val="1A1A1A"/>
+                          </a:solidFill>
+                          <a:latin typeface="Arial"/>
+                        </a:rPr>
+                        <a:t>40.3%</a:t>
+                      </a:r>
+                    </a:p>
+                  </a:txBody>
+                  <a:tcPr anchor="ctr">
+                    <a:solidFill>
+                      <a:srgbClr val="FFFFFF"/>
+                    </a:solidFill>
+                  </a:tcPr>
+                </a:tc>
+                <a:tc>
+                  <a:txBody>
+                    <a:bodyPr/>
+                    <a:lstStyle/>
+                    <a:p>
+                      <a:pPr algn="ctr"/>
+                      <a:r>
+                        <a:rPr sz="1050" b="0">
+                          <a:solidFill>
+                            <a:srgbClr val="1A1A1A"/>
+                          </a:solidFill>
+                          <a:latin typeface="Arial"/>
+                        </a:rPr>
+                        <a:t>0.252</a:t>
+                      </a:r>
+                    </a:p>
+                  </a:txBody>
+                  <a:tcPr anchor="ctr">
+                    <a:solidFill>
+                      <a:srgbClr val="FFFFFF"/>
+                    </a:solidFill>
+                  </a:tcPr>
+                </a:tc>
+                <a:tc>
+                  <a:txBody>
+                    <a:bodyPr/>
+                    <a:lstStyle/>
+                    <a:p>
+                      <a:pPr algn="ctr"/>
+                      <a:r>
+                        <a:rPr sz="1050" b="0">
+                          <a:solidFill>
+                            <a:srgbClr val="1A1A1A"/>
+                          </a:solidFill>
+                          <a:latin typeface="Arial"/>
+                        </a:rPr>
+                        <a:t>0.291</a:t>
+                      </a:r>
+                    </a:p>
+                  </a:txBody>
+                  <a:tcPr anchor="ctr">
+                    <a:solidFill>
+                      <a:srgbClr val="FFFFFF"/>
+                    </a:solidFill>
+                  </a:tcPr>
+                </a:tc>
+              </a:tr>
+              <a:tr h="249935">
+                <a:tc>
+                  <a:txBody>
+                    <a:bodyPr/>
+                    <a:lstStyle/>
+                    <a:p>
+                      <a:pPr algn="l"/>
+                      <a:r>
+                        <a:rPr sz="1050" b="0">
+                          <a:solidFill>
+                            <a:srgbClr val="1A1A1A"/>
+                          </a:solidFill>
+                          <a:latin typeface="Arial"/>
+                        </a:rPr>
+                        <a:t>SVM</a:t>
+                      </a:r>
+                    </a:p>
+                  </a:txBody>
+                  <a:tcPr anchor="ctr">
+                    <a:solidFill>
+                      <a:srgbClr val="F2F2F2"/>
+                    </a:solidFill>
+                  </a:tcPr>
+                </a:tc>
+                <a:tc>
+                  <a:txBody>
+                    <a:bodyPr/>
+                    <a:lstStyle/>
+                    <a:p>
+                      <a:pPr algn="l"/>
+                      <a:r>
+                        <a:rPr sz="1050" b="0">
+                          <a:solidFill>
+                            <a:srgbClr val="1A1A1A"/>
+                          </a:solidFill>
+                          <a:latin typeface="Arial"/>
+                        </a:rPr>
+                        <a:t>lda</a:t>
+                      </a:r>
+                    </a:p>
+                  </a:txBody>
+                  <a:tcPr anchor="ctr">
+                    <a:solidFill>
+                      <a:srgbClr val="F2F2F2"/>
+                    </a:solidFill>
+                  </a:tcPr>
+                </a:tc>
+                <a:tc>
+                  <a:txBody>
+                    <a:bodyPr/>
+                    <a:lstStyle/>
+                    <a:p>
+                      <a:pPr algn="ctr"/>
+                      <a:r>
+                        <a:rPr sz="1050" b="0">
+                          <a:solidFill>
+                            <a:srgbClr val="1A1A1A"/>
+                          </a:solidFill>
+                          <a:latin typeface="Arial"/>
+                        </a:rPr>
+                        <a:t>issue</a:t>
+                      </a:r>
+                    </a:p>
+                  </a:txBody>
+                  <a:tcPr anchor="ctr">
+                    <a:solidFill>
+                      <a:srgbClr val="F2F2F2"/>
+                    </a:solidFill>
+                  </a:tcPr>
+                </a:tc>
+                <a:tc>
+                  <a:txBody>
+                    <a:bodyPr/>
+                    <a:lstStyle/>
+                    <a:p>
+                      <a:pPr algn="ctr"/>
+                      <a:r>
+                        <a:rPr sz="1050" b="0">
+                          <a:solidFill>
+                            <a:srgbClr val="1A1A1A"/>
+                          </a:solidFill>
+                          <a:latin typeface="Arial"/>
+                        </a:rPr>
+                        <a:t>18.5%</a:t>
+                      </a:r>
+                    </a:p>
+                  </a:txBody>
+                  <a:tcPr anchor="ctr">
+                    <a:solidFill>
+                      <a:srgbClr val="F2F2F2"/>
+                    </a:solidFill>
+                  </a:tcPr>
+                </a:tc>
+                <a:tc>
+                  <a:txBody>
+                    <a:bodyPr/>
+                    <a:lstStyle/>
+                    <a:p>
+                      <a:pPr algn="ctr"/>
+                      <a:r>
+                        <a:rPr sz="1050" b="0">
+                          <a:solidFill>
+                            <a:srgbClr val="1A1A1A"/>
+                          </a:solidFill>
+                          <a:latin typeface="Arial"/>
+                        </a:rPr>
+                        <a:t>25.6%</a:t>
+                      </a:r>
+                    </a:p>
+                  </a:txBody>
+                  <a:tcPr anchor="ctr">
+                    <a:solidFill>
+                      <a:srgbClr val="F2F2F2"/>
+                    </a:solidFill>
+                  </a:tcPr>
+                </a:tc>
+                <a:tc>
+                  <a:txBody>
+                    <a:bodyPr/>
+                    <a:lstStyle/>
+                    <a:p>
+                      <a:pPr algn="ctr"/>
+                      <a:r>
+                        <a:rPr sz="1050" b="0">
+                          <a:solidFill>
+                            <a:srgbClr val="1A1A1A"/>
+                          </a:solidFill>
+                          <a:latin typeface="Arial"/>
+                        </a:rPr>
+                        <a:t>0.080</a:t>
+                      </a:r>
+                    </a:p>
+                  </a:txBody>
+                  <a:tcPr anchor="ctr">
+                    <a:solidFill>
+                      <a:srgbClr val="F2F2F2"/>
+                    </a:solidFill>
+                  </a:tcPr>
+                </a:tc>
+                <a:tc>
+                  <a:txBody>
+                    <a:bodyPr/>
+                    <a:lstStyle/>
+                    <a:p>
+                      <a:pPr algn="ctr"/>
+                      <a:r>
+                        <a:rPr sz="1050" b="0">
+                          <a:solidFill>
+                            <a:srgbClr val="1A1A1A"/>
+                          </a:solidFill>
+                          <a:latin typeface="Arial"/>
+                        </a:rPr>
+                        <a:t>0.180</a:t>
+                      </a:r>
+                    </a:p>
+                  </a:txBody>
+                  <a:tcPr anchor="ctr">
+                    <a:solidFill>
+                      <a:srgbClr val="F2F2F2"/>
+                    </a:solidFill>
+                  </a:tcPr>
+                </a:tc>
+              </a:tr>
+              <a:tr h="249935">
+                <a:tc>
+                  <a:txBody>
+                    <a:bodyPr/>
+                    <a:lstStyle/>
+                    <a:p>
+                      <a:pPr algn="l"/>
+                      <a:r>
+                        <a:rPr sz="1050" b="0">
+                          <a:solidFill>
+                            <a:srgbClr val="1A1A1A"/>
+                          </a:solidFill>
+                          <a:latin typeface="Arial"/>
+                        </a:rPr>
+                        <a:t>Random Forest</a:t>
+                      </a:r>
+                    </a:p>
+                  </a:txBody>
+                  <a:tcPr anchor="ctr">
+                    <a:solidFill>
+                      <a:srgbClr val="FFFFFF"/>
+                    </a:solidFill>
+                  </a:tcPr>
+                </a:tc>
+                <a:tc>
+                  <a:txBody>
+                    <a:bodyPr/>
+                    <a:lstStyle/>
+                    <a:p>
+                      <a:pPr algn="l"/>
+                      <a:r>
+                        <a:rPr sz="1050" b="0">
+                          <a:solidFill>
+                            <a:srgbClr val="1A1A1A"/>
+                          </a:solidFill>
+                          <a:latin typeface="Arial"/>
+                        </a:rPr>
+                        <a:t>lda</a:t>
+                      </a:r>
+                    </a:p>
+                  </a:txBody>
+                  <a:tcPr anchor="ctr">
+                    <a:solidFill>
+                      <a:srgbClr val="FFFFFF"/>
+                    </a:solidFill>
+                  </a:tcPr>
+                </a:tc>
+                <a:tc>
+                  <a:txBody>
+                    <a:bodyPr/>
+                    <a:lstStyle/>
+                    <a:p>
+                      <a:pPr algn="ctr"/>
+                      <a:r>
+                        <a:rPr sz="1050" b="0">
+                          <a:solidFill>
+                            <a:srgbClr val="1A1A1A"/>
+                          </a:solidFill>
+                          <a:latin typeface="Arial"/>
+                        </a:rPr>
+                        <a:t>issue</a:t>
+                      </a:r>
+                    </a:p>
+                  </a:txBody>
+                  <a:tcPr anchor="ctr">
+                    <a:solidFill>
+                      <a:srgbClr val="FFFFFF"/>
+                    </a:solidFill>
+                  </a:tcPr>
+                </a:tc>
+                <a:tc>
+                  <a:txBody>
+                    <a:bodyPr/>
+                    <a:lstStyle/>
+                    <a:p>
+                      <a:pPr algn="ctr"/>
+                      <a:r>
+                        <a:rPr sz="1050" b="0">
+                          <a:solidFill>
+                            <a:srgbClr val="1A1A1A"/>
+                          </a:solidFill>
+                          <a:latin typeface="Arial"/>
+                        </a:rPr>
+                        <a:t>21.1%</a:t>
+                      </a:r>
+                    </a:p>
+                  </a:txBody>
+                  <a:tcPr anchor="ctr">
+                    <a:solidFill>
+                      <a:srgbClr val="FFFFFF"/>
+                    </a:solidFill>
+                  </a:tcPr>
+                </a:tc>
+                <a:tc>
+                  <a:txBody>
+                    <a:bodyPr/>
+                    <a:lstStyle/>
+                    <a:p>
+                      <a:pPr algn="ctr"/>
+                      <a:r>
+                        <a:rPr sz="1050" b="0">
+                          <a:solidFill>
+                            <a:srgbClr val="1A1A1A"/>
+                          </a:solidFill>
+                          <a:latin typeface="Arial"/>
+                        </a:rPr>
+                        <a:t>23.2%</a:t>
+                      </a:r>
+                    </a:p>
+                  </a:txBody>
+                  <a:tcPr anchor="ctr">
+                    <a:solidFill>
+                      <a:srgbClr val="FFFFFF"/>
+                    </a:solidFill>
+                  </a:tcPr>
+                </a:tc>
+                <a:tc>
+                  <a:txBody>
+                    <a:bodyPr/>
+                    <a:lstStyle/>
+                    <a:p>
+                      <a:pPr algn="ctr"/>
+                      <a:r>
+                        <a:rPr sz="1050" b="0">
+                          <a:solidFill>
+                            <a:srgbClr val="1A1A1A"/>
+                          </a:solidFill>
+                          <a:latin typeface="Arial"/>
+                        </a:rPr>
+                        <a:t>0.129</a:t>
+                      </a:r>
+                    </a:p>
+                  </a:txBody>
+                  <a:tcPr anchor="ctr">
+                    <a:solidFill>
+                      <a:srgbClr val="FFFFFF"/>
+                    </a:solidFill>
+                  </a:tcPr>
+                </a:tc>
+                <a:tc>
+                  <a:txBody>
+                    <a:bodyPr/>
+                    <a:lstStyle/>
+                    <a:p>
+                      <a:pPr algn="ctr"/>
+                      <a:r>
+                        <a:rPr sz="1050" b="0">
+                          <a:solidFill>
+                            <a:srgbClr val="1A1A1A"/>
+                          </a:solidFill>
+                          <a:latin typeface="Arial"/>
+                        </a:rPr>
+                        <a:t>0.131</a:t>
+                      </a:r>
+                    </a:p>
+                  </a:txBody>
+                  <a:tcPr anchor="ctr">
+                    <a:solidFill>
+                      <a:srgbClr val="FFFFFF"/>
+                    </a:solidFill>
+                  </a:tcPr>
+                </a:tc>
+              </a:tr>
+              <a:tr h="249935">
+                <a:tc>
+                  <a:txBody>
+                    <a:bodyPr/>
+                    <a:lstStyle/>
+                    <a:p>
+                      <a:pPr algn="l"/>
+                      <a:r>
+                        <a:rPr sz="1050" b="0">
+                          <a:solidFill>
+                            <a:srgbClr val="1A1A1A"/>
+                          </a:solidFill>
+                          <a:latin typeface="Arial"/>
+                        </a:rPr>
+                        <a:t>Naive Bayes (Gaussian)</a:t>
+                      </a:r>
+                    </a:p>
+                  </a:txBody>
+                  <a:tcPr anchor="ctr">
+                    <a:solidFill>
+                      <a:srgbClr val="F2F2F2"/>
+                    </a:solidFill>
+                  </a:tcPr>
+                </a:tc>
+                <a:tc>
+                  <a:txBody>
+                    <a:bodyPr/>
+                    <a:lstStyle/>
+                    <a:p>
+                      <a:pPr algn="l"/>
+                      <a:r>
+                        <a:rPr sz="1050" b="0">
+                          <a:solidFill>
+                            <a:srgbClr val="1A1A1A"/>
+                          </a:solidFill>
+                          <a:latin typeface="Arial"/>
+                        </a:rPr>
+                        <a:t>lda</a:t>
+                      </a:r>
+                    </a:p>
+                  </a:txBody>
+                  <a:tcPr anchor="ctr">
+                    <a:solidFill>
+                      <a:srgbClr val="F2F2F2"/>
+                    </a:solidFill>
+                  </a:tcPr>
+                </a:tc>
+                <a:tc>
+                  <a:txBody>
+                    <a:bodyPr/>
+                    <a:lstStyle/>
+                    <a:p>
+                      <a:pPr algn="ctr"/>
+                      <a:r>
+                        <a:rPr sz="1050" b="0">
+                          <a:solidFill>
+                            <a:srgbClr val="1A1A1A"/>
+                          </a:solidFill>
+                          <a:latin typeface="Arial"/>
+                        </a:rPr>
+                        <a:t>issue</a:t>
+                      </a:r>
+                    </a:p>
+                  </a:txBody>
+                  <a:tcPr anchor="ctr">
+                    <a:solidFill>
+                      <a:srgbClr val="F2F2F2"/>
+                    </a:solidFill>
+                  </a:tcPr>
+                </a:tc>
+                <a:tc>
+                  <a:txBody>
+                    <a:bodyPr/>
+                    <a:lstStyle/>
+                    <a:p>
+                      <a:pPr algn="ctr"/>
+                      <a:r>
+                        <a:rPr sz="1050" b="0">
+                          <a:solidFill>
+                            <a:srgbClr val="1A1A1A"/>
+                          </a:solidFill>
+                          <a:latin typeface="Arial"/>
+                        </a:rPr>
+                        <a:t>7.4%</a:t>
+                      </a:r>
+                    </a:p>
+                  </a:txBody>
+                  <a:tcPr anchor="ctr">
+                    <a:solidFill>
+                      <a:srgbClr val="F2F2F2"/>
+                    </a:solidFill>
+                  </a:tcPr>
+                </a:tc>
+                <a:tc>
+                  <a:txBody>
+                    <a:bodyPr/>
+                    <a:lstStyle/>
+                    <a:p>
+                      <a:pPr algn="ctr"/>
+                      <a:r>
+                        <a:rPr sz="1050" b="0">
+                          <a:solidFill>
+                            <a:srgbClr val="1A1A1A"/>
+                          </a:solidFill>
+                          <a:latin typeface="Arial"/>
+                        </a:rPr>
+                        <a:t>20.8%</a:t>
+                      </a:r>
+                    </a:p>
+                  </a:txBody>
+                  <a:tcPr anchor="ctr">
+                    <a:solidFill>
+                      <a:srgbClr val="F2F2F2"/>
+                    </a:solidFill>
+                  </a:tcPr>
+                </a:tc>
+                <a:tc>
+                  <a:txBody>
+                    <a:bodyPr/>
+                    <a:lstStyle/>
+                    <a:p>
+                      <a:pPr algn="ctr"/>
+                      <a:r>
+                        <a:rPr sz="1050" b="0">
+                          <a:solidFill>
+                            <a:srgbClr val="1A1A1A"/>
+                          </a:solidFill>
+                          <a:latin typeface="Arial"/>
+                        </a:rPr>
+                        <a:t>0.075</a:t>
+                      </a:r>
+                    </a:p>
+                  </a:txBody>
+                  <a:tcPr anchor="ctr">
+                    <a:solidFill>
+                      <a:srgbClr val="F2F2F2"/>
+                    </a:solidFill>
+                  </a:tcPr>
+                </a:tc>
+                <a:tc>
+                  <a:txBody>
+                    <a:bodyPr/>
+                    <a:lstStyle/>
+                    <a:p>
+                      <a:pPr algn="ctr"/>
+                      <a:r>
+                        <a:rPr sz="1050" b="0">
+                          <a:solidFill>
+                            <a:srgbClr val="1A1A1A"/>
+                          </a:solidFill>
+                          <a:latin typeface="Arial"/>
+                        </a:rPr>
+                        <a:t>0.150</a:t>
+                      </a:r>
+                    </a:p>
+                  </a:txBody>
+                  <a:tcPr anchor="ctr">
+                    <a:solidFill>
+                      <a:srgbClr val="F2F2F2"/>
+                    </a:solidFill>
+                  </a:tcPr>
+                </a:tc>
+              </a:tr>
+              <a:tr h="249935">
+                <a:tc>
+                  <a:txBody>
+                    <a:bodyPr/>
+                    <a:lstStyle/>
+                    <a:p>
+                      <a:pPr algn="l"/>
+                      <a:r>
+                        <a:rPr sz="1050" b="0">
+                          <a:solidFill>
+                            <a:srgbClr val="1A1A1A"/>
+                          </a:solidFill>
+                          <a:latin typeface="Arial"/>
+                        </a:rPr>
+                        <a:t>Naive Bayes (Multinomial)</a:t>
+                      </a:r>
+                    </a:p>
+                  </a:txBody>
+                  <a:tcPr anchor="ctr">
+                    <a:solidFill>
+                      <a:srgbClr val="FFFFFF"/>
+                    </a:solidFill>
+                  </a:tcPr>
+                </a:tc>
+                <a:tc>
+                  <a:txBody>
+                    <a:bodyPr/>
+                    <a:lstStyle/>
+                    <a:p>
+                      <a:pPr algn="l"/>
+                      <a:r>
+                        <a:rPr sz="1050" b="0">
+                          <a:solidFill>
+                            <a:srgbClr val="1A1A1A"/>
+                          </a:solidFill>
+                          <a:latin typeface="Arial"/>
+                        </a:rPr>
+                        <a:t>lda</a:t>
+                      </a:r>
+                    </a:p>
+                  </a:txBody>
+                  <a:tcPr anchor="ctr">
+                    <a:solidFill>
+                      <a:srgbClr val="FFFFFF"/>
+                    </a:solidFill>
+                  </a:tcPr>
+                </a:tc>
+                <a:tc>
+                  <a:txBody>
+                    <a:bodyPr/>
+                    <a:lstStyle/>
+                    <a:p>
+                      <a:pPr algn="ctr"/>
+                      <a:r>
+                        <a:rPr sz="1050" b="0">
+                          <a:solidFill>
+                            <a:srgbClr val="1A1A1A"/>
+                          </a:solidFill>
+                          <a:latin typeface="Arial"/>
+                        </a:rPr>
+                        <a:t>issue</a:t>
+                      </a:r>
+                    </a:p>
+                  </a:txBody>
+                  <a:tcPr anchor="ctr">
+                    <a:solidFill>
+                      <a:srgbClr val="FFFFFF"/>
+                    </a:solidFill>
+                  </a:tcPr>
+                </a:tc>
+                <a:tc>
+                  <a:txBody>
+                    <a:bodyPr/>
+                    <a:lstStyle/>
+                    <a:p>
+                      <a:pPr algn="ctr"/>
+                      <a:r>
+                        <a:rPr sz="1050" b="0">
+                          <a:solidFill>
+                            <a:srgbClr val="1A1A1A"/>
+                          </a:solidFill>
+                          <a:latin typeface="Arial"/>
+                        </a:rPr>
+                        <a:t>n/a</a:t>
+                      </a:r>
+                    </a:p>
+                  </a:txBody>
+                  <a:tcPr anchor="ctr">
+                    <a:solidFill>
+                      <a:srgbClr val="FFFFFF"/>
+                    </a:solidFill>
+                  </a:tcPr>
+                </a:tc>
+                <a:tc>
+                  <a:txBody>
+                    <a:bodyPr/>
+                    <a:lstStyle/>
+                    <a:p>
+                      <a:pPr algn="ctr"/>
+                      <a:r>
+                        <a:rPr sz="1050" b="0">
+                          <a:solidFill>
+                            <a:srgbClr val="1A1A1A"/>
+                          </a:solidFill>
+                          <a:latin typeface="Arial"/>
+                        </a:rPr>
+                        <a:t>7.5%</a:t>
+                      </a:r>
+                    </a:p>
+                  </a:txBody>
+                  <a:tcPr anchor="ctr">
+                    <a:solidFill>
+                      <a:srgbClr val="FFFFFF"/>
+                    </a:solidFill>
+                  </a:tcPr>
+                </a:tc>
+                <a:tc>
+                  <a:txBody>
+                    <a:bodyPr/>
+                    <a:lstStyle/>
+                    <a:p>
+                      <a:pPr algn="ctr"/>
+                      <a:r>
+                        <a:rPr sz="1050" b="0">
+                          <a:solidFill>
+                            <a:srgbClr val="1A1A1A"/>
+                          </a:solidFill>
+                          <a:latin typeface="Arial"/>
+                        </a:rPr>
+                        <a:t>n/a</a:t>
+                      </a:r>
+                    </a:p>
+                  </a:txBody>
+                  <a:tcPr anchor="ctr">
+                    <a:solidFill>
+                      <a:srgbClr val="FFFFFF"/>
+                    </a:solidFill>
+                  </a:tcPr>
+                </a:tc>
+                <a:tc>
+                  <a:txBody>
+                    <a:bodyPr/>
+                    <a:lstStyle/>
+                    <a:p>
+                      <a:pPr algn="ctr"/>
+                      <a:r>
+                        <a:rPr sz="1050" b="0">
+                          <a:solidFill>
+                            <a:srgbClr val="1A1A1A"/>
+                          </a:solidFill>
+                          <a:latin typeface="Arial"/>
+                        </a:rPr>
+                        <a:t>0.009</a:t>
+                      </a:r>
+                    </a:p>
+                  </a:txBody>
+                  <a:tcPr anchor="ctr">
+                    <a:solidFill>
+                      <a:srgbClr val="FFFFFF"/>
+                    </a:solidFill>
+                  </a:tcPr>
+                </a:tc>
+              </a:tr>
+              <a:tr h="249935">
+                <a:tc>
+                  <a:txBody>
+                    <a:bodyPr/>
+                    <a:lstStyle/>
+                    <a:p>
+                      <a:pPr algn="l"/>
+                      <a:r>
+                        <a:rPr sz="1050" b="1">
                           <a:solidFill>
                             <a:srgbClr val="1E7A3D"/>
                           </a:solidFill>
                           <a:latin typeface="Arial"/>
                         </a:rPr>
-                        <a:t>GaussianNB · lda/issue_area</a:t>
+                        <a:t>SVM</a:t>
                       </a:r>
                     </a:p>
                   </a:txBody>
@@ -12438,7 +13675,914 @@
                     <a:p>
                       <a:pPr algn="l"/>
                       <a:r>
-                        <a:rPr sz="1300" b="1">
+                        <a:rPr sz="1050" b="1">
+                          <a:solidFill>
+                            <a:srgbClr val="1E7A3D"/>
+                          </a:solidFill>
+                          <a:latin typeface="Arial"/>
+                        </a:rPr>
+                        <a:t>doc2vec</a:t>
+                      </a:r>
+                    </a:p>
+                  </a:txBody>
+                  <a:tcPr anchor="ctr">
+                    <a:solidFill>
+                      <a:srgbClr val="E8F3EC"/>
+                    </a:solidFill>
+                  </a:tcPr>
+                </a:tc>
+                <a:tc>
+                  <a:txBody>
+                    <a:bodyPr/>
+                    <a:lstStyle/>
+                    <a:p>
+                      <a:pPr algn="ctr"/>
+                      <a:r>
+                        <a:rPr sz="1050" b="1">
+                          <a:solidFill>
+                            <a:srgbClr val="1E7A3D"/>
+                          </a:solidFill>
+                          <a:latin typeface="Arial"/>
+                        </a:rPr>
+                        <a:t>issue_area</a:t>
+                      </a:r>
+                    </a:p>
+                  </a:txBody>
+                  <a:tcPr anchor="ctr">
+                    <a:solidFill>
+                      <a:srgbClr val="E8F3EC"/>
+                    </a:solidFill>
+                  </a:tcPr>
+                </a:tc>
+                <a:tc>
+                  <a:txBody>
+                    <a:bodyPr/>
+                    <a:lstStyle/>
+                    <a:p>
+                      <a:pPr algn="ctr"/>
+                      <a:r>
+                        <a:rPr sz="1050" b="1">
+                          <a:solidFill>
+                            <a:srgbClr val="1E7A3D"/>
+                          </a:solidFill>
+                          <a:latin typeface="Arial"/>
+                        </a:rPr>
+                        <a:t>68.8%</a:t>
+                      </a:r>
+                    </a:p>
+                  </a:txBody>
+                  <a:tcPr anchor="ctr">
+                    <a:solidFill>
+                      <a:srgbClr val="E8F3EC"/>
+                    </a:solidFill>
+                  </a:tcPr>
+                </a:tc>
+                <a:tc>
+                  <a:txBody>
+                    <a:bodyPr/>
+                    <a:lstStyle/>
+                    <a:p>
+                      <a:pPr algn="ctr"/>
+                      <a:r>
+                        <a:rPr sz="1050" b="1">
+                          <a:solidFill>
+                            <a:srgbClr val="1E7A3D"/>
+                          </a:solidFill>
+                          <a:latin typeface="Arial"/>
+                        </a:rPr>
+                        <a:t>63.3%</a:t>
+                      </a:r>
+                    </a:p>
+                  </a:txBody>
+                  <a:tcPr anchor="ctr">
+                    <a:solidFill>
+                      <a:srgbClr val="E8F3EC"/>
+                    </a:solidFill>
+                  </a:tcPr>
+                </a:tc>
+                <a:tc>
+                  <a:txBody>
+                    <a:bodyPr/>
+                    <a:lstStyle/>
+                    <a:p>
+                      <a:pPr algn="ctr"/>
+                      <a:r>
+                        <a:rPr sz="1050" b="1">
+                          <a:solidFill>
+                            <a:srgbClr val="1E7A3D"/>
+                          </a:solidFill>
+                          <a:latin typeface="Arial"/>
+                        </a:rPr>
+                        <a:t>0.499</a:t>
+                      </a:r>
+                    </a:p>
+                  </a:txBody>
+                  <a:tcPr anchor="ctr">
+                    <a:solidFill>
+                      <a:srgbClr val="E8F3EC"/>
+                    </a:solidFill>
+                  </a:tcPr>
+                </a:tc>
+                <a:tc>
+                  <a:txBody>
+                    <a:bodyPr/>
+                    <a:lstStyle/>
+                    <a:p>
+                      <a:pPr algn="ctr"/>
+                      <a:r>
+                        <a:rPr sz="1050" b="1">
+                          <a:solidFill>
+                            <a:srgbClr val="1E7A3D"/>
+                          </a:solidFill>
+                          <a:latin typeface="Arial"/>
+                        </a:rPr>
+                        <a:t>0.512</a:t>
+                      </a:r>
+                    </a:p>
+                  </a:txBody>
+                  <a:tcPr anchor="ctr">
+                    <a:solidFill>
+                      <a:srgbClr val="E8F3EC"/>
+                    </a:solidFill>
+                  </a:tcPr>
+                </a:tc>
+              </a:tr>
+              <a:tr h="249935">
+                <a:tc>
+                  <a:txBody>
+                    <a:bodyPr/>
+                    <a:lstStyle/>
+                    <a:p>
+                      <a:pPr algn="l"/>
+                      <a:r>
+                        <a:rPr sz="1050" b="0">
+                          <a:solidFill>
+                            <a:srgbClr val="1A1A1A"/>
+                          </a:solidFill>
+                          <a:latin typeface="Arial"/>
+                        </a:rPr>
+                        <a:t>Random Forest</a:t>
+                      </a:r>
+                    </a:p>
+                  </a:txBody>
+                  <a:tcPr anchor="ctr">
+                    <a:solidFill>
+                      <a:srgbClr val="FFFFFF"/>
+                    </a:solidFill>
+                  </a:tcPr>
+                </a:tc>
+                <a:tc>
+                  <a:txBody>
+                    <a:bodyPr/>
+                    <a:lstStyle/>
+                    <a:p>
+                      <a:pPr algn="l"/>
+                      <a:r>
+                        <a:rPr sz="1050" b="0">
+                          <a:solidFill>
+                            <a:srgbClr val="1A1A1A"/>
+                          </a:solidFill>
+                          <a:latin typeface="Arial"/>
+                        </a:rPr>
+                        <a:t>doc2vec</a:t>
+                      </a:r>
+                    </a:p>
+                  </a:txBody>
+                  <a:tcPr anchor="ctr">
+                    <a:solidFill>
+                      <a:srgbClr val="FFFFFF"/>
+                    </a:solidFill>
+                  </a:tcPr>
+                </a:tc>
+                <a:tc>
+                  <a:txBody>
+                    <a:bodyPr/>
+                    <a:lstStyle/>
+                    <a:p>
+                      <a:pPr algn="ctr"/>
+                      <a:r>
+                        <a:rPr sz="1050" b="0">
+                          <a:solidFill>
+                            <a:srgbClr val="1A1A1A"/>
+                          </a:solidFill>
+                          <a:latin typeface="Arial"/>
+                        </a:rPr>
+                        <a:t>issue_area</a:t>
+                      </a:r>
+                    </a:p>
+                  </a:txBody>
+                  <a:tcPr anchor="ctr">
+                    <a:solidFill>
+                      <a:srgbClr val="FFFFFF"/>
+                    </a:solidFill>
+                  </a:tcPr>
+                </a:tc>
+                <a:tc>
+                  <a:txBody>
+                    <a:bodyPr/>
+                    <a:lstStyle/>
+                    <a:p>
+                      <a:pPr algn="ctr"/>
+                      <a:r>
+                        <a:rPr sz="1050" b="0">
+                          <a:solidFill>
+                            <a:srgbClr val="1A1A1A"/>
+                          </a:solidFill>
+                          <a:latin typeface="Arial"/>
+                        </a:rPr>
+                        <a:t>59.6%</a:t>
+                      </a:r>
+                    </a:p>
+                  </a:txBody>
+                  <a:tcPr anchor="ctr">
+                    <a:solidFill>
+                      <a:srgbClr val="FFFFFF"/>
+                    </a:solidFill>
+                  </a:tcPr>
+                </a:tc>
+                <a:tc>
+                  <a:txBody>
+                    <a:bodyPr/>
+                    <a:lstStyle/>
+                    <a:p>
+                      <a:pPr algn="ctr"/>
+                      <a:r>
+                        <a:rPr sz="1050" b="0">
+                          <a:solidFill>
+                            <a:srgbClr val="1A1A1A"/>
+                          </a:solidFill>
+                          <a:latin typeface="Arial"/>
+                        </a:rPr>
+                        <a:t>59.1%</a:t>
+                      </a:r>
+                    </a:p>
+                  </a:txBody>
+                  <a:tcPr anchor="ctr">
+                    <a:solidFill>
+                      <a:srgbClr val="FFFFFF"/>
+                    </a:solidFill>
+                  </a:tcPr>
+                </a:tc>
+                <a:tc>
+                  <a:txBody>
+                    <a:bodyPr/>
+                    <a:lstStyle/>
+                    <a:p>
+                      <a:pPr algn="ctr"/>
+                      <a:r>
+                        <a:rPr sz="1050" b="0">
+                          <a:solidFill>
+                            <a:srgbClr val="1A1A1A"/>
+                          </a:solidFill>
+                          <a:latin typeface="Arial"/>
+                        </a:rPr>
+                        <a:t>0.317</a:t>
+                      </a:r>
+                    </a:p>
+                  </a:txBody>
+                  <a:tcPr anchor="ctr">
+                    <a:solidFill>
+                      <a:srgbClr val="FFFFFF"/>
+                    </a:solidFill>
+                  </a:tcPr>
+                </a:tc>
+                <a:tc>
+                  <a:txBody>
+                    <a:bodyPr/>
+                    <a:lstStyle/>
+                    <a:p>
+                      <a:pPr algn="ctr"/>
+                      <a:r>
+                        <a:rPr sz="1050" b="0">
+                          <a:solidFill>
+                            <a:srgbClr val="1A1A1A"/>
+                          </a:solidFill>
+                          <a:latin typeface="Arial"/>
+                        </a:rPr>
+                        <a:t>0.317</a:t>
+                      </a:r>
+                    </a:p>
+                  </a:txBody>
+                  <a:tcPr anchor="ctr">
+                    <a:solidFill>
+                      <a:srgbClr val="FFFFFF"/>
+                    </a:solidFill>
+                  </a:tcPr>
+                </a:tc>
+              </a:tr>
+              <a:tr h="249935">
+                <a:tc>
+                  <a:txBody>
+                    <a:bodyPr/>
+                    <a:lstStyle/>
+                    <a:p>
+                      <a:pPr algn="l"/>
+                      <a:r>
+                        <a:rPr sz="1050" b="0">
+                          <a:solidFill>
+                            <a:srgbClr val="1A1A1A"/>
+                          </a:solidFill>
+                          <a:latin typeface="Arial"/>
+                        </a:rPr>
+                        <a:t>Naive Bayes (Gaussian)</a:t>
+                      </a:r>
+                    </a:p>
+                  </a:txBody>
+                  <a:tcPr anchor="ctr">
+                    <a:solidFill>
+                      <a:srgbClr val="F2F2F2"/>
+                    </a:solidFill>
+                  </a:tcPr>
+                </a:tc>
+                <a:tc>
+                  <a:txBody>
+                    <a:bodyPr/>
+                    <a:lstStyle/>
+                    <a:p>
+                      <a:pPr algn="l"/>
+                      <a:r>
+                        <a:rPr sz="1050" b="0">
+                          <a:solidFill>
+                            <a:srgbClr val="1A1A1A"/>
+                          </a:solidFill>
+                          <a:latin typeface="Arial"/>
+                        </a:rPr>
+                        <a:t>doc2vec</a:t>
+                      </a:r>
+                    </a:p>
+                  </a:txBody>
+                  <a:tcPr anchor="ctr">
+                    <a:solidFill>
+                      <a:srgbClr val="F2F2F2"/>
+                    </a:solidFill>
+                  </a:tcPr>
+                </a:tc>
+                <a:tc>
+                  <a:txBody>
+                    <a:bodyPr/>
+                    <a:lstStyle/>
+                    <a:p>
+                      <a:pPr algn="ctr"/>
+                      <a:r>
+                        <a:rPr sz="1050" b="0">
+                          <a:solidFill>
+                            <a:srgbClr val="1A1A1A"/>
+                          </a:solidFill>
+                          <a:latin typeface="Arial"/>
+                        </a:rPr>
+                        <a:t>issue_area</a:t>
+                      </a:r>
+                    </a:p>
+                  </a:txBody>
+                  <a:tcPr anchor="ctr">
+                    <a:solidFill>
+                      <a:srgbClr val="F2F2F2"/>
+                    </a:solidFill>
+                  </a:tcPr>
+                </a:tc>
+                <a:tc>
+                  <a:txBody>
+                    <a:bodyPr/>
+                    <a:lstStyle/>
+                    <a:p>
+                      <a:pPr algn="ctr"/>
+                      <a:r>
+                        <a:rPr sz="1050" b="0">
+                          <a:solidFill>
+                            <a:srgbClr val="1A1A1A"/>
+                          </a:solidFill>
+                          <a:latin typeface="Arial"/>
+                        </a:rPr>
+                        <a:t>58.7%</a:t>
+                      </a:r>
+                    </a:p>
+                  </a:txBody>
+                  <a:tcPr anchor="ctr">
+                    <a:solidFill>
+                      <a:srgbClr val="F2F2F2"/>
+                    </a:solidFill>
+                  </a:tcPr>
+                </a:tc>
+                <a:tc>
+                  <a:txBody>
+                    <a:bodyPr/>
+                    <a:lstStyle/>
+                    <a:p>
+                      <a:pPr algn="ctr"/>
+                      <a:r>
+                        <a:rPr sz="1050" b="0">
+                          <a:solidFill>
+                            <a:srgbClr val="1A1A1A"/>
+                          </a:solidFill>
+                          <a:latin typeface="Arial"/>
+                        </a:rPr>
+                        <a:t>60.2%</a:t>
+                      </a:r>
+                    </a:p>
+                  </a:txBody>
+                  <a:tcPr anchor="ctr">
+                    <a:solidFill>
+                      <a:srgbClr val="F2F2F2"/>
+                    </a:solidFill>
+                  </a:tcPr>
+                </a:tc>
+                <a:tc>
+                  <a:txBody>
+                    <a:bodyPr/>
+                    <a:lstStyle/>
+                    <a:p>
+                      <a:pPr algn="ctr"/>
+                      <a:r>
+                        <a:rPr sz="1050" b="0">
+                          <a:solidFill>
+                            <a:srgbClr val="1A1A1A"/>
+                          </a:solidFill>
+                          <a:latin typeface="Arial"/>
+                        </a:rPr>
+                        <a:t>0.462</a:t>
+                      </a:r>
+                    </a:p>
+                  </a:txBody>
+                  <a:tcPr anchor="ctr">
+                    <a:solidFill>
+                      <a:srgbClr val="F2F2F2"/>
+                    </a:solidFill>
+                  </a:tcPr>
+                </a:tc>
+                <a:tc>
+                  <a:txBody>
+                    <a:bodyPr/>
+                    <a:lstStyle/>
+                    <a:p>
+                      <a:pPr algn="ctr"/>
+                      <a:r>
+                        <a:rPr sz="1050" b="0">
+                          <a:solidFill>
+                            <a:srgbClr val="1A1A1A"/>
+                          </a:solidFill>
+                          <a:latin typeface="Arial"/>
+                        </a:rPr>
+                        <a:t>0.474</a:t>
+                      </a:r>
+                    </a:p>
+                  </a:txBody>
+                  <a:tcPr anchor="ctr">
+                    <a:solidFill>
+                      <a:srgbClr val="F2F2F2"/>
+                    </a:solidFill>
+                  </a:tcPr>
+                </a:tc>
+              </a:tr>
+              <a:tr h="249935">
+                <a:tc>
+                  <a:txBody>
+                    <a:bodyPr/>
+                    <a:lstStyle/>
+                    <a:p>
+                      <a:pPr algn="l"/>
+                      <a:r>
+                        <a:rPr sz="1050" b="0">
+                          <a:solidFill>
+                            <a:srgbClr val="1A1A1A"/>
+                          </a:solidFill>
+                          <a:latin typeface="Arial"/>
+                        </a:rPr>
+                        <a:t>SVM</a:t>
+                      </a:r>
+                    </a:p>
+                  </a:txBody>
+                  <a:tcPr anchor="ctr">
+                    <a:solidFill>
+                      <a:srgbClr val="FFFFFF"/>
+                    </a:solidFill>
+                  </a:tcPr>
+                </a:tc>
+                <a:tc>
+                  <a:txBody>
+                    <a:bodyPr/>
+                    <a:lstStyle/>
+                    <a:p>
+                      <a:pPr algn="l"/>
+                      <a:r>
+                        <a:rPr sz="1050" b="0">
+                          <a:solidFill>
+                            <a:srgbClr val="1A1A1A"/>
+                          </a:solidFill>
+                          <a:latin typeface="Arial"/>
+                        </a:rPr>
+                        <a:t>lda</a:t>
+                      </a:r>
+                    </a:p>
+                  </a:txBody>
+                  <a:tcPr anchor="ctr">
+                    <a:solidFill>
+                      <a:srgbClr val="FFFFFF"/>
+                    </a:solidFill>
+                  </a:tcPr>
+                </a:tc>
+                <a:tc>
+                  <a:txBody>
+                    <a:bodyPr/>
+                    <a:lstStyle/>
+                    <a:p>
+                      <a:pPr algn="ctr"/>
+                      <a:r>
+                        <a:rPr sz="1050" b="0">
+                          <a:solidFill>
+                            <a:srgbClr val="1A1A1A"/>
+                          </a:solidFill>
+                          <a:latin typeface="Arial"/>
+                        </a:rPr>
+                        <a:t>issue_area</a:t>
+                      </a:r>
+                    </a:p>
+                  </a:txBody>
+                  <a:tcPr anchor="ctr">
+                    <a:solidFill>
+                      <a:srgbClr val="FFFFFF"/>
+                    </a:solidFill>
+                  </a:tcPr>
+                </a:tc>
+                <a:tc>
+                  <a:txBody>
+                    <a:bodyPr/>
+                    <a:lstStyle/>
+                    <a:p>
+                      <a:pPr algn="ctr"/>
+                      <a:r>
+                        <a:rPr sz="1050" b="0">
+                          <a:solidFill>
+                            <a:srgbClr val="1A1A1A"/>
+                          </a:solidFill>
+                          <a:latin typeface="Arial"/>
+                        </a:rPr>
+                        <a:t>49.1%</a:t>
+                      </a:r>
+                    </a:p>
+                  </a:txBody>
+                  <a:tcPr anchor="ctr">
+                    <a:solidFill>
+                      <a:srgbClr val="FFFFFF"/>
+                    </a:solidFill>
+                  </a:tcPr>
+                </a:tc>
+                <a:tc>
+                  <a:txBody>
+                    <a:bodyPr/>
+                    <a:lstStyle/>
+                    <a:p>
+                      <a:pPr algn="ctr"/>
+                      <a:r>
+                        <a:rPr sz="1050" b="0">
+                          <a:solidFill>
+                            <a:srgbClr val="1A1A1A"/>
+                          </a:solidFill>
+                          <a:latin typeface="Arial"/>
+                        </a:rPr>
+                        <a:t>51.4%</a:t>
+                      </a:r>
+                    </a:p>
+                  </a:txBody>
+                  <a:tcPr anchor="ctr">
+                    <a:solidFill>
+                      <a:srgbClr val="FFFFFF"/>
+                    </a:solidFill>
+                  </a:tcPr>
+                </a:tc>
+                <a:tc>
+                  <a:txBody>
+                    <a:bodyPr/>
+                    <a:lstStyle/>
+                    <a:p>
+                      <a:pPr algn="ctr"/>
+                      <a:r>
+                        <a:rPr sz="1050" b="0">
+                          <a:solidFill>
+                            <a:srgbClr val="1A1A1A"/>
+                          </a:solidFill>
+                          <a:latin typeface="Arial"/>
+                        </a:rPr>
+                        <a:t>0.266</a:t>
+                      </a:r>
+                    </a:p>
+                  </a:txBody>
+                  <a:tcPr anchor="ctr">
+                    <a:solidFill>
+                      <a:srgbClr val="FFFFFF"/>
+                    </a:solidFill>
+                  </a:tcPr>
+                </a:tc>
+                <a:tc>
+                  <a:txBody>
+                    <a:bodyPr/>
+                    <a:lstStyle/>
+                    <a:p>
+                      <a:pPr algn="ctr"/>
+                      <a:r>
+                        <a:rPr sz="1050" b="0">
+                          <a:solidFill>
+                            <a:srgbClr val="1A1A1A"/>
+                          </a:solidFill>
+                          <a:latin typeface="Arial"/>
+                        </a:rPr>
+                        <a:t>0.303</a:t>
+                      </a:r>
+                    </a:p>
+                  </a:txBody>
+                  <a:tcPr anchor="ctr">
+                    <a:solidFill>
+                      <a:srgbClr val="FFFFFF"/>
+                    </a:solidFill>
+                  </a:tcPr>
+                </a:tc>
+              </a:tr>
+              <a:tr h="249935">
+                <a:tc>
+                  <a:txBody>
+                    <a:bodyPr/>
+                    <a:lstStyle/>
+                    <a:p>
+                      <a:pPr algn="l"/>
+                      <a:r>
+                        <a:rPr sz="1050" b="0">
+                          <a:solidFill>
+                            <a:srgbClr val="1A1A1A"/>
+                          </a:solidFill>
+                          <a:latin typeface="Arial"/>
+                        </a:rPr>
+                        <a:t>Random Forest</a:t>
+                      </a:r>
+                    </a:p>
+                  </a:txBody>
+                  <a:tcPr anchor="ctr">
+                    <a:solidFill>
+                      <a:srgbClr val="F2F2F2"/>
+                    </a:solidFill>
+                  </a:tcPr>
+                </a:tc>
+                <a:tc>
+                  <a:txBody>
+                    <a:bodyPr/>
+                    <a:lstStyle/>
+                    <a:p>
+                      <a:pPr algn="l"/>
+                      <a:r>
+                        <a:rPr sz="1050" b="0">
+                          <a:solidFill>
+                            <a:srgbClr val="1A1A1A"/>
+                          </a:solidFill>
+                          <a:latin typeface="Arial"/>
+                        </a:rPr>
+                        <a:t>lda</a:t>
+                      </a:r>
+                    </a:p>
+                  </a:txBody>
+                  <a:tcPr anchor="ctr">
+                    <a:solidFill>
+                      <a:srgbClr val="F2F2F2"/>
+                    </a:solidFill>
+                  </a:tcPr>
+                </a:tc>
+                <a:tc>
+                  <a:txBody>
+                    <a:bodyPr/>
+                    <a:lstStyle/>
+                    <a:p>
+                      <a:pPr algn="ctr"/>
+                      <a:r>
+                        <a:rPr sz="1050" b="0">
+                          <a:solidFill>
+                            <a:srgbClr val="1A1A1A"/>
+                          </a:solidFill>
+                          <a:latin typeface="Arial"/>
+                        </a:rPr>
+                        <a:t>issue_area</a:t>
+                      </a:r>
+                    </a:p>
+                  </a:txBody>
+                  <a:tcPr anchor="ctr">
+                    <a:solidFill>
+                      <a:srgbClr val="F2F2F2"/>
+                    </a:solidFill>
+                  </a:tcPr>
+                </a:tc>
+                <a:tc>
+                  <a:txBody>
+                    <a:bodyPr/>
+                    <a:lstStyle/>
+                    <a:p>
+                      <a:pPr algn="ctr"/>
+                      <a:r>
+                        <a:rPr sz="1050" b="0">
+                          <a:solidFill>
+                            <a:srgbClr val="1A1A1A"/>
+                          </a:solidFill>
+                          <a:latin typeface="Arial"/>
+                        </a:rPr>
+                        <a:t>46.1%</a:t>
+                      </a:r>
+                    </a:p>
+                  </a:txBody>
+                  <a:tcPr anchor="ctr">
+                    <a:solidFill>
+                      <a:srgbClr val="F2F2F2"/>
+                    </a:solidFill>
+                  </a:tcPr>
+                </a:tc>
+                <a:tc>
+                  <a:txBody>
+                    <a:bodyPr/>
+                    <a:lstStyle/>
+                    <a:p>
+                      <a:pPr algn="ctr"/>
+                      <a:r>
+                        <a:rPr sz="1050" b="0">
+                          <a:solidFill>
+                            <a:srgbClr val="1A1A1A"/>
+                          </a:solidFill>
+                          <a:latin typeface="Arial"/>
+                        </a:rPr>
+                        <a:t>46.6%</a:t>
+                      </a:r>
+                    </a:p>
+                  </a:txBody>
+                  <a:tcPr anchor="ctr">
+                    <a:solidFill>
+                      <a:srgbClr val="F2F2F2"/>
+                    </a:solidFill>
+                  </a:tcPr>
+                </a:tc>
+                <a:tc>
+                  <a:txBody>
+                    <a:bodyPr/>
+                    <a:lstStyle/>
+                    <a:p>
+                      <a:pPr algn="ctr"/>
+                      <a:r>
+                        <a:rPr sz="1050" b="0">
+                          <a:solidFill>
+                            <a:srgbClr val="1A1A1A"/>
+                          </a:solidFill>
+                          <a:latin typeface="Arial"/>
+                        </a:rPr>
+                        <a:t>0.253</a:t>
+                      </a:r>
+                    </a:p>
+                  </a:txBody>
+                  <a:tcPr anchor="ctr">
+                    <a:solidFill>
+                      <a:srgbClr val="F2F2F2"/>
+                    </a:solidFill>
+                  </a:tcPr>
+                </a:tc>
+                <a:tc>
+                  <a:txBody>
+                    <a:bodyPr/>
+                    <a:lstStyle/>
+                    <a:p>
+                      <a:pPr algn="ctr"/>
+                      <a:r>
+                        <a:rPr sz="1050" b="0">
+                          <a:solidFill>
+                            <a:srgbClr val="1A1A1A"/>
+                          </a:solidFill>
+                          <a:latin typeface="Arial"/>
+                        </a:rPr>
+                        <a:t>0.251</a:t>
+                      </a:r>
+                    </a:p>
+                  </a:txBody>
+                  <a:tcPr anchor="ctr">
+                    <a:solidFill>
+                      <a:srgbClr val="F2F2F2"/>
+                    </a:solidFill>
+                  </a:tcPr>
+                </a:tc>
+              </a:tr>
+              <a:tr h="249935">
+                <a:tc>
+                  <a:txBody>
+                    <a:bodyPr/>
+                    <a:lstStyle/>
+                    <a:p>
+                      <a:pPr algn="l"/>
+                      <a:r>
+                        <a:rPr sz="1050" b="1">
+                          <a:solidFill>
+                            <a:srgbClr val="1E7A3D"/>
+                          </a:solidFill>
+                          <a:latin typeface="Arial"/>
+                        </a:rPr>
+                        <a:t>Naive Bayes (Gaussian)</a:t>
+                      </a:r>
+                    </a:p>
+                  </a:txBody>
+                  <a:tcPr anchor="ctr">
+                    <a:solidFill>
+                      <a:srgbClr val="E8F3EC"/>
+                    </a:solidFill>
+                  </a:tcPr>
+                </a:tc>
+                <a:tc>
+                  <a:txBody>
+                    <a:bodyPr/>
+                    <a:lstStyle/>
+                    <a:p>
+                      <a:pPr algn="l"/>
+                      <a:r>
+                        <a:rPr sz="1050" b="1">
+                          <a:solidFill>
+                            <a:srgbClr val="1E7A3D"/>
+                          </a:solidFill>
+                          <a:latin typeface="Arial"/>
+                        </a:rPr>
+                        <a:t>lda</a:t>
+                      </a:r>
+                    </a:p>
+                  </a:txBody>
+                  <a:tcPr anchor="ctr">
+                    <a:solidFill>
+                      <a:srgbClr val="E8F3EC"/>
+                    </a:solidFill>
+                  </a:tcPr>
+                </a:tc>
+                <a:tc>
+                  <a:txBody>
+                    <a:bodyPr/>
+                    <a:lstStyle/>
+                    <a:p>
+                      <a:pPr algn="ctr"/>
+                      <a:r>
+                        <a:rPr sz="1050" b="1">
+                          <a:solidFill>
+                            <a:srgbClr val="1E7A3D"/>
+                          </a:solidFill>
+                          <a:latin typeface="Arial"/>
+                        </a:rPr>
+                        <a:t>issue_area</a:t>
+                      </a:r>
+                    </a:p>
+                  </a:txBody>
+                  <a:tcPr anchor="ctr">
+                    <a:solidFill>
+                      <a:srgbClr val="E8F3EC"/>
+                    </a:solidFill>
+                  </a:tcPr>
+                </a:tc>
+                <a:tc>
+                  <a:txBody>
+                    <a:bodyPr/>
+                    <a:lstStyle/>
+                    <a:p>
+                      <a:pPr algn="ctr"/>
+                      <a:r>
+                        <a:rPr sz="1050" b="1">
+                          <a:solidFill>
+                            <a:srgbClr val="1E7A3D"/>
+                          </a:solidFill>
+                          <a:latin typeface="Arial"/>
+                        </a:rPr>
+                        <a:t>13.1%</a:t>
+                      </a:r>
+                    </a:p>
+                  </a:txBody>
+                  <a:tcPr anchor="ctr">
+                    <a:solidFill>
+                      <a:srgbClr val="E8F3EC"/>
+                    </a:solidFill>
+                  </a:tcPr>
+                </a:tc>
+                <a:tc>
+                  <a:txBody>
+                    <a:bodyPr/>
+                    <a:lstStyle/>
+                    <a:p>
+                      <a:pPr algn="ctr"/>
+                      <a:r>
+                        <a:rPr sz="1050" b="1">
+                          <a:solidFill>
+                            <a:srgbClr val="1E7A3D"/>
+                          </a:solidFill>
+                          <a:latin typeface="Arial"/>
+                        </a:rPr>
+                        <a:t>40.4%</a:t>
+                      </a:r>
+                    </a:p>
+                  </a:txBody>
+                  <a:tcPr anchor="ctr">
+                    <a:solidFill>
+                      <a:srgbClr val="E8F3EC"/>
+                    </a:solidFill>
+                  </a:tcPr>
+                </a:tc>
+                <a:tc>
+                  <a:txBody>
+                    <a:bodyPr/>
+                    <a:lstStyle/>
+                    <a:p>
+                      <a:pPr algn="ctr"/>
+                      <a:r>
+                        <a:rPr sz="1050" b="1">
                           <a:solidFill>
                             <a:srgbClr val="1E7A3D"/>
                           </a:solidFill>
@@ -12461,7 +14605,7 @@
                     <a:p>
                       <a:pPr algn="ctr"/>
                       <a:r>
-                        <a:rPr sz="1300" b="1">
+                        <a:rPr sz="1050" b="1">
                           <a:solidFill>
                             <a:srgbClr val="1E7A3D"/>
                           </a:solidFill>
@@ -12478,7 +14622,7 @@
                   </a:tcPr>
                 </a:tc>
               </a:tr>
-              <a:tr h="365760">
+              <a:tr h="249949">
                 <a:tc>
                   <a:txBody>
                     <a:bodyPr/>
@@ -12486,13 +14630,13 @@
                     <a:p>
                       <a:pPr algn="l"/>
                       <a:r>
-                        <a:rPr sz="1300" b="0">
+                        <a:rPr sz="1050" b="0">
                           <a:solidFill>
                             <a:srgbClr val="1A1A1A"/>
                           </a:solidFill>
                           <a:latin typeface="Arial"/>
                         </a:rPr>
-                        <a:t>SVM · lda/issue</a:t>
+                        <a:t>Naive Bayes (Multinomial)</a:t>
                       </a:r>
                     </a:p>
                   </a:txBody>
@@ -12509,13 +14653,13 @@
                     <a:p>
                       <a:pPr algn="l"/>
                       <a:r>
-                        <a:rPr sz="1300" b="0">
+                        <a:rPr sz="1050" b="0">
                           <a:solidFill>
                             <a:srgbClr val="1A1A1A"/>
                           </a:solidFill>
                           <a:latin typeface="Arial"/>
                         </a:rPr>
-                        <a:t>0.080</a:t>
+                        <a:t>lda</a:t>
                       </a:r>
                     </a:p>
                   </a:txBody>
@@ -12532,132 +14676,13 @@
                     <a:p>
                       <a:pPr algn="ctr"/>
                       <a:r>
-                        <a:rPr sz="1300" b="0">
+                        <a:rPr sz="1050" b="0">
                           <a:solidFill>
                             <a:srgbClr val="1A1A1A"/>
                           </a:solidFill>
                           <a:latin typeface="Arial"/>
                         </a:rPr>
-                        <a:t>0.180</a:t>
-                      </a:r>
-                    </a:p>
-                  </a:txBody>
-                  <a:tcPr anchor="ctr">
-                    <a:solidFill>
-                      <a:srgbClr val="F2F2F2"/>
-                    </a:solidFill>
-                  </a:tcPr>
-                </a:tc>
-              </a:tr>
-              <a:tr h="365760">
-                <a:tc>
-                  <a:txBody>
-                    <a:bodyPr/>
-                    <a:lstStyle/>
-                    <a:p>
-                      <a:pPr algn="l"/>
-                      <a:r>
-                        <a:rPr sz="1300" b="0">
-                          <a:solidFill>
-                            <a:srgbClr val="1A1A1A"/>
-                          </a:solidFill>
-                          <a:latin typeface="Arial"/>
-                        </a:rPr>
-                        <a:t>GaussianNB · lda/issue</a:t>
-                      </a:r>
-                    </a:p>
-                  </a:txBody>
-                  <a:tcPr anchor="ctr">
-                    <a:solidFill>
-                      <a:srgbClr val="FFFFFF"/>
-                    </a:solidFill>
-                  </a:tcPr>
-                </a:tc>
-                <a:tc>
-                  <a:txBody>
-                    <a:bodyPr/>
-                    <a:lstStyle/>
-                    <a:p>
-                      <a:pPr algn="l"/>
-                      <a:r>
-                        <a:rPr sz="1300" b="0">
-                          <a:solidFill>
-                            <a:srgbClr val="1A1A1A"/>
-                          </a:solidFill>
-                          <a:latin typeface="Arial"/>
-                        </a:rPr>
-                        <a:t>0.075</a:t>
-                      </a:r>
-                    </a:p>
-                  </a:txBody>
-                  <a:tcPr anchor="ctr">
-                    <a:solidFill>
-                      <a:srgbClr val="FFFFFF"/>
-                    </a:solidFill>
-                  </a:tcPr>
-                </a:tc>
-                <a:tc>
-                  <a:txBody>
-                    <a:bodyPr/>
-                    <a:lstStyle/>
-                    <a:p>
-                      <a:pPr algn="ctr"/>
-                      <a:r>
-                        <a:rPr sz="1300" b="0">
-                          <a:solidFill>
-                            <a:srgbClr val="1A1A1A"/>
-                          </a:solidFill>
-                          <a:latin typeface="Arial"/>
-                        </a:rPr>
-                        <a:t>0.150</a:t>
-                      </a:r>
-                    </a:p>
-                  </a:txBody>
-                  <a:tcPr anchor="ctr">
-                    <a:solidFill>
-                      <a:srgbClr val="FFFFFF"/>
-                    </a:solidFill>
-                  </a:tcPr>
-                </a:tc>
-              </a:tr>
-              <a:tr h="365760">
-                <a:tc>
-                  <a:txBody>
-                    <a:bodyPr/>
-                    <a:lstStyle/>
-                    <a:p>
-                      <a:pPr algn="l"/>
-                      <a:r>
-                        <a:rPr sz="1300" b="0">
-                          <a:solidFill>
-                            <a:srgbClr val="1A1A1A"/>
-                          </a:solidFill>
-                          <a:latin typeface="Arial"/>
-                        </a:rPr>
-                        <a:t>GaussianNB · doc2vec/issue</a:t>
-                      </a:r>
-                    </a:p>
-                  </a:txBody>
-                  <a:tcPr anchor="ctr">
-                    <a:solidFill>
-                      <a:srgbClr val="F2F2F2"/>
-                    </a:solidFill>
-                  </a:tcPr>
-                </a:tc>
-                <a:tc>
-                  <a:txBody>
-                    <a:bodyPr/>
-                    <a:lstStyle/>
-                    <a:p>
-                      <a:pPr algn="l"/>
-                      <a:r>
-                        <a:rPr sz="1300" b="0">
-                          <a:solidFill>
-                            <a:srgbClr val="1A1A1A"/>
-                          </a:solidFill>
-                          <a:latin typeface="Arial"/>
-                        </a:rPr>
-                        <a:t>0.252</a:t>
+                        <a:t>issue_area</a:t>
                       </a:r>
                     </a:p>
                   </a:txBody>
@@ -12674,13 +14699,82 @@
                     <a:p>
                       <a:pPr algn="ctr"/>
                       <a:r>
-                        <a:rPr sz="1300" b="0">
+                        <a:rPr sz="1050" b="0">
                           <a:solidFill>
                             <a:srgbClr val="1A1A1A"/>
                           </a:solidFill>
                           <a:latin typeface="Arial"/>
                         </a:rPr>
-                        <a:t>0.291</a:t>
+                        <a:t>n/a</a:t>
+                      </a:r>
+                    </a:p>
+                  </a:txBody>
+                  <a:tcPr anchor="ctr">
+                    <a:solidFill>
+                      <a:srgbClr val="F2F2F2"/>
+                    </a:solidFill>
+                  </a:tcPr>
+                </a:tc>
+                <a:tc>
+                  <a:txBody>
+                    <a:bodyPr/>
+                    <a:lstStyle/>
+                    <a:p>
+                      <a:pPr algn="ctr"/>
+                      <a:r>
+                        <a:rPr sz="1050" b="0">
+                          <a:solidFill>
+                            <a:srgbClr val="1A1A1A"/>
+                          </a:solidFill>
+                          <a:latin typeface="Arial"/>
+                        </a:rPr>
+                        <a:t>33.5%</a:t>
+                      </a:r>
+                    </a:p>
+                  </a:txBody>
+                  <a:tcPr anchor="ctr">
+                    <a:solidFill>
+                      <a:srgbClr val="F2F2F2"/>
+                    </a:solidFill>
+                  </a:tcPr>
+                </a:tc>
+                <a:tc>
+                  <a:txBody>
+                    <a:bodyPr/>
+                    <a:lstStyle/>
+                    <a:p>
+                      <a:pPr algn="ctr"/>
+                      <a:r>
+                        <a:rPr sz="1050" b="0">
+                          <a:solidFill>
+                            <a:srgbClr val="1A1A1A"/>
+                          </a:solidFill>
+                          <a:latin typeface="Arial"/>
+                        </a:rPr>
+                        <a:t>n/a</a:t>
+                      </a:r>
+                    </a:p>
+                  </a:txBody>
+                  <a:tcPr anchor="ctr">
+                    <a:solidFill>
+                      <a:srgbClr val="F2F2F2"/>
+                    </a:solidFill>
+                  </a:tcPr>
+                </a:tc>
+                <a:tc>
+                  <a:txBody>
+                    <a:bodyPr/>
+                    <a:lstStyle/>
+                    <a:p>
+                      <a:pPr algn="ctr"/>
+                      <a:r>
+                        <a:rPr sz="1050" b="0">
+                          <a:solidFill>
+                            <a:srgbClr val="1A1A1A"/>
+                          </a:solidFill>
+                          <a:latin typeface="Arial"/>
+                        </a:rPr>
+                        <a:t>0.076</a:t>
                       </a:r>
                     </a:p>
                   </a:txBody>
@@ -12691,77 +14785,6 @@
                   </a:tcPr>
                 </a:tc>
               </a:tr>
-              <a:tr h="365760">
-                <a:tc>
-                  <a:txBody>
-                    <a:bodyPr/>
-                    <a:lstStyle/>
-                    <a:p>
-                      <a:pPr algn="l"/>
-                      <a:r>
-                        <a:rPr sz="1300" b="0">
-                          <a:solidFill>
-                            <a:srgbClr val="1A1A1A"/>
-                          </a:solidFill>
-                          <a:latin typeface="Arial"/>
-                        </a:rPr>
-                        <a:t>SVM · lda/issue_area</a:t>
-                      </a:r>
-                    </a:p>
-                  </a:txBody>
-                  <a:tcPr anchor="ctr">
-                    <a:solidFill>
-                      <a:srgbClr val="FFFFFF"/>
-                    </a:solidFill>
-                  </a:tcPr>
-                </a:tc>
-                <a:tc>
-                  <a:txBody>
-                    <a:bodyPr/>
-                    <a:lstStyle/>
-                    <a:p>
-                      <a:pPr algn="l"/>
-                      <a:r>
-                        <a:rPr sz="1300" b="0">
-                          <a:solidFill>
-                            <a:srgbClr val="1A1A1A"/>
-                          </a:solidFill>
-                          <a:latin typeface="Arial"/>
-                        </a:rPr>
-                        <a:t>0.266</a:t>
-                      </a:r>
-                    </a:p>
-                  </a:txBody>
-                  <a:tcPr anchor="ctr">
-                    <a:solidFill>
-                      <a:srgbClr val="FFFFFF"/>
-                    </a:solidFill>
-                  </a:tcPr>
-                </a:tc>
-                <a:tc>
-                  <a:txBody>
-                    <a:bodyPr/>
-                    <a:lstStyle/>
-                    <a:p>
-                      <a:pPr algn="ctr"/>
-                      <a:r>
-                        <a:rPr sz="1300" b="0">
-                          <a:solidFill>
-                            <a:srgbClr val="1A1A1A"/>
-                          </a:solidFill>
-                          <a:latin typeface="Arial"/>
-                        </a:rPr>
-                        <a:t>0.303</a:t>
-                      </a:r>
-                    </a:p>
-                  </a:txBody>
-                  <a:tcPr anchor="ctr">
-                    <a:solidFill>
-                      <a:srgbClr val="FFFFFF"/>
-                    </a:solidFill>
-                  </a:tcPr>
-                </a:tc>
-              </a:tr>
             </a:tbl>
           </a:graphicData>
         </a:graphic>
@@ -12774,8 +14797,8 @@
         </p:nvSpPr>
         <p:spPr>
           <a:xfrm>
-            <a:off x="822960" y="4846320"/>
-            <a:ext cx="4937760" cy="1188720"/>
+            <a:off x="822960" y="5760720"/>
+            <a:ext cx="10241280" cy="594360"/>
           </a:xfrm>
           <a:prstGeom prst="rect">
             <a:avLst/>
@@ -12790,48 +14813,24 @@
           <a:p>
             <a:pPr algn="l">
               <a:lnSpc>
-                <a:spcPct val="125000"/>
+                <a:spcPct val="120000"/>
               </a:lnSpc>
             </a:pPr>
             <a:r>
-              <a:rPr sz="1300" b="0" i="0">
+              <a:rPr sz="1150" b="0" i="1">
                 <a:solidFill>
                   <a:srgbClr val="4A5568"/>
                 </a:solidFill>
                 <a:latin typeface="Arial"/>
               </a:rPr>
-              <a:t>Gaussian NB's default smoothing was badly miscalibrated for LDA's topic-probability features — one knob (var_smoothing) more than doubled its macro-F1.</a:t>
+              <a:t>SVM's accuracy actually dropped (68.8% → 63.3%) even though its F1 rose — tuning for macro-F1 traded raw accuracy for fairness across categories. Gaussian NB on LDA/issue_area is the one case where both rose sharply (13.1% → 40.4% accuracy).</a:t>
             </a:r>
           </a:p>
         </p:txBody>
       </p:sp>
-      <p:pic>
-        <p:nvPicPr>
-          <p:cNvPr id="8" name="Picture 7" descr="phase4_tuning_gains.png"/>
-          <p:cNvPicPr>
-            <a:picLocks noChangeAspect="1"/>
-          </p:cNvPicPr>
-          <p:nvPr/>
-        </p:nvPicPr>
-        <p:blipFill>
-          <a:blip r:embed="rId2"/>
-          <a:stretch>
-            <a:fillRect/>
-          </a:stretch>
-        </p:blipFill>
-        <p:spPr>
-          <a:xfrm>
-            <a:off x="6035040" y="1600200"/>
-            <a:ext cx="5394960" cy="2967228"/>
-          </a:xfrm>
-          <a:prstGeom prst="rect">
-            <a:avLst/>
-          </a:prstGeom>
-        </p:spPr>
-      </p:pic>
-      <p:sp>
-        <p:nvSpPr>
-          <p:cNvPr id="9" name="Oval 8"/>
+      <p:sp>
+        <p:nvSpPr>
+          <p:cNvPr id="8" name="Oval 7"/>
           <p:cNvSpPr/>
           <p:nvPr/>
         </p:nvSpPr>
@@ -12875,7 +14874,7 @@
       </p:sp>
       <p:sp>
         <p:nvSpPr>
-          <p:cNvPr id="10" name="Oval 9"/>
+          <p:cNvPr id="9" name="Oval 8"/>
           <p:cNvSpPr/>
           <p:nvPr/>
         </p:nvSpPr>
@@ -12919,7 +14918,7 @@
       </p:sp>
       <p:sp>
         <p:nvSpPr>
-          <p:cNvPr id="11" name="Oval 10"/>
+          <p:cNvPr id="10" name="Oval 9"/>
           <p:cNvSpPr/>
           <p:nvPr/>
         </p:nvSpPr>
@@ -12963,7 +14962,7 @@
       </p:sp>
       <p:sp>
         <p:nvSpPr>
-          <p:cNvPr id="12" name="Oval 11"/>
+          <p:cNvPr id="11" name="Oval 10"/>
           <p:cNvSpPr/>
           <p:nvPr/>
         </p:nvSpPr>
@@ -13007,7 +15006,7 @@
       </p:sp>
       <p:sp>
         <p:nvSpPr>
-          <p:cNvPr id="13" name="Oval 12"/>
+          <p:cNvPr id="12" name="Oval 11"/>
           <p:cNvSpPr/>
           <p:nvPr/>
         </p:nvSpPr>
@@ -13051,7 +15050,7 @@
       </p:sp>
       <p:sp>
         <p:nvSpPr>
-          <p:cNvPr id="14" name="Oval 13"/>
+          <p:cNvPr id="13" name="Oval 12"/>
           <p:cNvSpPr/>
           <p:nvPr/>
         </p:nvSpPr>
@@ -13095,7 +15094,7 @@
       </p:sp>
       <p:sp>
         <p:nvSpPr>
-          <p:cNvPr id="15" name="Oval 14"/>
+          <p:cNvPr id="14" name="Oval 13"/>
           <p:cNvSpPr/>
           <p:nvPr/>
         </p:nvSpPr>
@@ -13139,7 +15138,7 @@
       </p:sp>
       <p:sp>
         <p:nvSpPr>
-          <p:cNvPr id="16" name="Oval 15"/>
+          <p:cNvPr id="15" name="Oval 14"/>
           <p:cNvSpPr/>
           <p:nvPr/>
         </p:nvSpPr>
@@ -13183,7 +15182,7 @@
       </p:sp>
       <p:sp>
         <p:nvSpPr>
-          <p:cNvPr id="17" name="Oval 16"/>
+          <p:cNvPr id="16" name="Oval 15"/>
           <p:cNvSpPr/>
           <p:nvPr/>
         </p:nvSpPr>
@@ -13227,7 +15226,7 @@
       </p:sp>
       <p:sp>
         <p:nvSpPr>
-          <p:cNvPr id="18" name="Oval 17"/>
+          <p:cNvPr id="17" name="Oval 16"/>
           <p:cNvSpPr/>
           <p:nvPr/>
         </p:nvSpPr>
@@ -13271,7 +15270,7 @@
       </p:sp>
       <p:sp>
         <p:nvSpPr>
-          <p:cNvPr id="19" name="TextBox 18"/>
+          <p:cNvPr id="18" name="TextBox 17"/>
           <p:cNvSpPr txBox="1"/>
           <p:nvPr/>
         </p:nvSpPr>

</xml_diff>

<commit_message>
Add confusion matrix slide, extend demo samples to 10
- evaluate_best_model.py: loads the saved Doc2Vec+SVM model, predicts on
  the test set, writes results/confusion_matrix.json and a row-normalized
  heatmap (results/figures/confusion_matrix.png) with full category names
- New slide 'Where the best model actually gets confused' (deck: 10 -> 11
  content slides): Economic Activity visibly pulls in misclassifications
  from Judicial Power (35) and Federalism (19) -- a concrete picture of
  the majority-class-bias story the per-category F1 slide already argues
  in aggregate
- extract_samples.py: 5 -> 10 sample opinions (now covers 10 of 13
  issue_area categories) for trying predict.py
- Caught and fixed during review: the confusion matrix image's aspect
  ratio made it overflow past the slide bottom into the footer on first
  render; shrunk and recentered, verified via rendered PDF
</commit_message>
<xml_diff>
--- a/report/slides.pptx
+++ b/report/slides.pptx
@@ -16,6 +16,7 @@
     <p:sldId id="264" r:id="rId15"/>
     <p:sldId id="265" r:id="rId16"/>
     <p:sldId id="266" r:id="rId17"/>
+    <p:sldId id="267" r:id="rId18"/>
   </p:sldIdLst>
   <p:sldSz cx="12191695" cy="6858000" type="screen4x3"/>
   <p:notesSz cx="6858000" cy="9144000"/>
@@ -3532,7 +3533,7 @@
                 </a:solidFill>
                 <a:latin typeface="Arial"/>
               </a:rPr>
-              <a:t>PUTTING IT TOGETHER</a:t>
+              <a:t>A CLOSER LOOK</a:t>
             </a:r>
           </a:p>
         </p:txBody>
@@ -3546,7 +3547,7 @@
         <p:spPr>
           <a:xfrm>
             <a:off x="822960" y="868680"/>
-            <a:ext cx="10515600" cy="822960"/>
+            <a:ext cx="10515600" cy="502920"/>
           </a:xfrm>
           <a:prstGeom prst="rect">
             <a:avLst/>
@@ -3565,20 +3566,20 @@
               </a:lnSpc>
             </a:pPr>
             <a:r>
-              <a:rPr sz="2800" b="1" i="0">
+              <a:rPr sz="2400" b="1" i="0">
                 <a:solidFill>
                   <a:srgbClr val="1A1A1A"/>
                 </a:solidFill>
                 <a:latin typeface="Arial"/>
               </a:rPr>
-              <a:t>Each phase pushed the best model further</a:t>
+              <a:t>Where the best model actually gets confused</a:t>
             </a:r>
           </a:p>
         </p:txBody>
       </p:sp>
       <p:pic>
         <p:nvPicPr>
-          <p:cNvPr id="5" name="Picture 4" descr="progress_by_phase.png"/>
+          <p:cNvPr id="5" name="Picture 4" descr="confusion_matrix.png"/>
           <p:cNvPicPr>
             <a:picLocks noChangeAspect="1"/>
           </p:cNvPicPr>
@@ -3592,8 +3593,8 @@
         </p:blipFill>
         <p:spPr>
           <a:xfrm>
-            <a:off x="822960" y="1828800"/>
-            <a:ext cx="5486400" cy="3771900"/>
+            <a:off x="3630168" y="1280160"/>
+            <a:ext cx="4937760" cy="4389120"/>
           </a:xfrm>
           <a:prstGeom prst="rect">
             <a:avLst/>
@@ -3602,20 +3603,59 @@
       </p:pic>
       <p:sp>
         <p:nvSpPr>
-          <p:cNvPr id="6" name="Oval 5"/>
+          <p:cNvPr id="6" name="TextBox 5"/>
+          <p:cNvSpPr txBox="1"/>
+          <p:nvPr/>
+        </p:nvSpPr>
+        <p:spPr>
+          <a:xfrm>
+            <a:off x="822960" y="5806440"/>
+            <a:ext cx="10607040" cy="320040"/>
+          </a:xfrm>
+          <a:prstGeom prst="rect">
+            <a:avLst/>
+          </a:prstGeom>
+          <a:noFill/>
+        </p:spPr>
+        <p:txBody>
+          <a:bodyPr wrap="square">
+            <a:spAutoFit/>
+          </a:bodyPr>
+          <a:lstStyle/>
+          <a:p>
+            <a:pPr algn="ctr">
+              <a:lnSpc>
+                <a:spcPct val="110000"/>
+              </a:lnSpc>
+            </a:pPr>
+            <a:r>
+              <a:rPr sz="1100" b="0" i="0">
+                <a:solidFill>
+                  <a:srgbClr val="4A5568"/>
+                </a:solidFill>
+                <a:latin typeface="Arial"/>
+              </a:rPr>
+              <a:t>Rows = true category, columns = predicted — Economic Activity pulls in misclassifications from Judicial Power and Federalism.</a:t>
+            </a:r>
+          </a:p>
+        </p:txBody>
+      </p:sp>
+      <p:sp>
+        <p:nvSpPr>
+          <p:cNvPr id="7" name="Oval 6"/>
           <p:cNvSpPr/>
           <p:nvPr/>
         </p:nvSpPr>
         <p:spPr>
           <a:xfrm>
-            <a:off x="6675120" y="2377440"/>
-            <a:ext cx="292608" cy="292608"/>
+            <a:off x="9357055" y="6473952"/>
+            <a:ext cx="82296" cy="82296"/>
           </a:xfrm>
           <a:prstGeom prst="ellipse">
             <a:avLst/>
           </a:prstGeom>
           <a:solidFill>
-            <a:srgbClr val="2A5CAA"/>
+            <a:srgbClr val="DDE1DC"/>
           </a:solidFill>
           <a:ln>
             <a:noFill/>
@@ -3637,58 +3677,10 @@
           </a:fontRef>
         </p:style>
         <p:txBody>
-          <a:bodyPr rtlCol="0" anchor="ctr" wrap="none"/>
+          <a:bodyPr rtlCol="0" anchor="ctr"/>
           <a:lstStyle/>
           <a:p>
             <a:pPr algn="ctr"/>
-            <a:r>
-              <a:rPr sz="1300" b="1">
-                <a:solidFill>
-                  <a:srgbClr val="142340"/>
-                </a:solidFill>
-                <a:latin typeface="Arial"/>
-              </a:rPr>
-              <a:t>✓</a:t>
-            </a:r>
-          </a:p>
-        </p:txBody>
-      </p:sp>
-      <p:sp>
-        <p:nvSpPr>
-          <p:cNvPr id="7" name="TextBox 6"/>
-          <p:cNvSpPr txBox="1"/>
-          <p:nvPr/>
-        </p:nvSpPr>
-        <p:spPr>
-          <a:xfrm>
-            <a:off x="7132320" y="2350008"/>
-            <a:ext cx="4206240" cy="566928"/>
-          </a:xfrm>
-          <a:prstGeom prst="rect">
-            <a:avLst/>
-          </a:prstGeom>
-          <a:noFill/>
-        </p:spPr>
-        <p:txBody>
-          <a:bodyPr wrap="square">
-            <a:spAutoFit/>
-          </a:bodyPr>
-          <a:lstStyle/>
-          <a:p>
-            <a:pPr algn="l">
-              <a:lnSpc>
-                <a:spcPct val="115000"/>
-              </a:lnSpc>
-            </a:pPr>
-            <a:r>
-              <a:rPr sz="1500" b="0" i="0">
-                <a:solidFill>
-                  <a:srgbClr val="1A1A1A"/>
-                </a:solidFill>
-                <a:latin typeface="Arial"/>
-              </a:rPr>
-              <a:t>Phase 1: Doc2Vec + Logistic Regression, paper's default settings — 59.1%</a:t>
-            </a:r>
           </a:p>
         </p:txBody>
       </p:sp>
@@ -3700,14 +3692,14 @@
         </p:nvSpPr>
         <p:spPr>
           <a:xfrm>
-            <a:off x="6675120" y="2944368"/>
-            <a:ext cx="292608" cy="292608"/>
+            <a:off x="9539935" y="6473952"/>
+            <a:ext cx="82296" cy="82296"/>
           </a:xfrm>
           <a:prstGeom prst="ellipse">
             <a:avLst/>
           </a:prstGeom>
           <a:solidFill>
-            <a:srgbClr val="2A5CAA"/>
+            <a:srgbClr val="DDE1DC"/>
           </a:solidFill>
           <a:ln>
             <a:noFill/>
@@ -3729,77 +3721,29 @@
           </a:fontRef>
         </p:style>
         <p:txBody>
-          <a:bodyPr rtlCol="0" anchor="ctr" wrap="none"/>
+          <a:bodyPr rtlCol="0" anchor="ctr"/>
           <a:lstStyle/>
           <a:p>
             <a:pPr algn="ctr"/>
-            <a:r>
-              <a:rPr sz="1300" b="1">
-                <a:solidFill>
-                  <a:srgbClr val="142340"/>
-                </a:solidFill>
-                <a:latin typeface="Arial"/>
-              </a:rPr>
-              <a:t>✓</a:t>
-            </a:r>
-          </a:p>
-        </p:txBody>
-      </p:sp>
-      <p:sp>
-        <p:nvSpPr>
-          <p:cNvPr id="9" name="TextBox 8"/>
-          <p:cNvSpPr txBox="1"/>
-          <p:nvPr/>
-        </p:nvSpPr>
-        <p:spPr>
-          <a:xfrm>
-            <a:off x="7132320" y="2916936"/>
-            <a:ext cx="4206240" cy="566928"/>
-          </a:xfrm>
-          <a:prstGeom prst="rect">
-            <a:avLst/>
-          </a:prstGeom>
-          <a:noFill/>
-        </p:spPr>
-        <p:txBody>
-          <a:bodyPr wrap="square">
-            <a:spAutoFit/>
-          </a:bodyPr>
-          <a:lstStyle/>
-          <a:p>
-            <a:pPr algn="l">
-              <a:lnSpc>
-                <a:spcPct val="115000"/>
-              </a:lnSpc>
-            </a:pPr>
-            <a:r>
-              <a:rPr sz="1500" b="0" i="0">
-                <a:solidFill>
-                  <a:srgbClr val="1A1A1A"/>
-                </a:solidFill>
-                <a:latin typeface="Arial"/>
-              </a:rPr>
-              <a:t>Phase 2: tuned vector_size (100→50) and C on dev only — 62.2%</a:t>
-            </a:r>
-          </a:p>
-        </p:txBody>
-      </p:sp>
-      <p:sp>
-        <p:nvSpPr>
-          <p:cNvPr id="10" name="Oval 9"/>
+          </a:p>
+        </p:txBody>
+      </p:sp>
+      <p:sp>
+        <p:nvSpPr>
+          <p:cNvPr id="9" name="Oval 8"/>
           <p:cNvSpPr/>
           <p:nvPr/>
         </p:nvSpPr>
         <p:spPr>
           <a:xfrm>
-            <a:off x="6675120" y="3511296"/>
-            <a:ext cx="292608" cy="292608"/>
+            <a:off x="9722815" y="6473952"/>
+            <a:ext cx="82296" cy="82296"/>
           </a:xfrm>
           <a:prstGeom prst="ellipse">
             <a:avLst/>
           </a:prstGeom>
           <a:solidFill>
-            <a:srgbClr val="2A5CAA"/>
+            <a:srgbClr val="DDE1DC"/>
           </a:solidFill>
           <a:ln>
             <a:noFill/>
@@ -3821,109 +3765,22 @@
           </a:fontRef>
         </p:style>
         <p:txBody>
-          <a:bodyPr rtlCol="0" anchor="ctr" wrap="none"/>
+          <a:bodyPr rtlCol="0" anchor="ctr"/>
           <a:lstStyle/>
           <a:p>
             <a:pPr algn="ctr"/>
-            <a:r>
-              <a:rPr sz="1300" b="1">
-                <a:solidFill>
-                  <a:srgbClr val="142340"/>
-                </a:solidFill>
-                <a:latin typeface="Arial"/>
-              </a:rPr>
-              <a:t>✓</a:t>
-            </a:r>
-          </a:p>
-        </p:txBody>
-      </p:sp>
-      <p:sp>
-        <p:nvSpPr>
-          <p:cNvPr id="11" name="TextBox 10"/>
-          <p:cNvSpPr txBox="1"/>
-          <p:nvPr/>
-        </p:nvSpPr>
-        <p:spPr>
-          <a:xfrm>
-            <a:off x="7132320" y="3483864"/>
-            <a:ext cx="4206240" cy="566928"/>
-          </a:xfrm>
-          <a:prstGeom prst="rect">
-            <a:avLst/>
-          </a:prstGeom>
-          <a:noFill/>
-        </p:spPr>
-        <p:txBody>
-          <a:bodyPr wrap="square">
-            <a:spAutoFit/>
-          </a:bodyPr>
-          <a:lstStyle/>
-          <a:p>
-            <a:pPr algn="l">
-              <a:lnSpc>
-                <a:spcPct val="115000"/>
-              </a:lnSpc>
-            </a:pPr>
-            <a:r>
-              <a:rPr sz="1500" b="0" i="0">
-                <a:solidFill>
-                  <a:srgbClr val="1A1A1A"/>
-                </a:solidFill>
-                <a:latin typeface="Arial"/>
-              </a:rPr>
-              <a:t>Phase 3: swapped in SVM (RBF kernel) on the same features — 68.8%</a:t>
-            </a:r>
-          </a:p>
-        </p:txBody>
-      </p:sp>
-      <p:sp>
-        <p:nvSpPr>
-          <p:cNvPr id="12" name="TextBox 11"/>
-          <p:cNvSpPr txBox="1"/>
-          <p:nvPr/>
-        </p:nvSpPr>
-        <p:spPr>
-          <a:xfrm>
-            <a:off x="6675120" y="4846320"/>
-            <a:ext cx="4663440" cy="1097280"/>
-          </a:xfrm>
-          <a:prstGeom prst="rect">
-            <a:avLst/>
-          </a:prstGeom>
-          <a:noFill/>
-        </p:spPr>
-        <p:txBody>
-          <a:bodyPr wrap="square">
-            <a:spAutoFit/>
-          </a:bodyPr>
-          <a:lstStyle/>
-          <a:p>
-            <a:pPr algn="l">
-              <a:lnSpc>
-                <a:spcPct val="130000"/>
-              </a:lnSpc>
-            </a:pPr>
-            <a:r>
-              <a:rPr sz="1400" b="0" i="1">
-                <a:solidFill>
-                  <a:srgbClr val="4A5568"/>
-                </a:solidFill>
-                <a:latin typeface="Arial"/>
-              </a:rPr>
-              <a:t>Nearly 10 points of accuracy gained beyond the paper's own result, without touching the dataset.</a:t>
-            </a:r>
-          </a:p>
-        </p:txBody>
-      </p:sp>
-      <p:sp>
-        <p:nvSpPr>
-          <p:cNvPr id="13" name="Oval 12"/>
+          </a:p>
+        </p:txBody>
+      </p:sp>
+      <p:sp>
+        <p:nvSpPr>
+          <p:cNvPr id="10" name="Oval 9"/>
           <p:cNvSpPr/>
           <p:nvPr/>
         </p:nvSpPr>
         <p:spPr>
           <a:xfrm>
-            <a:off x="9539935" y="6473952"/>
+            <a:off x="9905695" y="6473952"/>
             <a:ext cx="82296" cy="82296"/>
           </a:xfrm>
           <a:prstGeom prst="ellipse">
@@ -3961,13 +3818,13 @@
       </p:sp>
       <p:sp>
         <p:nvSpPr>
-          <p:cNvPr id="14" name="Oval 13"/>
+          <p:cNvPr id="11" name="Oval 10"/>
           <p:cNvSpPr/>
           <p:nvPr/>
         </p:nvSpPr>
         <p:spPr>
           <a:xfrm>
-            <a:off x="9722815" y="6473952"/>
+            <a:off x="10088575" y="6473952"/>
             <a:ext cx="82296" cy="82296"/>
           </a:xfrm>
           <a:prstGeom prst="ellipse">
@@ -4005,13 +3862,13 @@
       </p:sp>
       <p:sp>
         <p:nvSpPr>
-          <p:cNvPr id="15" name="Oval 14"/>
+          <p:cNvPr id="12" name="Oval 11"/>
           <p:cNvSpPr/>
           <p:nvPr/>
         </p:nvSpPr>
         <p:spPr>
           <a:xfrm>
-            <a:off x="9905695" y="6473952"/>
+            <a:off x="10271455" y="6473952"/>
             <a:ext cx="82296" cy="82296"/>
           </a:xfrm>
           <a:prstGeom prst="ellipse">
@@ -4049,13 +3906,13 @@
       </p:sp>
       <p:sp>
         <p:nvSpPr>
-          <p:cNvPr id="16" name="Oval 15"/>
+          <p:cNvPr id="13" name="Oval 12"/>
           <p:cNvSpPr/>
           <p:nvPr/>
         </p:nvSpPr>
         <p:spPr>
           <a:xfrm>
-            <a:off x="10088575" y="6473952"/>
+            <a:off x="10454335" y="6473952"/>
             <a:ext cx="82296" cy="82296"/>
           </a:xfrm>
           <a:prstGeom prst="ellipse">
@@ -4093,13 +3950,13 @@
       </p:sp>
       <p:sp>
         <p:nvSpPr>
-          <p:cNvPr id="17" name="Oval 16"/>
+          <p:cNvPr id="14" name="Oval 13"/>
           <p:cNvSpPr/>
           <p:nvPr/>
         </p:nvSpPr>
         <p:spPr>
           <a:xfrm>
-            <a:off x="10271455" y="6473952"/>
+            <a:off x="10637215" y="6473952"/>
             <a:ext cx="82296" cy="82296"/>
           </a:xfrm>
           <a:prstGeom prst="ellipse">
@@ -4137,20 +3994,20 @@
       </p:sp>
       <p:sp>
         <p:nvSpPr>
-          <p:cNvPr id="18" name="Oval 17"/>
+          <p:cNvPr id="15" name="Oval 14"/>
           <p:cNvSpPr/>
           <p:nvPr/>
         </p:nvSpPr>
         <p:spPr>
           <a:xfrm>
-            <a:off x="10454335" y="6473952"/>
+            <a:off x="10820095" y="6473952"/>
             <a:ext cx="82296" cy="82296"/>
           </a:xfrm>
           <a:prstGeom prst="ellipse">
             <a:avLst/>
           </a:prstGeom>
           <a:solidFill>
-            <a:srgbClr val="DDE1DC"/>
+            <a:srgbClr val="2A5CAA"/>
           </a:solidFill>
           <a:ln>
             <a:noFill/>
@@ -4181,13 +4038,13 @@
       </p:sp>
       <p:sp>
         <p:nvSpPr>
-          <p:cNvPr id="19" name="Oval 18"/>
+          <p:cNvPr id="16" name="Oval 15"/>
           <p:cNvSpPr/>
           <p:nvPr/>
         </p:nvSpPr>
         <p:spPr>
           <a:xfrm>
-            <a:off x="10637215" y="6473952"/>
+            <a:off x="11002975" y="6473952"/>
             <a:ext cx="82296" cy="82296"/>
           </a:xfrm>
           <a:prstGeom prst="ellipse">
@@ -4225,13 +4082,13 @@
       </p:sp>
       <p:sp>
         <p:nvSpPr>
-          <p:cNvPr id="20" name="Oval 19"/>
+          <p:cNvPr id="17" name="Oval 16"/>
           <p:cNvSpPr/>
           <p:nvPr/>
         </p:nvSpPr>
         <p:spPr>
           <a:xfrm>
-            <a:off x="10820095" y="6473952"/>
+            <a:off x="11185855" y="6473952"/>
             <a:ext cx="82296" cy="82296"/>
           </a:xfrm>
           <a:prstGeom prst="ellipse">
@@ -4269,95 +4126,7 @@
       </p:sp>
       <p:sp>
         <p:nvSpPr>
-          <p:cNvPr id="21" name="Oval 20"/>
-          <p:cNvSpPr/>
-          <p:nvPr/>
-        </p:nvSpPr>
-        <p:spPr>
-          <a:xfrm>
-            <a:off x="11002975" y="6473952"/>
-            <a:ext cx="82296" cy="82296"/>
-          </a:xfrm>
-          <a:prstGeom prst="ellipse">
-            <a:avLst/>
-          </a:prstGeom>
-          <a:solidFill>
-            <a:srgbClr val="2A5CAA"/>
-          </a:solidFill>
-          <a:ln>
-            <a:noFill/>
-          </a:ln>
-          <a:effectLst/>
-        </p:spPr>
-        <p:style>
-          <a:lnRef idx="1">
-            <a:schemeClr val="accent1"/>
-          </a:lnRef>
-          <a:fillRef idx="3">
-            <a:schemeClr val="accent1"/>
-          </a:fillRef>
-          <a:effectRef idx="2">
-            <a:schemeClr val="accent1"/>
-          </a:effectRef>
-          <a:fontRef idx="minor">
-            <a:schemeClr val="lt1"/>
-          </a:fontRef>
-        </p:style>
-        <p:txBody>
-          <a:bodyPr rtlCol="0" anchor="ctr"/>
-          <a:lstStyle/>
-          <a:p>
-            <a:pPr algn="ctr"/>
-          </a:p>
-        </p:txBody>
-      </p:sp>
-      <p:sp>
-        <p:nvSpPr>
-          <p:cNvPr id="22" name="Oval 21"/>
-          <p:cNvSpPr/>
-          <p:nvPr/>
-        </p:nvSpPr>
-        <p:spPr>
-          <a:xfrm>
-            <a:off x="11185855" y="6473952"/>
-            <a:ext cx="82296" cy="82296"/>
-          </a:xfrm>
-          <a:prstGeom prst="ellipse">
-            <a:avLst/>
-          </a:prstGeom>
-          <a:solidFill>
-            <a:srgbClr val="DDE1DC"/>
-          </a:solidFill>
-          <a:ln>
-            <a:noFill/>
-          </a:ln>
-          <a:effectLst/>
-        </p:spPr>
-        <p:style>
-          <a:lnRef idx="1">
-            <a:schemeClr val="accent1"/>
-          </a:lnRef>
-          <a:fillRef idx="3">
-            <a:schemeClr val="accent1"/>
-          </a:fillRef>
-          <a:effectRef idx="2">
-            <a:schemeClr val="accent1"/>
-          </a:effectRef>
-          <a:fontRef idx="minor">
-            <a:schemeClr val="lt1"/>
-          </a:fontRef>
-        </p:style>
-        <p:txBody>
-          <a:bodyPr rtlCol="0" anchor="ctr"/>
-          <a:lstStyle/>
-          <a:p>
-            <a:pPr algn="ctr"/>
-          </a:p>
-        </p:txBody>
-      </p:sp>
-      <p:sp>
-        <p:nvSpPr>
-          <p:cNvPr id="23" name="TextBox 22"/>
+          <p:cNvPr id="18" name="TextBox 17"/>
           <p:cNvSpPr txBox="1"/>
           <p:nvPr/>
         </p:nvSpPr>
@@ -4389,7 +4158,7 @@
                 </a:solidFill>
                 <a:latin typeface="Arial"/>
               </a:rPr>
-              <a:t>9 / 10</a:t>
+              <a:t>9 / 11</a:t>
             </a:r>
           </a:p>
         </p:txBody>
@@ -4427,6 +4196,1008 @@
             <a:avLst/>
           </a:prstGeom>
           <a:solidFill>
+            <a:srgbClr val="FBFBF8"/>
+          </a:solidFill>
+          <a:ln>
+            <a:noFill/>
+          </a:ln>
+          <a:effectLst/>
+        </p:spPr>
+        <p:style>
+          <a:lnRef idx="1">
+            <a:schemeClr val="accent1"/>
+          </a:lnRef>
+          <a:fillRef idx="3">
+            <a:schemeClr val="accent1"/>
+          </a:fillRef>
+          <a:effectRef idx="2">
+            <a:schemeClr val="accent1"/>
+          </a:effectRef>
+          <a:fontRef idx="minor">
+            <a:schemeClr val="lt1"/>
+          </a:fontRef>
+        </p:style>
+        <p:txBody>
+          <a:bodyPr rtlCol="0" anchor="ctr"/>
+          <a:lstStyle/>
+          <a:p>
+            <a:pPr algn="ctr"/>
+          </a:p>
+        </p:txBody>
+      </p:sp>
+      <p:sp>
+        <p:nvSpPr>
+          <p:cNvPr id="3" name="TextBox 2"/>
+          <p:cNvSpPr txBox="1"/>
+          <p:nvPr/>
+        </p:nvSpPr>
+        <p:spPr>
+          <a:xfrm>
+            <a:off x="822960" y="502920"/>
+            <a:ext cx="10058400" cy="365760"/>
+          </a:xfrm>
+          <a:prstGeom prst="rect">
+            <a:avLst/>
+          </a:prstGeom>
+          <a:noFill/>
+        </p:spPr>
+        <p:txBody>
+          <a:bodyPr wrap="square">
+            <a:spAutoFit/>
+          </a:bodyPr>
+          <a:lstStyle/>
+          <a:p>
+            <a:pPr algn="l">
+              <a:lnSpc>
+                <a:spcPct val="110000"/>
+              </a:lnSpc>
+            </a:pPr>
+            <a:r>
+              <a:rPr sz="1300" b="1" i="0">
+                <a:solidFill>
+                  <a:srgbClr val="2A5CAA"/>
+                </a:solidFill>
+                <a:latin typeface="Arial"/>
+              </a:rPr>
+              <a:t>PUTTING IT TOGETHER</a:t>
+            </a:r>
+          </a:p>
+        </p:txBody>
+      </p:sp>
+      <p:sp>
+        <p:nvSpPr>
+          <p:cNvPr id="4" name="TextBox 3"/>
+          <p:cNvSpPr txBox="1"/>
+          <p:nvPr/>
+        </p:nvSpPr>
+        <p:spPr>
+          <a:xfrm>
+            <a:off x="822960" y="868680"/>
+            <a:ext cx="10515600" cy="822960"/>
+          </a:xfrm>
+          <a:prstGeom prst="rect">
+            <a:avLst/>
+          </a:prstGeom>
+          <a:noFill/>
+        </p:spPr>
+        <p:txBody>
+          <a:bodyPr wrap="square">
+            <a:spAutoFit/>
+          </a:bodyPr>
+          <a:lstStyle/>
+          <a:p>
+            <a:pPr algn="l">
+              <a:lnSpc>
+                <a:spcPct val="110000"/>
+              </a:lnSpc>
+            </a:pPr>
+            <a:r>
+              <a:rPr sz="2800" b="1" i="0">
+                <a:solidFill>
+                  <a:srgbClr val="1A1A1A"/>
+                </a:solidFill>
+                <a:latin typeface="Arial"/>
+              </a:rPr>
+              <a:t>Each phase pushed the best model further</a:t>
+            </a:r>
+          </a:p>
+        </p:txBody>
+      </p:sp>
+      <p:pic>
+        <p:nvPicPr>
+          <p:cNvPr id="5" name="Picture 4" descr="progress_by_phase.png"/>
+          <p:cNvPicPr>
+            <a:picLocks noChangeAspect="1"/>
+          </p:cNvPicPr>
+          <p:nvPr/>
+        </p:nvPicPr>
+        <p:blipFill>
+          <a:blip r:embed="rId2"/>
+          <a:stretch>
+            <a:fillRect/>
+          </a:stretch>
+        </p:blipFill>
+        <p:spPr>
+          <a:xfrm>
+            <a:off x="822960" y="1828800"/>
+            <a:ext cx="5486400" cy="3771900"/>
+          </a:xfrm>
+          <a:prstGeom prst="rect">
+            <a:avLst/>
+          </a:prstGeom>
+        </p:spPr>
+      </p:pic>
+      <p:sp>
+        <p:nvSpPr>
+          <p:cNvPr id="6" name="Oval 5"/>
+          <p:cNvSpPr/>
+          <p:nvPr/>
+        </p:nvSpPr>
+        <p:spPr>
+          <a:xfrm>
+            <a:off x="6675120" y="2377440"/>
+            <a:ext cx="292608" cy="292608"/>
+          </a:xfrm>
+          <a:prstGeom prst="ellipse">
+            <a:avLst/>
+          </a:prstGeom>
+          <a:solidFill>
+            <a:srgbClr val="2A5CAA"/>
+          </a:solidFill>
+          <a:ln>
+            <a:noFill/>
+          </a:ln>
+          <a:effectLst/>
+        </p:spPr>
+        <p:style>
+          <a:lnRef idx="1">
+            <a:schemeClr val="accent1"/>
+          </a:lnRef>
+          <a:fillRef idx="3">
+            <a:schemeClr val="accent1"/>
+          </a:fillRef>
+          <a:effectRef idx="2">
+            <a:schemeClr val="accent1"/>
+          </a:effectRef>
+          <a:fontRef idx="minor">
+            <a:schemeClr val="lt1"/>
+          </a:fontRef>
+        </p:style>
+        <p:txBody>
+          <a:bodyPr rtlCol="0" anchor="ctr" wrap="none"/>
+          <a:lstStyle/>
+          <a:p>
+            <a:pPr algn="ctr"/>
+            <a:r>
+              <a:rPr sz="1300" b="1">
+                <a:solidFill>
+                  <a:srgbClr val="142340"/>
+                </a:solidFill>
+                <a:latin typeface="Arial"/>
+              </a:rPr>
+              <a:t>✓</a:t>
+            </a:r>
+          </a:p>
+        </p:txBody>
+      </p:sp>
+      <p:sp>
+        <p:nvSpPr>
+          <p:cNvPr id="7" name="TextBox 6"/>
+          <p:cNvSpPr txBox="1"/>
+          <p:nvPr/>
+        </p:nvSpPr>
+        <p:spPr>
+          <a:xfrm>
+            <a:off x="7132320" y="2350008"/>
+            <a:ext cx="4206240" cy="566928"/>
+          </a:xfrm>
+          <a:prstGeom prst="rect">
+            <a:avLst/>
+          </a:prstGeom>
+          <a:noFill/>
+        </p:spPr>
+        <p:txBody>
+          <a:bodyPr wrap="square">
+            <a:spAutoFit/>
+          </a:bodyPr>
+          <a:lstStyle/>
+          <a:p>
+            <a:pPr algn="l">
+              <a:lnSpc>
+                <a:spcPct val="115000"/>
+              </a:lnSpc>
+            </a:pPr>
+            <a:r>
+              <a:rPr sz="1500" b="0" i="0">
+                <a:solidFill>
+                  <a:srgbClr val="1A1A1A"/>
+                </a:solidFill>
+                <a:latin typeface="Arial"/>
+              </a:rPr>
+              <a:t>Phase 1: Doc2Vec + Logistic Regression, paper's default settings — 59.1%</a:t>
+            </a:r>
+          </a:p>
+        </p:txBody>
+      </p:sp>
+      <p:sp>
+        <p:nvSpPr>
+          <p:cNvPr id="8" name="Oval 7"/>
+          <p:cNvSpPr/>
+          <p:nvPr/>
+        </p:nvSpPr>
+        <p:spPr>
+          <a:xfrm>
+            <a:off x="6675120" y="2944368"/>
+            <a:ext cx="292608" cy="292608"/>
+          </a:xfrm>
+          <a:prstGeom prst="ellipse">
+            <a:avLst/>
+          </a:prstGeom>
+          <a:solidFill>
+            <a:srgbClr val="2A5CAA"/>
+          </a:solidFill>
+          <a:ln>
+            <a:noFill/>
+          </a:ln>
+          <a:effectLst/>
+        </p:spPr>
+        <p:style>
+          <a:lnRef idx="1">
+            <a:schemeClr val="accent1"/>
+          </a:lnRef>
+          <a:fillRef idx="3">
+            <a:schemeClr val="accent1"/>
+          </a:fillRef>
+          <a:effectRef idx="2">
+            <a:schemeClr val="accent1"/>
+          </a:effectRef>
+          <a:fontRef idx="minor">
+            <a:schemeClr val="lt1"/>
+          </a:fontRef>
+        </p:style>
+        <p:txBody>
+          <a:bodyPr rtlCol="0" anchor="ctr" wrap="none"/>
+          <a:lstStyle/>
+          <a:p>
+            <a:pPr algn="ctr"/>
+            <a:r>
+              <a:rPr sz="1300" b="1">
+                <a:solidFill>
+                  <a:srgbClr val="142340"/>
+                </a:solidFill>
+                <a:latin typeface="Arial"/>
+              </a:rPr>
+              <a:t>✓</a:t>
+            </a:r>
+          </a:p>
+        </p:txBody>
+      </p:sp>
+      <p:sp>
+        <p:nvSpPr>
+          <p:cNvPr id="9" name="TextBox 8"/>
+          <p:cNvSpPr txBox="1"/>
+          <p:nvPr/>
+        </p:nvSpPr>
+        <p:spPr>
+          <a:xfrm>
+            <a:off x="7132320" y="2916936"/>
+            <a:ext cx="4206240" cy="566928"/>
+          </a:xfrm>
+          <a:prstGeom prst="rect">
+            <a:avLst/>
+          </a:prstGeom>
+          <a:noFill/>
+        </p:spPr>
+        <p:txBody>
+          <a:bodyPr wrap="square">
+            <a:spAutoFit/>
+          </a:bodyPr>
+          <a:lstStyle/>
+          <a:p>
+            <a:pPr algn="l">
+              <a:lnSpc>
+                <a:spcPct val="115000"/>
+              </a:lnSpc>
+            </a:pPr>
+            <a:r>
+              <a:rPr sz="1500" b="0" i="0">
+                <a:solidFill>
+                  <a:srgbClr val="1A1A1A"/>
+                </a:solidFill>
+                <a:latin typeface="Arial"/>
+              </a:rPr>
+              <a:t>Phase 2: tuned vector_size (100→50) and C on dev only — 62.2%</a:t>
+            </a:r>
+          </a:p>
+        </p:txBody>
+      </p:sp>
+      <p:sp>
+        <p:nvSpPr>
+          <p:cNvPr id="10" name="Oval 9"/>
+          <p:cNvSpPr/>
+          <p:nvPr/>
+        </p:nvSpPr>
+        <p:spPr>
+          <a:xfrm>
+            <a:off x="6675120" y="3511296"/>
+            <a:ext cx="292608" cy="292608"/>
+          </a:xfrm>
+          <a:prstGeom prst="ellipse">
+            <a:avLst/>
+          </a:prstGeom>
+          <a:solidFill>
+            <a:srgbClr val="2A5CAA"/>
+          </a:solidFill>
+          <a:ln>
+            <a:noFill/>
+          </a:ln>
+          <a:effectLst/>
+        </p:spPr>
+        <p:style>
+          <a:lnRef idx="1">
+            <a:schemeClr val="accent1"/>
+          </a:lnRef>
+          <a:fillRef idx="3">
+            <a:schemeClr val="accent1"/>
+          </a:fillRef>
+          <a:effectRef idx="2">
+            <a:schemeClr val="accent1"/>
+          </a:effectRef>
+          <a:fontRef idx="minor">
+            <a:schemeClr val="lt1"/>
+          </a:fontRef>
+        </p:style>
+        <p:txBody>
+          <a:bodyPr rtlCol="0" anchor="ctr" wrap="none"/>
+          <a:lstStyle/>
+          <a:p>
+            <a:pPr algn="ctr"/>
+            <a:r>
+              <a:rPr sz="1300" b="1">
+                <a:solidFill>
+                  <a:srgbClr val="142340"/>
+                </a:solidFill>
+                <a:latin typeface="Arial"/>
+              </a:rPr>
+              <a:t>✓</a:t>
+            </a:r>
+          </a:p>
+        </p:txBody>
+      </p:sp>
+      <p:sp>
+        <p:nvSpPr>
+          <p:cNvPr id="11" name="TextBox 10"/>
+          <p:cNvSpPr txBox="1"/>
+          <p:nvPr/>
+        </p:nvSpPr>
+        <p:spPr>
+          <a:xfrm>
+            <a:off x="7132320" y="3483864"/>
+            <a:ext cx="4206240" cy="566928"/>
+          </a:xfrm>
+          <a:prstGeom prst="rect">
+            <a:avLst/>
+          </a:prstGeom>
+          <a:noFill/>
+        </p:spPr>
+        <p:txBody>
+          <a:bodyPr wrap="square">
+            <a:spAutoFit/>
+          </a:bodyPr>
+          <a:lstStyle/>
+          <a:p>
+            <a:pPr algn="l">
+              <a:lnSpc>
+                <a:spcPct val="115000"/>
+              </a:lnSpc>
+            </a:pPr>
+            <a:r>
+              <a:rPr sz="1500" b="0" i="0">
+                <a:solidFill>
+                  <a:srgbClr val="1A1A1A"/>
+                </a:solidFill>
+                <a:latin typeface="Arial"/>
+              </a:rPr>
+              <a:t>Phase 3: swapped in SVM (RBF kernel) on the same features — 68.8%</a:t>
+            </a:r>
+          </a:p>
+        </p:txBody>
+      </p:sp>
+      <p:sp>
+        <p:nvSpPr>
+          <p:cNvPr id="12" name="TextBox 11"/>
+          <p:cNvSpPr txBox="1"/>
+          <p:nvPr/>
+        </p:nvSpPr>
+        <p:spPr>
+          <a:xfrm>
+            <a:off x="6675120" y="4846320"/>
+            <a:ext cx="4663440" cy="1097280"/>
+          </a:xfrm>
+          <a:prstGeom prst="rect">
+            <a:avLst/>
+          </a:prstGeom>
+          <a:noFill/>
+        </p:spPr>
+        <p:txBody>
+          <a:bodyPr wrap="square">
+            <a:spAutoFit/>
+          </a:bodyPr>
+          <a:lstStyle/>
+          <a:p>
+            <a:pPr algn="l">
+              <a:lnSpc>
+                <a:spcPct val="130000"/>
+              </a:lnSpc>
+            </a:pPr>
+            <a:r>
+              <a:rPr sz="1400" b="0" i="1">
+                <a:solidFill>
+                  <a:srgbClr val="4A5568"/>
+                </a:solidFill>
+                <a:latin typeface="Arial"/>
+              </a:rPr>
+              <a:t>Nearly 10 points of accuracy gained beyond the paper's own result, without touching the dataset.</a:t>
+            </a:r>
+          </a:p>
+        </p:txBody>
+      </p:sp>
+      <p:sp>
+        <p:nvSpPr>
+          <p:cNvPr id="13" name="Oval 12"/>
+          <p:cNvSpPr/>
+          <p:nvPr/>
+        </p:nvSpPr>
+        <p:spPr>
+          <a:xfrm>
+            <a:off x="9357055" y="6473952"/>
+            <a:ext cx="82296" cy="82296"/>
+          </a:xfrm>
+          <a:prstGeom prst="ellipse">
+            <a:avLst/>
+          </a:prstGeom>
+          <a:solidFill>
+            <a:srgbClr val="DDE1DC"/>
+          </a:solidFill>
+          <a:ln>
+            <a:noFill/>
+          </a:ln>
+          <a:effectLst/>
+        </p:spPr>
+        <p:style>
+          <a:lnRef idx="1">
+            <a:schemeClr val="accent1"/>
+          </a:lnRef>
+          <a:fillRef idx="3">
+            <a:schemeClr val="accent1"/>
+          </a:fillRef>
+          <a:effectRef idx="2">
+            <a:schemeClr val="accent1"/>
+          </a:effectRef>
+          <a:fontRef idx="minor">
+            <a:schemeClr val="lt1"/>
+          </a:fontRef>
+        </p:style>
+        <p:txBody>
+          <a:bodyPr rtlCol="0" anchor="ctr"/>
+          <a:lstStyle/>
+          <a:p>
+            <a:pPr algn="ctr"/>
+          </a:p>
+        </p:txBody>
+      </p:sp>
+      <p:sp>
+        <p:nvSpPr>
+          <p:cNvPr id="14" name="Oval 13"/>
+          <p:cNvSpPr/>
+          <p:nvPr/>
+        </p:nvSpPr>
+        <p:spPr>
+          <a:xfrm>
+            <a:off x="9539935" y="6473952"/>
+            <a:ext cx="82296" cy="82296"/>
+          </a:xfrm>
+          <a:prstGeom prst="ellipse">
+            <a:avLst/>
+          </a:prstGeom>
+          <a:solidFill>
+            <a:srgbClr val="DDE1DC"/>
+          </a:solidFill>
+          <a:ln>
+            <a:noFill/>
+          </a:ln>
+          <a:effectLst/>
+        </p:spPr>
+        <p:style>
+          <a:lnRef idx="1">
+            <a:schemeClr val="accent1"/>
+          </a:lnRef>
+          <a:fillRef idx="3">
+            <a:schemeClr val="accent1"/>
+          </a:fillRef>
+          <a:effectRef idx="2">
+            <a:schemeClr val="accent1"/>
+          </a:effectRef>
+          <a:fontRef idx="minor">
+            <a:schemeClr val="lt1"/>
+          </a:fontRef>
+        </p:style>
+        <p:txBody>
+          <a:bodyPr rtlCol="0" anchor="ctr"/>
+          <a:lstStyle/>
+          <a:p>
+            <a:pPr algn="ctr"/>
+          </a:p>
+        </p:txBody>
+      </p:sp>
+      <p:sp>
+        <p:nvSpPr>
+          <p:cNvPr id="15" name="Oval 14"/>
+          <p:cNvSpPr/>
+          <p:nvPr/>
+        </p:nvSpPr>
+        <p:spPr>
+          <a:xfrm>
+            <a:off x="9722815" y="6473952"/>
+            <a:ext cx="82296" cy="82296"/>
+          </a:xfrm>
+          <a:prstGeom prst="ellipse">
+            <a:avLst/>
+          </a:prstGeom>
+          <a:solidFill>
+            <a:srgbClr val="DDE1DC"/>
+          </a:solidFill>
+          <a:ln>
+            <a:noFill/>
+          </a:ln>
+          <a:effectLst/>
+        </p:spPr>
+        <p:style>
+          <a:lnRef idx="1">
+            <a:schemeClr val="accent1"/>
+          </a:lnRef>
+          <a:fillRef idx="3">
+            <a:schemeClr val="accent1"/>
+          </a:fillRef>
+          <a:effectRef idx="2">
+            <a:schemeClr val="accent1"/>
+          </a:effectRef>
+          <a:fontRef idx="minor">
+            <a:schemeClr val="lt1"/>
+          </a:fontRef>
+        </p:style>
+        <p:txBody>
+          <a:bodyPr rtlCol="0" anchor="ctr"/>
+          <a:lstStyle/>
+          <a:p>
+            <a:pPr algn="ctr"/>
+          </a:p>
+        </p:txBody>
+      </p:sp>
+      <p:sp>
+        <p:nvSpPr>
+          <p:cNvPr id="16" name="Oval 15"/>
+          <p:cNvSpPr/>
+          <p:nvPr/>
+        </p:nvSpPr>
+        <p:spPr>
+          <a:xfrm>
+            <a:off x="9905695" y="6473952"/>
+            <a:ext cx="82296" cy="82296"/>
+          </a:xfrm>
+          <a:prstGeom prst="ellipse">
+            <a:avLst/>
+          </a:prstGeom>
+          <a:solidFill>
+            <a:srgbClr val="DDE1DC"/>
+          </a:solidFill>
+          <a:ln>
+            <a:noFill/>
+          </a:ln>
+          <a:effectLst/>
+        </p:spPr>
+        <p:style>
+          <a:lnRef idx="1">
+            <a:schemeClr val="accent1"/>
+          </a:lnRef>
+          <a:fillRef idx="3">
+            <a:schemeClr val="accent1"/>
+          </a:fillRef>
+          <a:effectRef idx="2">
+            <a:schemeClr val="accent1"/>
+          </a:effectRef>
+          <a:fontRef idx="minor">
+            <a:schemeClr val="lt1"/>
+          </a:fontRef>
+        </p:style>
+        <p:txBody>
+          <a:bodyPr rtlCol="0" anchor="ctr"/>
+          <a:lstStyle/>
+          <a:p>
+            <a:pPr algn="ctr"/>
+          </a:p>
+        </p:txBody>
+      </p:sp>
+      <p:sp>
+        <p:nvSpPr>
+          <p:cNvPr id="17" name="Oval 16"/>
+          <p:cNvSpPr/>
+          <p:nvPr/>
+        </p:nvSpPr>
+        <p:spPr>
+          <a:xfrm>
+            <a:off x="10088575" y="6473952"/>
+            <a:ext cx="82296" cy="82296"/>
+          </a:xfrm>
+          <a:prstGeom prst="ellipse">
+            <a:avLst/>
+          </a:prstGeom>
+          <a:solidFill>
+            <a:srgbClr val="DDE1DC"/>
+          </a:solidFill>
+          <a:ln>
+            <a:noFill/>
+          </a:ln>
+          <a:effectLst/>
+        </p:spPr>
+        <p:style>
+          <a:lnRef idx="1">
+            <a:schemeClr val="accent1"/>
+          </a:lnRef>
+          <a:fillRef idx="3">
+            <a:schemeClr val="accent1"/>
+          </a:fillRef>
+          <a:effectRef idx="2">
+            <a:schemeClr val="accent1"/>
+          </a:effectRef>
+          <a:fontRef idx="minor">
+            <a:schemeClr val="lt1"/>
+          </a:fontRef>
+        </p:style>
+        <p:txBody>
+          <a:bodyPr rtlCol="0" anchor="ctr"/>
+          <a:lstStyle/>
+          <a:p>
+            <a:pPr algn="ctr"/>
+          </a:p>
+        </p:txBody>
+      </p:sp>
+      <p:sp>
+        <p:nvSpPr>
+          <p:cNvPr id="18" name="Oval 17"/>
+          <p:cNvSpPr/>
+          <p:nvPr/>
+        </p:nvSpPr>
+        <p:spPr>
+          <a:xfrm>
+            <a:off x="10271455" y="6473952"/>
+            <a:ext cx="82296" cy="82296"/>
+          </a:xfrm>
+          <a:prstGeom prst="ellipse">
+            <a:avLst/>
+          </a:prstGeom>
+          <a:solidFill>
+            <a:srgbClr val="DDE1DC"/>
+          </a:solidFill>
+          <a:ln>
+            <a:noFill/>
+          </a:ln>
+          <a:effectLst/>
+        </p:spPr>
+        <p:style>
+          <a:lnRef idx="1">
+            <a:schemeClr val="accent1"/>
+          </a:lnRef>
+          <a:fillRef idx="3">
+            <a:schemeClr val="accent1"/>
+          </a:fillRef>
+          <a:effectRef idx="2">
+            <a:schemeClr val="accent1"/>
+          </a:effectRef>
+          <a:fontRef idx="minor">
+            <a:schemeClr val="lt1"/>
+          </a:fontRef>
+        </p:style>
+        <p:txBody>
+          <a:bodyPr rtlCol="0" anchor="ctr"/>
+          <a:lstStyle/>
+          <a:p>
+            <a:pPr algn="ctr"/>
+          </a:p>
+        </p:txBody>
+      </p:sp>
+      <p:sp>
+        <p:nvSpPr>
+          <p:cNvPr id="19" name="Oval 18"/>
+          <p:cNvSpPr/>
+          <p:nvPr/>
+        </p:nvSpPr>
+        <p:spPr>
+          <a:xfrm>
+            <a:off x="10454335" y="6473952"/>
+            <a:ext cx="82296" cy="82296"/>
+          </a:xfrm>
+          <a:prstGeom prst="ellipse">
+            <a:avLst/>
+          </a:prstGeom>
+          <a:solidFill>
+            <a:srgbClr val="DDE1DC"/>
+          </a:solidFill>
+          <a:ln>
+            <a:noFill/>
+          </a:ln>
+          <a:effectLst/>
+        </p:spPr>
+        <p:style>
+          <a:lnRef idx="1">
+            <a:schemeClr val="accent1"/>
+          </a:lnRef>
+          <a:fillRef idx="3">
+            <a:schemeClr val="accent1"/>
+          </a:fillRef>
+          <a:effectRef idx="2">
+            <a:schemeClr val="accent1"/>
+          </a:effectRef>
+          <a:fontRef idx="minor">
+            <a:schemeClr val="lt1"/>
+          </a:fontRef>
+        </p:style>
+        <p:txBody>
+          <a:bodyPr rtlCol="0" anchor="ctr"/>
+          <a:lstStyle/>
+          <a:p>
+            <a:pPr algn="ctr"/>
+          </a:p>
+        </p:txBody>
+      </p:sp>
+      <p:sp>
+        <p:nvSpPr>
+          <p:cNvPr id="20" name="Oval 19"/>
+          <p:cNvSpPr/>
+          <p:nvPr/>
+        </p:nvSpPr>
+        <p:spPr>
+          <a:xfrm>
+            <a:off x="10637215" y="6473952"/>
+            <a:ext cx="82296" cy="82296"/>
+          </a:xfrm>
+          <a:prstGeom prst="ellipse">
+            <a:avLst/>
+          </a:prstGeom>
+          <a:solidFill>
+            <a:srgbClr val="DDE1DC"/>
+          </a:solidFill>
+          <a:ln>
+            <a:noFill/>
+          </a:ln>
+          <a:effectLst/>
+        </p:spPr>
+        <p:style>
+          <a:lnRef idx="1">
+            <a:schemeClr val="accent1"/>
+          </a:lnRef>
+          <a:fillRef idx="3">
+            <a:schemeClr val="accent1"/>
+          </a:fillRef>
+          <a:effectRef idx="2">
+            <a:schemeClr val="accent1"/>
+          </a:effectRef>
+          <a:fontRef idx="minor">
+            <a:schemeClr val="lt1"/>
+          </a:fontRef>
+        </p:style>
+        <p:txBody>
+          <a:bodyPr rtlCol="0" anchor="ctr"/>
+          <a:lstStyle/>
+          <a:p>
+            <a:pPr algn="ctr"/>
+          </a:p>
+        </p:txBody>
+      </p:sp>
+      <p:sp>
+        <p:nvSpPr>
+          <p:cNvPr id="21" name="Oval 20"/>
+          <p:cNvSpPr/>
+          <p:nvPr/>
+        </p:nvSpPr>
+        <p:spPr>
+          <a:xfrm>
+            <a:off x="10820095" y="6473952"/>
+            <a:ext cx="82296" cy="82296"/>
+          </a:xfrm>
+          <a:prstGeom prst="ellipse">
+            <a:avLst/>
+          </a:prstGeom>
+          <a:solidFill>
+            <a:srgbClr val="DDE1DC"/>
+          </a:solidFill>
+          <a:ln>
+            <a:noFill/>
+          </a:ln>
+          <a:effectLst/>
+        </p:spPr>
+        <p:style>
+          <a:lnRef idx="1">
+            <a:schemeClr val="accent1"/>
+          </a:lnRef>
+          <a:fillRef idx="3">
+            <a:schemeClr val="accent1"/>
+          </a:fillRef>
+          <a:effectRef idx="2">
+            <a:schemeClr val="accent1"/>
+          </a:effectRef>
+          <a:fontRef idx="minor">
+            <a:schemeClr val="lt1"/>
+          </a:fontRef>
+        </p:style>
+        <p:txBody>
+          <a:bodyPr rtlCol="0" anchor="ctr"/>
+          <a:lstStyle/>
+          <a:p>
+            <a:pPr algn="ctr"/>
+          </a:p>
+        </p:txBody>
+      </p:sp>
+      <p:sp>
+        <p:nvSpPr>
+          <p:cNvPr id="22" name="Oval 21"/>
+          <p:cNvSpPr/>
+          <p:nvPr/>
+        </p:nvSpPr>
+        <p:spPr>
+          <a:xfrm>
+            <a:off x="11002975" y="6473952"/>
+            <a:ext cx="82296" cy="82296"/>
+          </a:xfrm>
+          <a:prstGeom prst="ellipse">
+            <a:avLst/>
+          </a:prstGeom>
+          <a:solidFill>
+            <a:srgbClr val="2A5CAA"/>
+          </a:solidFill>
+          <a:ln>
+            <a:noFill/>
+          </a:ln>
+          <a:effectLst/>
+        </p:spPr>
+        <p:style>
+          <a:lnRef idx="1">
+            <a:schemeClr val="accent1"/>
+          </a:lnRef>
+          <a:fillRef idx="3">
+            <a:schemeClr val="accent1"/>
+          </a:fillRef>
+          <a:effectRef idx="2">
+            <a:schemeClr val="accent1"/>
+          </a:effectRef>
+          <a:fontRef idx="minor">
+            <a:schemeClr val="lt1"/>
+          </a:fontRef>
+        </p:style>
+        <p:txBody>
+          <a:bodyPr rtlCol="0" anchor="ctr"/>
+          <a:lstStyle/>
+          <a:p>
+            <a:pPr algn="ctr"/>
+          </a:p>
+        </p:txBody>
+      </p:sp>
+      <p:sp>
+        <p:nvSpPr>
+          <p:cNvPr id="23" name="Oval 22"/>
+          <p:cNvSpPr/>
+          <p:nvPr/>
+        </p:nvSpPr>
+        <p:spPr>
+          <a:xfrm>
+            <a:off x="11185855" y="6473952"/>
+            <a:ext cx="82296" cy="82296"/>
+          </a:xfrm>
+          <a:prstGeom prst="ellipse">
+            <a:avLst/>
+          </a:prstGeom>
+          <a:solidFill>
+            <a:srgbClr val="DDE1DC"/>
+          </a:solidFill>
+          <a:ln>
+            <a:noFill/>
+          </a:ln>
+          <a:effectLst/>
+        </p:spPr>
+        <p:style>
+          <a:lnRef idx="1">
+            <a:schemeClr val="accent1"/>
+          </a:lnRef>
+          <a:fillRef idx="3">
+            <a:schemeClr val="accent1"/>
+          </a:fillRef>
+          <a:effectRef idx="2">
+            <a:schemeClr val="accent1"/>
+          </a:effectRef>
+          <a:fontRef idx="minor">
+            <a:schemeClr val="lt1"/>
+          </a:fontRef>
+        </p:style>
+        <p:txBody>
+          <a:bodyPr rtlCol="0" anchor="ctr"/>
+          <a:lstStyle/>
+          <a:p>
+            <a:pPr algn="ctr"/>
+          </a:p>
+        </p:txBody>
+      </p:sp>
+      <p:sp>
+        <p:nvSpPr>
+          <p:cNvPr id="24" name="TextBox 23"/>
+          <p:cNvSpPr txBox="1"/>
+          <p:nvPr/>
+        </p:nvSpPr>
+        <p:spPr>
+          <a:xfrm>
+            <a:off x="822960" y="6355080"/>
+            <a:ext cx="1828800" cy="365760"/>
+          </a:xfrm>
+          <a:prstGeom prst="rect">
+            <a:avLst/>
+          </a:prstGeom>
+          <a:noFill/>
+        </p:spPr>
+        <p:txBody>
+          <a:bodyPr wrap="square">
+            <a:spAutoFit/>
+          </a:bodyPr>
+          <a:lstStyle/>
+          <a:p>
+            <a:pPr algn="l">
+              <a:lnSpc>
+                <a:spcPct val="110000"/>
+              </a:lnSpc>
+            </a:pPr>
+            <a:r>
+              <a:rPr sz="1100" b="0" i="0">
+                <a:solidFill>
+                  <a:srgbClr val="6A7179"/>
+                </a:solidFill>
+                <a:latin typeface="Arial"/>
+              </a:rPr>
+              <a:t>10 / 11</a:t>
+            </a:r>
+          </a:p>
+        </p:txBody>
+      </p:sp>
+    </p:spTree>
+  </p:cSld>
+  <p:clrMapOvr>
+    <a:masterClrMapping/>
+  </p:clrMapOvr>
+</p:sld>
+</file>
+
+<file path=ppt/slides/slide12.xml><?xml version="1.0" encoding="utf-8"?>
+<p:sld xmlns:a="http://schemas.openxmlformats.org/drawingml/2006/main" xmlns:p="http://schemas.openxmlformats.org/presentationml/2006/main" xmlns:r="http://schemas.openxmlformats.org/officeDocument/2006/relationships">
+  <p:cSld>
+    <p:spTree>
+      <p:nvGrpSpPr>
+        <p:cNvPr id="1" name=""/>
+        <p:cNvGrpSpPr/>
+        <p:nvPr/>
+      </p:nvGrpSpPr>
+      <p:grpSpPr/>
+      <p:sp>
+        <p:nvSpPr>
+          <p:cNvPr id="2" name="Rectangle 1"/>
+          <p:cNvSpPr/>
+          <p:nvPr/>
+        </p:nvSpPr>
+        <p:spPr>
+          <a:xfrm>
+            <a:off x="0" y="0"/>
+            <a:ext cx="12191695" cy="6858000"/>
+          </a:xfrm>
+          <a:prstGeom prst="rect">
+            <a:avLst/>
+          </a:prstGeom>
+          <a:solidFill>
             <a:srgbClr val="142340"/>
           </a:solidFill>
           <a:ln>
@@ -5186,7 +5957,7 @@
         </p:nvSpPr>
         <p:spPr>
           <a:xfrm>
-            <a:off x="9539935" y="6473952"/>
+            <a:off x="9357055" y="6473952"/>
             <a:ext cx="82296" cy="82296"/>
           </a:xfrm>
           <a:prstGeom prst="ellipse">
@@ -5230,7 +6001,7 @@
         </p:nvSpPr>
         <p:spPr>
           <a:xfrm>
-            <a:off x="9722815" y="6473952"/>
+            <a:off x="9539935" y="6473952"/>
             <a:ext cx="82296" cy="82296"/>
           </a:xfrm>
           <a:prstGeom prst="ellipse">
@@ -5274,7 +6045,7 @@
         </p:nvSpPr>
         <p:spPr>
           <a:xfrm>
-            <a:off x="9905695" y="6473952"/>
+            <a:off x="9722815" y="6473952"/>
             <a:ext cx="82296" cy="82296"/>
           </a:xfrm>
           <a:prstGeom prst="ellipse">
@@ -5318,7 +6089,7 @@
         </p:nvSpPr>
         <p:spPr>
           <a:xfrm>
-            <a:off x="10088575" y="6473952"/>
+            <a:off x="9905695" y="6473952"/>
             <a:ext cx="82296" cy="82296"/>
           </a:xfrm>
           <a:prstGeom prst="ellipse">
@@ -5362,7 +6133,7 @@
         </p:nvSpPr>
         <p:spPr>
           <a:xfrm>
-            <a:off x="10271455" y="6473952"/>
+            <a:off x="10088575" y="6473952"/>
             <a:ext cx="82296" cy="82296"/>
           </a:xfrm>
           <a:prstGeom prst="ellipse">
@@ -5406,7 +6177,7 @@
         </p:nvSpPr>
         <p:spPr>
           <a:xfrm>
-            <a:off x="10454335" y="6473952"/>
+            <a:off x="10271455" y="6473952"/>
             <a:ext cx="82296" cy="82296"/>
           </a:xfrm>
           <a:prstGeom prst="ellipse">
@@ -5450,7 +6221,7 @@
         </p:nvSpPr>
         <p:spPr>
           <a:xfrm>
-            <a:off x="10637215" y="6473952"/>
+            <a:off x="10454335" y="6473952"/>
             <a:ext cx="82296" cy="82296"/>
           </a:xfrm>
           <a:prstGeom prst="ellipse">
@@ -5494,7 +6265,7 @@
         </p:nvSpPr>
         <p:spPr>
           <a:xfrm>
-            <a:off x="10820095" y="6473952"/>
+            <a:off x="10637215" y="6473952"/>
             <a:ext cx="82296" cy="82296"/>
           </a:xfrm>
           <a:prstGeom prst="ellipse">
@@ -5538,7 +6309,7 @@
         </p:nvSpPr>
         <p:spPr>
           <a:xfrm>
-            <a:off x="11002975" y="6473952"/>
+            <a:off x="10820095" y="6473952"/>
             <a:ext cx="82296" cy="82296"/>
           </a:xfrm>
           <a:prstGeom prst="ellipse">
@@ -5582,14 +6353,14 @@
         </p:nvSpPr>
         <p:spPr>
           <a:xfrm>
-            <a:off x="11185855" y="6473952"/>
+            <a:off x="11002975" y="6473952"/>
             <a:ext cx="82296" cy="82296"/>
           </a:xfrm>
           <a:prstGeom prst="ellipse">
             <a:avLst/>
           </a:prstGeom>
           <a:solidFill>
-            <a:srgbClr val="8FB4FF"/>
+            <a:srgbClr val="2A3C60"/>
           </a:solidFill>
           <a:ln>
             <a:noFill/>
@@ -5620,7 +6391,51 @@
       </p:sp>
       <p:sp>
         <p:nvSpPr>
-          <p:cNvPr id="29" name="TextBox 28"/>
+          <p:cNvPr id="29" name="Oval 28"/>
+          <p:cNvSpPr/>
+          <p:nvPr/>
+        </p:nvSpPr>
+        <p:spPr>
+          <a:xfrm>
+            <a:off x="11185855" y="6473952"/>
+            <a:ext cx="82296" cy="82296"/>
+          </a:xfrm>
+          <a:prstGeom prst="ellipse">
+            <a:avLst/>
+          </a:prstGeom>
+          <a:solidFill>
+            <a:srgbClr val="8FB4FF"/>
+          </a:solidFill>
+          <a:ln>
+            <a:noFill/>
+          </a:ln>
+          <a:effectLst/>
+        </p:spPr>
+        <p:style>
+          <a:lnRef idx="1">
+            <a:schemeClr val="accent1"/>
+          </a:lnRef>
+          <a:fillRef idx="3">
+            <a:schemeClr val="accent1"/>
+          </a:fillRef>
+          <a:effectRef idx="2">
+            <a:schemeClr val="accent1"/>
+          </a:effectRef>
+          <a:fontRef idx="minor">
+            <a:schemeClr val="lt1"/>
+          </a:fontRef>
+        </p:style>
+        <p:txBody>
+          <a:bodyPr rtlCol="0" anchor="ctr"/>
+          <a:lstStyle/>
+          <a:p>
+            <a:pPr algn="ctr"/>
+          </a:p>
+        </p:txBody>
+      </p:sp>
+      <p:sp>
+        <p:nvSpPr>
+          <p:cNvPr id="30" name="TextBox 29"/>
           <p:cNvSpPr txBox="1"/>
           <p:nvPr/>
         </p:nvSpPr>
@@ -5652,7 +6467,7 @@
                 </a:solidFill>
                 <a:latin typeface="Arial"/>
               </a:rPr>
-              <a:t>10 / 10</a:t>
+              <a:t>11 / 11</a:t>
             </a:r>
           </a:p>
         </p:txBody>
@@ -6088,7 +6903,7 @@
         </p:nvSpPr>
         <p:spPr>
           <a:xfrm>
-            <a:off x="9539935" y="6473952"/>
+            <a:off x="9357055" y="6473952"/>
             <a:ext cx="82296" cy="82296"/>
           </a:xfrm>
           <a:prstGeom prst="ellipse">
@@ -6132,7 +6947,7 @@
         </p:nvSpPr>
         <p:spPr>
           <a:xfrm>
-            <a:off x="9722815" y="6473952"/>
+            <a:off x="9539935" y="6473952"/>
             <a:ext cx="82296" cy="82296"/>
           </a:xfrm>
           <a:prstGeom prst="ellipse">
@@ -6176,7 +6991,7 @@
         </p:nvSpPr>
         <p:spPr>
           <a:xfrm>
-            <a:off x="9905695" y="6473952"/>
+            <a:off x="9722815" y="6473952"/>
             <a:ext cx="82296" cy="82296"/>
           </a:xfrm>
           <a:prstGeom prst="ellipse">
@@ -6220,7 +7035,7 @@
         </p:nvSpPr>
         <p:spPr>
           <a:xfrm>
-            <a:off x="10088575" y="6473952"/>
+            <a:off x="9905695" y="6473952"/>
             <a:ext cx="82296" cy="82296"/>
           </a:xfrm>
           <a:prstGeom prst="ellipse">
@@ -6264,7 +7079,7 @@
         </p:nvSpPr>
         <p:spPr>
           <a:xfrm>
-            <a:off x="10271455" y="6473952"/>
+            <a:off x="10088575" y="6473952"/>
             <a:ext cx="82296" cy="82296"/>
           </a:xfrm>
           <a:prstGeom prst="ellipse">
@@ -6308,7 +7123,7 @@
         </p:nvSpPr>
         <p:spPr>
           <a:xfrm>
-            <a:off x="10454335" y="6473952"/>
+            <a:off x="10271455" y="6473952"/>
             <a:ext cx="82296" cy="82296"/>
           </a:xfrm>
           <a:prstGeom prst="ellipse">
@@ -6352,7 +7167,7 @@
         </p:nvSpPr>
         <p:spPr>
           <a:xfrm>
-            <a:off x="10637215" y="6473952"/>
+            <a:off x="10454335" y="6473952"/>
             <a:ext cx="82296" cy="82296"/>
           </a:xfrm>
           <a:prstGeom prst="ellipse">
@@ -6396,7 +7211,7 @@
         </p:nvSpPr>
         <p:spPr>
           <a:xfrm>
-            <a:off x="10820095" y="6473952"/>
+            <a:off x="10637215" y="6473952"/>
             <a:ext cx="82296" cy="82296"/>
           </a:xfrm>
           <a:prstGeom prst="ellipse">
@@ -6440,7 +7255,7 @@
         </p:nvSpPr>
         <p:spPr>
           <a:xfrm>
-            <a:off x="11002975" y="6473952"/>
+            <a:off x="10820095" y="6473952"/>
             <a:ext cx="82296" cy="82296"/>
           </a:xfrm>
           <a:prstGeom prst="ellipse">
@@ -6484,7 +7299,7 @@
         </p:nvSpPr>
         <p:spPr>
           <a:xfrm>
-            <a:off x="11185855" y="6473952"/>
+            <a:off x="11002975" y="6473952"/>
             <a:ext cx="82296" cy="82296"/>
           </a:xfrm>
           <a:prstGeom prst="ellipse">
@@ -6522,7 +7337,51 @@
       </p:sp>
       <p:sp>
         <p:nvSpPr>
-          <p:cNvPr id="20" name="TextBox 19"/>
+          <p:cNvPr id="20" name="Oval 19"/>
+          <p:cNvSpPr/>
+          <p:nvPr/>
+        </p:nvSpPr>
+        <p:spPr>
+          <a:xfrm>
+            <a:off x="11185855" y="6473952"/>
+            <a:ext cx="82296" cy="82296"/>
+          </a:xfrm>
+          <a:prstGeom prst="ellipse">
+            <a:avLst/>
+          </a:prstGeom>
+          <a:solidFill>
+            <a:srgbClr val="DDE1DC"/>
+          </a:solidFill>
+          <a:ln>
+            <a:noFill/>
+          </a:ln>
+          <a:effectLst/>
+        </p:spPr>
+        <p:style>
+          <a:lnRef idx="1">
+            <a:schemeClr val="accent1"/>
+          </a:lnRef>
+          <a:fillRef idx="3">
+            <a:schemeClr val="accent1"/>
+          </a:fillRef>
+          <a:effectRef idx="2">
+            <a:schemeClr val="accent1"/>
+          </a:effectRef>
+          <a:fontRef idx="minor">
+            <a:schemeClr val="lt1"/>
+          </a:fontRef>
+        </p:style>
+        <p:txBody>
+          <a:bodyPr rtlCol="0" anchor="ctr"/>
+          <a:lstStyle/>
+          <a:p>
+            <a:pPr algn="ctr"/>
+          </a:p>
+        </p:txBody>
+      </p:sp>
+      <p:sp>
+        <p:nvSpPr>
+          <p:cNvPr id="21" name="TextBox 20"/>
           <p:cNvSpPr txBox="1"/>
           <p:nvPr/>
         </p:nvSpPr>
@@ -6554,7 +7413,7 @@
                 </a:solidFill>
                 <a:latin typeface="Arial"/>
               </a:rPr>
-              <a:t>1 / 10</a:t>
+              <a:t>1 / 11</a:t>
             </a:r>
           </a:p>
         </p:txBody>
@@ -7151,7 +8010,7 @@
         </p:nvSpPr>
         <p:spPr>
           <a:xfrm>
-            <a:off x="9539935" y="6473952"/>
+            <a:off x="9357055" y="6473952"/>
             <a:ext cx="82296" cy="82296"/>
           </a:xfrm>
           <a:prstGeom prst="ellipse">
@@ -7195,7 +8054,7 @@
         </p:nvSpPr>
         <p:spPr>
           <a:xfrm>
-            <a:off x="9722815" y="6473952"/>
+            <a:off x="9539935" y="6473952"/>
             <a:ext cx="82296" cy="82296"/>
           </a:xfrm>
           <a:prstGeom prst="ellipse">
@@ -7239,7 +8098,7 @@
         </p:nvSpPr>
         <p:spPr>
           <a:xfrm>
-            <a:off x="9905695" y="6473952"/>
+            <a:off x="9722815" y="6473952"/>
             <a:ext cx="82296" cy="82296"/>
           </a:xfrm>
           <a:prstGeom prst="ellipse">
@@ -7283,7 +8142,7 @@
         </p:nvSpPr>
         <p:spPr>
           <a:xfrm>
-            <a:off x="10088575" y="6473952"/>
+            <a:off x="9905695" y="6473952"/>
             <a:ext cx="82296" cy="82296"/>
           </a:xfrm>
           <a:prstGeom prst="ellipse">
@@ -7327,7 +8186,7 @@
         </p:nvSpPr>
         <p:spPr>
           <a:xfrm>
-            <a:off x="10271455" y="6473952"/>
+            <a:off x="10088575" y="6473952"/>
             <a:ext cx="82296" cy="82296"/>
           </a:xfrm>
           <a:prstGeom prst="ellipse">
@@ -7371,7 +8230,7 @@
         </p:nvSpPr>
         <p:spPr>
           <a:xfrm>
-            <a:off x="10454335" y="6473952"/>
+            <a:off x="10271455" y="6473952"/>
             <a:ext cx="82296" cy="82296"/>
           </a:xfrm>
           <a:prstGeom prst="ellipse">
@@ -7415,7 +8274,7 @@
         </p:nvSpPr>
         <p:spPr>
           <a:xfrm>
-            <a:off x="10637215" y="6473952"/>
+            <a:off x="10454335" y="6473952"/>
             <a:ext cx="82296" cy="82296"/>
           </a:xfrm>
           <a:prstGeom prst="ellipse">
@@ -7459,7 +8318,7 @@
         </p:nvSpPr>
         <p:spPr>
           <a:xfrm>
-            <a:off x="10820095" y="6473952"/>
+            <a:off x="10637215" y="6473952"/>
             <a:ext cx="82296" cy="82296"/>
           </a:xfrm>
           <a:prstGeom prst="ellipse">
@@ -7503,7 +8362,7 @@
         </p:nvSpPr>
         <p:spPr>
           <a:xfrm>
-            <a:off x="11002975" y="6473952"/>
+            <a:off x="10820095" y="6473952"/>
             <a:ext cx="82296" cy="82296"/>
           </a:xfrm>
           <a:prstGeom prst="ellipse">
@@ -7547,7 +8406,7 @@
         </p:nvSpPr>
         <p:spPr>
           <a:xfrm>
-            <a:off x="11185855" y="6473952"/>
+            <a:off x="11002975" y="6473952"/>
             <a:ext cx="82296" cy="82296"/>
           </a:xfrm>
           <a:prstGeom prst="ellipse">
@@ -7585,7 +8444,51 @@
       </p:sp>
       <p:sp>
         <p:nvSpPr>
-          <p:cNvPr id="23" name="TextBox 22"/>
+          <p:cNvPr id="23" name="Oval 22"/>
+          <p:cNvSpPr/>
+          <p:nvPr/>
+        </p:nvSpPr>
+        <p:spPr>
+          <a:xfrm>
+            <a:off x="11185855" y="6473952"/>
+            <a:ext cx="82296" cy="82296"/>
+          </a:xfrm>
+          <a:prstGeom prst="ellipse">
+            <a:avLst/>
+          </a:prstGeom>
+          <a:solidFill>
+            <a:srgbClr val="DDE1DC"/>
+          </a:solidFill>
+          <a:ln>
+            <a:noFill/>
+          </a:ln>
+          <a:effectLst/>
+        </p:spPr>
+        <p:style>
+          <a:lnRef idx="1">
+            <a:schemeClr val="accent1"/>
+          </a:lnRef>
+          <a:fillRef idx="3">
+            <a:schemeClr val="accent1"/>
+          </a:fillRef>
+          <a:effectRef idx="2">
+            <a:schemeClr val="accent1"/>
+          </a:effectRef>
+          <a:fontRef idx="minor">
+            <a:schemeClr val="lt1"/>
+          </a:fontRef>
+        </p:style>
+        <p:txBody>
+          <a:bodyPr rtlCol="0" anchor="ctr"/>
+          <a:lstStyle/>
+          <a:p>
+            <a:pPr algn="ctr"/>
+          </a:p>
+        </p:txBody>
+      </p:sp>
+      <p:sp>
+        <p:nvSpPr>
+          <p:cNvPr id="24" name="TextBox 23"/>
           <p:cNvSpPr txBox="1"/>
           <p:nvPr/>
         </p:nvSpPr>
@@ -7617,7 +8520,7 @@
                 </a:solidFill>
                 <a:latin typeface="Arial"/>
               </a:rPr>
-              <a:t>2 / 10</a:t>
+              <a:t>2 / 11</a:t>
             </a:r>
           </a:p>
         </p:txBody>
@@ -8161,7 +9064,7 @@
         </p:nvSpPr>
         <p:spPr>
           <a:xfrm>
-            <a:off x="9539935" y="6473952"/>
+            <a:off x="9357055" y="6473952"/>
             <a:ext cx="82296" cy="82296"/>
           </a:xfrm>
           <a:prstGeom prst="ellipse">
@@ -8205,7 +9108,7 @@
         </p:nvSpPr>
         <p:spPr>
           <a:xfrm>
-            <a:off x="9722815" y="6473952"/>
+            <a:off x="9539935" y="6473952"/>
             <a:ext cx="82296" cy="82296"/>
           </a:xfrm>
           <a:prstGeom prst="ellipse">
@@ -8249,7 +9152,7 @@
         </p:nvSpPr>
         <p:spPr>
           <a:xfrm>
-            <a:off x="9905695" y="6473952"/>
+            <a:off x="9722815" y="6473952"/>
             <a:ext cx="82296" cy="82296"/>
           </a:xfrm>
           <a:prstGeom prst="ellipse">
@@ -8293,7 +9196,7 @@
         </p:nvSpPr>
         <p:spPr>
           <a:xfrm>
-            <a:off x="10088575" y="6473952"/>
+            <a:off x="9905695" y="6473952"/>
             <a:ext cx="82296" cy="82296"/>
           </a:xfrm>
           <a:prstGeom prst="ellipse">
@@ -8337,7 +9240,7 @@
         </p:nvSpPr>
         <p:spPr>
           <a:xfrm>
-            <a:off x="10271455" y="6473952"/>
+            <a:off x="10088575" y="6473952"/>
             <a:ext cx="82296" cy="82296"/>
           </a:xfrm>
           <a:prstGeom prst="ellipse">
@@ -8381,7 +9284,7 @@
         </p:nvSpPr>
         <p:spPr>
           <a:xfrm>
-            <a:off x="10454335" y="6473952"/>
+            <a:off x="10271455" y="6473952"/>
             <a:ext cx="82296" cy="82296"/>
           </a:xfrm>
           <a:prstGeom prst="ellipse">
@@ -8425,7 +9328,7 @@
         </p:nvSpPr>
         <p:spPr>
           <a:xfrm>
-            <a:off x="10637215" y="6473952"/>
+            <a:off x="10454335" y="6473952"/>
             <a:ext cx="82296" cy="82296"/>
           </a:xfrm>
           <a:prstGeom prst="ellipse">
@@ -8469,7 +9372,7 @@
         </p:nvSpPr>
         <p:spPr>
           <a:xfrm>
-            <a:off x="10820095" y="6473952"/>
+            <a:off x="10637215" y="6473952"/>
             <a:ext cx="82296" cy="82296"/>
           </a:xfrm>
           <a:prstGeom prst="ellipse">
@@ -8513,7 +9416,7 @@
         </p:nvSpPr>
         <p:spPr>
           <a:xfrm>
-            <a:off x="11002975" y="6473952"/>
+            <a:off x="10820095" y="6473952"/>
             <a:ext cx="82296" cy="82296"/>
           </a:xfrm>
           <a:prstGeom prst="ellipse">
@@ -8557,7 +9460,7 @@
         </p:nvSpPr>
         <p:spPr>
           <a:xfrm>
-            <a:off x="11185855" y="6473952"/>
+            <a:off x="11002975" y="6473952"/>
             <a:ext cx="82296" cy="82296"/>
           </a:xfrm>
           <a:prstGeom prst="ellipse">
@@ -8595,7 +9498,51 @@
       </p:sp>
       <p:sp>
         <p:nvSpPr>
-          <p:cNvPr id="22" name="TextBox 21"/>
+          <p:cNvPr id="22" name="Oval 21"/>
+          <p:cNvSpPr/>
+          <p:nvPr/>
+        </p:nvSpPr>
+        <p:spPr>
+          <a:xfrm>
+            <a:off x="11185855" y="6473952"/>
+            <a:ext cx="82296" cy="82296"/>
+          </a:xfrm>
+          <a:prstGeom prst="ellipse">
+            <a:avLst/>
+          </a:prstGeom>
+          <a:solidFill>
+            <a:srgbClr val="DDE1DC"/>
+          </a:solidFill>
+          <a:ln>
+            <a:noFill/>
+          </a:ln>
+          <a:effectLst/>
+        </p:spPr>
+        <p:style>
+          <a:lnRef idx="1">
+            <a:schemeClr val="accent1"/>
+          </a:lnRef>
+          <a:fillRef idx="3">
+            <a:schemeClr val="accent1"/>
+          </a:fillRef>
+          <a:effectRef idx="2">
+            <a:schemeClr val="accent1"/>
+          </a:effectRef>
+          <a:fontRef idx="minor">
+            <a:schemeClr val="lt1"/>
+          </a:fontRef>
+        </p:style>
+        <p:txBody>
+          <a:bodyPr rtlCol="0" anchor="ctr"/>
+          <a:lstStyle/>
+          <a:p>
+            <a:pPr algn="ctr"/>
+          </a:p>
+        </p:txBody>
+      </p:sp>
+      <p:sp>
+        <p:nvSpPr>
+          <p:cNvPr id="23" name="TextBox 22"/>
           <p:cNvSpPr txBox="1"/>
           <p:nvPr/>
         </p:nvSpPr>
@@ -8627,7 +9574,7 @@
                 </a:solidFill>
                 <a:latin typeface="Arial"/>
               </a:rPr>
-              <a:t>3 / 10</a:t>
+              <a:t>3 / 11</a:t>
             </a:r>
           </a:p>
         </p:txBody>
@@ -9341,7 +10288,7 @@
         </p:nvSpPr>
         <p:spPr>
           <a:xfrm>
-            <a:off x="9539935" y="6473952"/>
+            <a:off x="9357055" y="6473952"/>
             <a:ext cx="82296" cy="82296"/>
           </a:xfrm>
           <a:prstGeom prst="ellipse">
@@ -9385,7 +10332,7 @@
         </p:nvSpPr>
         <p:spPr>
           <a:xfrm>
-            <a:off x="9722815" y="6473952"/>
+            <a:off x="9539935" y="6473952"/>
             <a:ext cx="82296" cy="82296"/>
           </a:xfrm>
           <a:prstGeom prst="ellipse">
@@ -9429,7 +10376,7 @@
         </p:nvSpPr>
         <p:spPr>
           <a:xfrm>
-            <a:off x="9905695" y="6473952"/>
+            <a:off x="9722815" y="6473952"/>
             <a:ext cx="82296" cy="82296"/>
           </a:xfrm>
           <a:prstGeom prst="ellipse">
@@ -9473,7 +10420,7 @@
         </p:nvSpPr>
         <p:spPr>
           <a:xfrm>
-            <a:off x="10088575" y="6473952"/>
+            <a:off x="9905695" y="6473952"/>
             <a:ext cx="82296" cy="82296"/>
           </a:xfrm>
           <a:prstGeom prst="ellipse">
@@ -9517,7 +10464,7 @@
         </p:nvSpPr>
         <p:spPr>
           <a:xfrm>
-            <a:off x="10271455" y="6473952"/>
+            <a:off x="10088575" y="6473952"/>
             <a:ext cx="82296" cy="82296"/>
           </a:xfrm>
           <a:prstGeom prst="ellipse">
@@ -9561,7 +10508,7 @@
         </p:nvSpPr>
         <p:spPr>
           <a:xfrm>
-            <a:off x="10454335" y="6473952"/>
+            <a:off x="10271455" y="6473952"/>
             <a:ext cx="82296" cy="82296"/>
           </a:xfrm>
           <a:prstGeom prst="ellipse">
@@ -9605,7 +10552,7 @@
         </p:nvSpPr>
         <p:spPr>
           <a:xfrm>
-            <a:off x="10637215" y="6473952"/>
+            <a:off x="10454335" y="6473952"/>
             <a:ext cx="82296" cy="82296"/>
           </a:xfrm>
           <a:prstGeom prst="ellipse">
@@ -9649,7 +10596,7 @@
         </p:nvSpPr>
         <p:spPr>
           <a:xfrm>
-            <a:off x="10820095" y="6473952"/>
+            <a:off x="10637215" y="6473952"/>
             <a:ext cx="82296" cy="82296"/>
           </a:xfrm>
           <a:prstGeom prst="ellipse">
@@ -9693,7 +10640,7 @@
         </p:nvSpPr>
         <p:spPr>
           <a:xfrm>
-            <a:off x="11002975" y="6473952"/>
+            <a:off x="10820095" y="6473952"/>
             <a:ext cx="82296" cy="82296"/>
           </a:xfrm>
           <a:prstGeom prst="ellipse">
@@ -9737,7 +10684,7 @@
         </p:nvSpPr>
         <p:spPr>
           <a:xfrm>
-            <a:off x="11185855" y="6473952"/>
+            <a:off x="11002975" y="6473952"/>
             <a:ext cx="82296" cy="82296"/>
           </a:xfrm>
           <a:prstGeom prst="ellipse">
@@ -9775,7 +10722,51 @@
       </p:sp>
       <p:sp>
         <p:nvSpPr>
-          <p:cNvPr id="18" name="TextBox 17"/>
+          <p:cNvPr id="18" name="Oval 17"/>
+          <p:cNvSpPr/>
+          <p:nvPr/>
+        </p:nvSpPr>
+        <p:spPr>
+          <a:xfrm>
+            <a:off x="11185855" y="6473952"/>
+            <a:ext cx="82296" cy="82296"/>
+          </a:xfrm>
+          <a:prstGeom prst="ellipse">
+            <a:avLst/>
+          </a:prstGeom>
+          <a:solidFill>
+            <a:srgbClr val="DDE1DC"/>
+          </a:solidFill>
+          <a:ln>
+            <a:noFill/>
+          </a:ln>
+          <a:effectLst/>
+        </p:spPr>
+        <p:style>
+          <a:lnRef idx="1">
+            <a:schemeClr val="accent1"/>
+          </a:lnRef>
+          <a:fillRef idx="3">
+            <a:schemeClr val="accent1"/>
+          </a:fillRef>
+          <a:effectRef idx="2">
+            <a:schemeClr val="accent1"/>
+          </a:effectRef>
+          <a:fontRef idx="minor">
+            <a:schemeClr val="lt1"/>
+          </a:fontRef>
+        </p:style>
+        <p:txBody>
+          <a:bodyPr rtlCol="0" anchor="ctr"/>
+          <a:lstStyle/>
+          <a:p>
+            <a:pPr algn="ctr"/>
+          </a:p>
+        </p:txBody>
+      </p:sp>
+      <p:sp>
+        <p:nvSpPr>
+          <p:cNvPr id="19" name="TextBox 18"/>
           <p:cNvSpPr txBox="1"/>
           <p:nvPr/>
         </p:nvSpPr>
@@ -9807,7 +10798,7 @@
                 </a:solidFill>
                 <a:latin typeface="Arial"/>
               </a:rPr>
-              <a:t>4 / 10</a:t>
+              <a:t>4 / 11</a:t>
             </a:r>
           </a:p>
         </p:txBody>
@@ -10521,7 +11512,7 @@
         </p:nvSpPr>
         <p:spPr>
           <a:xfrm>
-            <a:off x="9539935" y="6473952"/>
+            <a:off x="9357055" y="6473952"/>
             <a:ext cx="82296" cy="82296"/>
           </a:xfrm>
           <a:prstGeom prst="ellipse">
@@ -10565,7 +11556,7 @@
         </p:nvSpPr>
         <p:spPr>
           <a:xfrm>
-            <a:off x="9722815" y="6473952"/>
+            <a:off x="9539935" y="6473952"/>
             <a:ext cx="82296" cy="82296"/>
           </a:xfrm>
           <a:prstGeom prst="ellipse">
@@ -10609,7 +11600,7 @@
         </p:nvSpPr>
         <p:spPr>
           <a:xfrm>
-            <a:off x="9905695" y="6473952"/>
+            <a:off x="9722815" y="6473952"/>
             <a:ext cx="82296" cy="82296"/>
           </a:xfrm>
           <a:prstGeom prst="ellipse">
@@ -10653,7 +11644,7 @@
         </p:nvSpPr>
         <p:spPr>
           <a:xfrm>
-            <a:off x="10088575" y="6473952"/>
+            <a:off x="9905695" y="6473952"/>
             <a:ext cx="82296" cy="82296"/>
           </a:xfrm>
           <a:prstGeom prst="ellipse">
@@ -10697,7 +11688,7 @@
         </p:nvSpPr>
         <p:spPr>
           <a:xfrm>
-            <a:off x="10271455" y="6473952"/>
+            <a:off x="10088575" y="6473952"/>
             <a:ext cx="82296" cy="82296"/>
           </a:xfrm>
           <a:prstGeom prst="ellipse">
@@ -10741,7 +11732,7 @@
         </p:nvSpPr>
         <p:spPr>
           <a:xfrm>
-            <a:off x="10454335" y="6473952"/>
+            <a:off x="10271455" y="6473952"/>
             <a:ext cx="82296" cy="82296"/>
           </a:xfrm>
           <a:prstGeom prst="ellipse">
@@ -10785,7 +11776,7 @@
         </p:nvSpPr>
         <p:spPr>
           <a:xfrm>
-            <a:off x="10637215" y="6473952"/>
+            <a:off x="10454335" y="6473952"/>
             <a:ext cx="82296" cy="82296"/>
           </a:xfrm>
           <a:prstGeom prst="ellipse">
@@ -10829,7 +11820,7 @@
         </p:nvSpPr>
         <p:spPr>
           <a:xfrm>
-            <a:off x="10820095" y="6473952"/>
+            <a:off x="10637215" y="6473952"/>
             <a:ext cx="82296" cy="82296"/>
           </a:xfrm>
           <a:prstGeom prst="ellipse">
@@ -10873,7 +11864,7 @@
         </p:nvSpPr>
         <p:spPr>
           <a:xfrm>
-            <a:off x="11002975" y="6473952"/>
+            <a:off x="10820095" y="6473952"/>
             <a:ext cx="82296" cy="82296"/>
           </a:xfrm>
           <a:prstGeom prst="ellipse">
@@ -10917,7 +11908,7 @@
         </p:nvSpPr>
         <p:spPr>
           <a:xfrm>
-            <a:off x="11185855" y="6473952"/>
+            <a:off x="11002975" y="6473952"/>
             <a:ext cx="82296" cy="82296"/>
           </a:xfrm>
           <a:prstGeom prst="ellipse">
@@ -10955,7 +11946,51 @@
       </p:sp>
       <p:sp>
         <p:nvSpPr>
-          <p:cNvPr id="18" name="TextBox 17"/>
+          <p:cNvPr id="18" name="Oval 17"/>
+          <p:cNvSpPr/>
+          <p:nvPr/>
+        </p:nvSpPr>
+        <p:spPr>
+          <a:xfrm>
+            <a:off x="11185855" y="6473952"/>
+            <a:ext cx="82296" cy="82296"/>
+          </a:xfrm>
+          <a:prstGeom prst="ellipse">
+            <a:avLst/>
+          </a:prstGeom>
+          <a:solidFill>
+            <a:srgbClr val="DDE1DC"/>
+          </a:solidFill>
+          <a:ln>
+            <a:noFill/>
+          </a:ln>
+          <a:effectLst/>
+        </p:spPr>
+        <p:style>
+          <a:lnRef idx="1">
+            <a:schemeClr val="accent1"/>
+          </a:lnRef>
+          <a:fillRef idx="3">
+            <a:schemeClr val="accent1"/>
+          </a:fillRef>
+          <a:effectRef idx="2">
+            <a:schemeClr val="accent1"/>
+          </a:effectRef>
+          <a:fontRef idx="minor">
+            <a:schemeClr val="lt1"/>
+          </a:fontRef>
+        </p:style>
+        <p:txBody>
+          <a:bodyPr rtlCol="0" anchor="ctr"/>
+          <a:lstStyle/>
+          <a:p>
+            <a:pPr algn="ctr"/>
+          </a:p>
+        </p:txBody>
+      </p:sp>
+      <p:sp>
+        <p:nvSpPr>
+          <p:cNvPr id="19" name="TextBox 18"/>
           <p:cNvSpPr txBox="1"/>
           <p:nvPr/>
         </p:nvSpPr>
@@ -10987,7 +12022,7 @@
                 </a:solidFill>
                 <a:latin typeface="Arial"/>
               </a:rPr>
-              <a:t>5 / 10</a:t>
+              <a:t>5 / 11</a:t>
             </a:r>
           </a:p>
         </p:txBody>
@@ -11663,7 +12698,7 @@
         </p:nvSpPr>
         <p:spPr>
           <a:xfrm>
-            <a:off x="9539935" y="6473952"/>
+            <a:off x="9357055" y="6473952"/>
             <a:ext cx="82296" cy="82296"/>
           </a:xfrm>
           <a:prstGeom prst="ellipse">
@@ -11707,7 +12742,7 @@
         </p:nvSpPr>
         <p:spPr>
           <a:xfrm>
-            <a:off x="9722815" y="6473952"/>
+            <a:off x="9539935" y="6473952"/>
             <a:ext cx="82296" cy="82296"/>
           </a:xfrm>
           <a:prstGeom prst="ellipse">
@@ -11751,7 +12786,7 @@
         </p:nvSpPr>
         <p:spPr>
           <a:xfrm>
-            <a:off x="9905695" y="6473952"/>
+            <a:off x="9722815" y="6473952"/>
             <a:ext cx="82296" cy="82296"/>
           </a:xfrm>
           <a:prstGeom prst="ellipse">
@@ -11795,7 +12830,7 @@
         </p:nvSpPr>
         <p:spPr>
           <a:xfrm>
-            <a:off x="10088575" y="6473952"/>
+            <a:off x="9905695" y="6473952"/>
             <a:ext cx="82296" cy="82296"/>
           </a:xfrm>
           <a:prstGeom prst="ellipse">
@@ -11839,7 +12874,7 @@
         </p:nvSpPr>
         <p:spPr>
           <a:xfrm>
-            <a:off x="10271455" y="6473952"/>
+            <a:off x="10088575" y="6473952"/>
             <a:ext cx="82296" cy="82296"/>
           </a:xfrm>
           <a:prstGeom prst="ellipse">
@@ -11883,7 +12918,7 @@
         </p:nvSpPr>
         <p:spPr>
           <a:xfrm>
-            <a:off x="10454335" y="6473952"/>
+            <a:off x="10271455" y="6473952"/>
             <a:ext cx="82296" cy="82296"/>
           </a:xfrm>
           <a:prstGeom prst="ellipse">
@@ -11927,7 +12962,7 @@
         </p:nvSpPr>
         <p:spPr>
           <a:xfrm>
-            <a:off x="10637215" y="6473952"/>
+            <a:off x="10454335" y="6473952"/>
             <a:ext cx="82296" cy="82296"/>
           </a:xfrm>
           <a:prstGeom prst="ellipse">
@@ -11971,7 +13006,7 @@
         </p:nvSpPr>
         <p:spPr>
           <a:xfrm>
-            <a:off x="10820095" y="6473952"/>
+            <a:off x="10637215" y="6473952"/>
             <a:ext cx="82296" cy="82296"/>
           </a:xfrm>
           <a:prstGeom prst="ellipse">
@@ -12015,7 +13050,7 @@
         </p:nvSpPr>
         <p:spPr>
           <a:xfrm>
-            <a:off x="11002975" y="6473952"/>
+            <a:off x="10820095" y="6473952"/>
             <a:ext cx="82296" cy="82296"/>
           </a:xfrm>
           <a:prstGeom prst="ellipse">
@@ -12059,7 +13094,7 @@
         </p:nvSpPr>
         <p:spPr>
           <a:xfrm>
-            <a:off x="11185855" y="6473952"/>
+            <a:off x="11002975" y="6473952"/>
             <a:ext cx="82296" cy="82296"/>
           </a:xfrm>
           <a:prstGeom prst="ellipse">
@@ -12097,7 +13132,51 @@
       </p:sp>
       <p:sp>
         <p:nvSpPr>
-          <p:cNvPr id="20" name="TextBox 19"/>
+          <p:cNvPr id="20" name="Oval 19"/>
+          <p:cNvSpPr/>
+          <p:nvPr/>
+        </p:nvSpPr>
+        <p:spPr>
+          <a:xfrm>
+            <a:off x="11185855" y="6473952"/>
+            <a:ext cx="82296" cy="82296"/>
+          </a:xfrm>
+          <a:prstGeom prst="ellipse">
+            <a:avLst/>
+          </a:prstGeom>
+          <a:solidFill>
+            <a:srgbClr val="DDE1DC"/>
+          </a:solidFill>
+          <a:ln>
+            <a:noFill/>
+          </a:ln>
+          <a:effectLst/>
+        </p:spPr>
+        <p:style>
+          <a:lnRef idx="1">
+            <a:schemeClr val="accent1"/>
+          </a:lnRef>
+          <a:fillRef idx="3">
+            <a:schemeClr val="accent1"/>
+          </a:fillRef>
+          <a:effectRef idx="2">
+            <a:schemeClr val="accent1"/>
+          </a:effectRef>
+          <a:fontRef idx="minor">
+            <a:schemeClr val="lt1"/>
+          </a:fontRef>
+        </p:style>
+        <p:txBody>
+          <a:bodyPr rtlCol="0" anchor="ctr"/>
+          <a:lstStyle/>
+          <a:p>
+            <a:pPr algn="ctr"/>
+          </a:p>
+        </p:txBody>
+      </p:sp>
+      <p:sp>
+        <p:nvSpPr>
+          <p:cNvPr id="21" name="TextBox 20"/>
           <p:cNvSpPr txBox="1"/>
           <p:nvPr/>
         </p:nvSpPr>
@@ -12129,7 +13208,7 @@
                 </a:solidFill>
                 <a:latin typeface="Arial"/>
               </a:rPr>
-              <a:t>6 / 10</a:t>
+              <a:t>6 / 11</a:t>
             </a:r>
           </a:p>
         </p:txBody>
@@ -14836,7 +15915,7 @@
         </p:nvSpPr>
         <p:spPr>
           <a:xfrm>
-            <a:off x="9539935" y="6473952"/>
+            <a:off x="9357055" y="6473952"/>
             <a:ext cx="82296" cy="82296"/>
           </a:xfrm>
           <a:prstGeom prst="ellipse">
@@ -14880,7 +15959,7 @@
         </p:nvSpPr>
         <p:spPr>
           <a:xfrm>
-            <a:off x="9722815" y="6473952"/>
+            <a:off x="9539935" y="6473952"/>
             <a:ext cx="82296" cy="82296"/>
           </a:xfrm>
           <a:prstGeom prst="ellipse">
@@ -14924,7 +16003,7 @@
         </p:nvSpPr>
         <p:spPr>
           <a:xfrm>
-            <a:off x="9905695" y="6473952"/>
+            <a:off x="9722815" y="6473952"/>
             <a:ext cx="82296" cy="82296"/>
           </a:xfrm>
           <a:prstGeom prst="ellipse">
@@ -14968,7 +16047,7 @@
         </p:nvSpPr>
         <p:spPr>
           <a:xfrm>
-            <a:off x="10088575" y="6473952"/>
+            <a:off x="9905695" y="6473952"/>
             <a:ext cx="82296" cy="82296"/>
           </a:xfrm>
           <a:prstGeom prst="ellipse">
@@ -15012,7 +16091,7 @@
         </p:nvSpPr>
         <p:spPr>
           <a:xfrm>
-            <a:off x="10271455" y="6473952"/>
+            <a:off x="10088575" y="6473952"/>
             <a:ext cx="82296" cy="82296"/>
           </a:xfrm>
           <a:prstGeom prst="ellipse">
@@ -15056,7 +16135,7 @@
         </p:nvSpPr>
         <p:spPr>
           <a:xfrm>
-            <a:off x="10454335" y="6473952"/>
+            <a:off x="10271455" y="6473952"/>
             <a:ext cx="82296" cy="82296"/>
           </a:xfrm>
           <a:prstGeom prst="ellipse">
@@ -15100,7 +16179,7 @@
         </p:nvSpPr>
         <p:spPr>
           <a:xfrm>
-            <a:off x="10637215" y="6473952"/>
+            <a:off x="10454335" y="6473952"/>
             <a:ext cx="82296" cy="82296"/>
           </a:xfrm>
           <a:prstGeom prst="ellipse">
@@ -15144,7 +16223,7 @@
         </p:nvSpPr>
         <p:spPr>
           <a:xfrm>
-            <a:off x="10820095" y="6473952"/>
+            <a:off x="10637215" y="6473952"/>
             <a:ext cx="82296" cy="82296"/>
           </a:xfrm>
           <a:prstGeom prst="ellipse">
@@ -15188,7 +16267,7 @@
         </p:nvSpPr>
         <p:spPr>
           <a:xfrm>
-            <a:off x="11002975" y="6473952"/>
+            <a:off x="10820095" y="6473952"/>
             <a:ext cx="82296" cy="82296"/>
           </a:xfrm>
           <a:prstGeom prst="ellipse">
@@ -15232,7 +16311,7 @@
         </p:nvSpPr>
         <p:spPr>
           <a:xfrm>
-            <a:off x="11185855" y="6473952"/>
+            <a:off x="11002975" y="6473952"/>
             <a:ext cx="82296" cy="82296"/>
           </a:xfrm>
           <a:prstGeom prst="ellipse">
@@ -15270,7 +16349,51 @@
       </p:sp>
       <p:sp>
         <p:nvSpPr>
-          <p:cNvPr id="18" name="TextBox 17"/>
+          <p:cNvPr id="18" name="Oval 17"/>
+          <p:cNvSpPr/>
+          <p:nvPr/>
+        </p:nvSpPr>
+        <p:spPr>
+          <a:xfrm>
+            <a:off x="11185855" y="6473952"/>
+            <a:ext cx="82296" cy="82296"/>
+          </a:xfrm>
+          <a:prstGeom prst="ellipse">
+            <a:avLst/>
+          </a:prstGeom>
+          <a:solidFill>
+            <a:srgbClr val="DDE1DC"/>
+          </a:solidFill>
+          <a:ln>
+            <a:noFill/>
+          </a:ln>
+          <a:effectLst/>
+        </p:spPr>
+        <p:style>
+          <a:lnRef idx="1">
+            <a:schemeClr val="accent1"/>
+          </a:lnRef>
+          <a:fillRef idx="3">
+            <a:schemeClr val="accent1"/>
+          </a:fillRef>
+          <a:effectRef idx="2">
+            <a:schemeClr val="accent1"/>
+          </a:effectRef>
+          <a:fontRef idx="minor">
+            <a:schemeClr val="lt1"/>
+          </a:fontRef>
+        </p:style>
+        <p:txBody>
+          <a:bodyPr rtlCol="0" anchor="ctr"/>
+          <a:lstStyle/>
+          <a:p>
+            <a:pPr algn="ctr"/>
+          </a:p>
+        </p:txBody>
+      </p:sp>
+      <p:sp>
+        <p:nvSpPr>
+          <p:cNvPr id="19" name="TextBox 18"/>
           <p:cNvSpPr txBox="1"/>
           <p:nvPr/>
         </p:nvSpPr>
@@ -15302,7 +16425,7 @@
                 </a:solidFill>
                 <a:latin typeface="Arial"/>
               </a:rPr>
-              <a:t>7 / 10</a:t>
+              <a:t>7 / 11</a:t>
             </a:r>
           </a:p>
         </p:txBody>
@@ -15649,7 +16772,7 @@
         </p:nvSpPr>
         <p:spPr>
           <a:xfrm>
-            <a:off x="9539935" y="6473952"/>
+            <a:off x="9357055" y="6473952"/>
             <a:ext cx="82296" cy="82296"/>
           </a:xfrm>
           <a:prstGeom prst="ellipse">
@@ -15693,7 +16816,7 @@
         </p:nvSpPr>
         <p:spPr>
           <a:xfrm>
-            <a:off x="9722815" y="6473952"/>
+            <a:off x="9539935" y="6473952"/>
             <a:ext cx="82296" cy="82296"/>
           </a:xfrm>
           <a:prstGeom prst="ellipse">
@@ -15737,7 +16860,7 @@
         </p:nvSpPr>
         <p:spPr>
           <a:xfrm>
-            <a:off x="9905695" y="6473952"/>
+            <a:off x="9722815" y="6473952"/>
             <a:ext cx="82296" cy="82296"/>
           </a:xfrm>
           <a:prstGeom prst="ellipse">
@@ -15781,7 +16904,7 @@
         </p:nvSpPr>
         <p:spPr>
           <a:xfrm>
-            <a:off x="10088575" y="6473952"/>
+            <a:off x="9905695" y="6473952"/>
             <a:ext cx="82296" cy="82296"/>
           </a:xfrm>
           <a:prstGeom prst="ellipse">
@@ -15825,7 +16948,7 @@
         </p:nvSpPr>
         <p:spPr>
           <a:xfrm>
-            <a:off x="10271455" y="6473952"/>
+            <a:off x="10088575" y="6473952"/>
             <a:ext cx="82296" cy="82296"/>
           </a:xfrm>
           <a:prstGeom prst="ellipse">
@@ -15869,7 +16992,7 @@
         </p:nvSpPr>
         <p:spPr>
           <a:xfrm>
-            <a:off x="10454335" y="6473952"/>
+            <a:off x="10271455" y="6473952"/>
             <a:ext cx="82296" cy="82296"/>
           </a:xfrm>
           <a:prstGeom prst="ellipse">
@@ -15913,7 +17036,7 @@
         </p:nvSpPr>
         <p:spPr>
           <a:xfrm>
-            <a:off x="10637215" y="6473952"/>
+            <a:off x="10454335" y="6473952"/>
             <a:ext cx="82296" cy="82296"/>
           </a:xfrm>
           <a:prstGeom prst="ellipse">
@@ -15957,7 +17080,7 @@
         </p:nvSpPr>
         <p:spPr>
           <a:xfrm>
-            <a:off x="10820095" y="6473952"/>
+            <a:off x="10637215" y="6473952"/>
             <a:ext cx="82296" cy="82296"/>
           </a:xfrm>
           <a:prstGeom prst="ellipse">
@@ -16001,7 +17124,7 @@
         </p:nvSpPr>
         <p:spPr>
           <a:xfrm>
-            <a:off x="11002975" y="6473952"/>
+            <a:off x="10820095" y="6473952"/>
             <a:ext cx="82296" cy="82296"/>
           </a:xfrm>
           <a:prstGeom prst="ellipse">
@@ -16045,7 +17168,7 @@
         </p:nvSpPr>
         <p:spPr>
           <a:xfrm>
-            <a:off x="11185855" y="6473952"/>
+            <a:off x="11002975" y="6473952"/>
             <a:ext cx="82296" cy="82296"/>
           </a:xfrm>
           <a:prstGeom prst="ellipse">
@@ -16083,7 +17206,51 @@
       </p:sp>
       <p:sp>
         <p:nvSpPr>
-          <p:cNvPr id="20" name="TextBox 19"/>
+          <p:cNvPr id="20" name="Oval 19"/>
+          <p:cNvSpPr/>
+          <p:nvPr/>
+        </p:nvSpPr>
+        <p:spPr>
+          <a:xfrm>
+            <a:off x="11185855" y="6473952"/>
+            <a:ext cx="82296" cy="82296"/>
+          </a:xfrm>
+          <a:prstGeom prst="ellipse">
+            <a:avLst/>
+          </a:prstGeom>
+          <a:solidFill>
+            <a:srgbClr val="DDE1DC"/>
+          </a:solidFill>
+          <a:ln>
+            <a:noFill/>
+          </a:ln>
+          <a:effectLst/>
+        </p:spPr>
+        <p:style>
+          <a:lnRef idx="1">
+            <a:schemeClr val="accent1"/>
+          </a:lnRef>
+          <a:fillRef idx="3">
+            <a:schemeClr val="accent1"/>
+          </a:fillRef>
+          <a:effectRef idx="2">
+            <a:schemeClr val="accent1"/>
+          </a:effectRef>
+          <a:fontRef idx="minor">
+            <a:schemeClr val="lt1"/>
+          </a:fontRef>
+        </p:style>
+        <p:txBody>
+          <a:bodyPr rtlCol="0" anchor="ctr"/>
+          <a:lstStyle/>
+          <a:p>
+            <a:pPr algn="ctr"/>
+          </a:p>
+        </p:txBody>
+      </p:sp>
+      <p:sp>
+        <p:nvSpPr>
+          <p:cNvPr id="21" name="TextBox 20"/>
           <p:cNvSpPr txBox="1"/>
           <p:nvPr/>
         </p:nvSpPr>
@@ -16115,7 +17282,7 @@
                 </a:solidFill>
                 <a:latin typeface="Arial"/>
               </a:rPr>
-              <a:t>8 / 10</a:t>
+              <a:t>8 / 11</a:t>
             </a:r>
           </a:p>
         </p:txBody>

</xml_diff>